<commit_message>
Remove benchmark slide and benchmark references from the Second Review deck
The benchmark has not produced results, so the results table is dropped along with the benchmark rows, boxes and notes. Literature survey citations stay.
</commit_message>
<xml_diff>
--- a/P1_R2_13.pptx
+++ b/P1_R2_13.pptx
@@ -20,7 +20,6 @@
     <p:sldId id="267" r:id="rId13"/>
     <p:sldId id="268" r:id="rId14"/>
     <p:sldId id="269" r:id="rId15"/>
-    <p:sldId id="273" r:id="rId24"/>
     <p:sldId id="270" r:id="rId16"/>
     <p:sldId id="271" r:id="rId17"/>
   </p:sldIdLst>
@@ -1070,7 +1069,7 @@
             <a:pPr/>
             <a:r>
               <a:rPr lang="en-US" dirty="0"/>
-              <a:t>Every row is one measurement on one machine, mostly on our own user:dev namespace, so none of this is a benchmark result. The two numbers that miss their target are the median context size and the latency when the date planner runs.</a:t>
+              <a:t>Every row is one measurement on one machine, mostly on our own user:dev namespace, so treat each as a single measurement. The two numbers that miss their target are the median context size and the latency when the date planner runs.</a:t>
             </a:r>
           </a:p>
           <a:p>
@@ -1092,7 +1091,7 @@
             </a:pPr>
             <a:r>
               <a:rPr lang="en-US" dirty="0"/>
-              <a:t>The local model row replays 10 of the 18 document batches that the hosted model had already processed, and the 14B model passed 2 of them. LongMemEval-S has not been run, because it needs a 277 MB dataset and a lot of model use, so we cannot say yet that memory improves answers.</a:t>
+              <a:t>The local model row replays 10 of the 18 document batches that the hosted model had already processed, and the 14B model passed 2 of them.</a:t>
             </a:r>
           </a:p>
         </p:txBody>
@@ -1191,7 +1190,7 @@
             </a:pPr>
             <a:r>
               <a:rPr lang="en-US" dirty="0"/>
-              <a:t>M4 covers jobs, consolidation, traces, metrics and the LongMemEval runner, and decay, re-embedding and backup are Planned. The local 14B extractor is In progress because it passed validation on only 2 of 10 test batches.</a:t>
+              <a:t>M4 covers jobs, consolidation, traces and metrics, and decay, re-embedding and backup are Planned. The local 14B extractor is In progress because it passed validation on only 2 of 10 test batches.</a:t>
             </a:r>
           </a:p>
           <a:p>
@@ -1202,7 +1201,7 @@
             </a:pPr>
             <a:r>
               <a:rPr lang="en-US" dirty="0"/>
-              <a:t>The fine-tuned worker is In progress because its internal scores are mixed: consolidation and reflection improved, extraction coverage fell, and we have not yet run the full benchmark with it.</a:t>
+              <a:t>The fine-tuned worker is In progress because its internal scores are mixed: consolidation and reflection improved, extraction coverage fell.</a:t>
             </a:r>
           </a:p>
         </p:txBody>
@@ -1421,76 +1420,6 @@
           <a:p>
             <a:r>
               <a:t>Retaining a conversation and interpreting it are separate jobs. Retain stores the episode and queues an extract job in one transaction. A worker claims that job under a lease, sends windows of about 2,800 tokens to mem-extractor on Ollama, and checks every reply against the engine's rules, with at most two repairs. Valid claims are stored as facts: a new value in a single-value slot supersedes the old one, and the old one stays as history. Storing an episode queues a consolidate job, where the same model combines two or more facts into observations, and a project job that copies entities and edges to Neo4j. A job lease renewed every 30 seconds lets one attempt own a job, and a namespace lease keeps one episode per namespace at a time, so four namespaces run in parallel by default. A late attempt that lost its lease cannot commit. There is no fallback model: if the model is unreachable or never gives a valid reply, the job fails and is retried.</a:t>
-            </a:r>
-          </a:p>
-        </p:txBody>
-      </p:sp>
-      <p:sp>
-        <p:nvSpPr>
-          <p:cNvPr id="4" name="Slide Number Placeholder 3"/>
-          <p:cNvSpPr>
-            <a:spLocks noGrp="1"/>
-          </p:cNvSpPr>
-          <p:nvPr>
-            <p:ph type="sldNum" idx="5" sz="quarter"/>
-          </p:nvPr>
-        </p:nvSpPr>
-        <p:spPr/>
-      </p:sp>
-    </p:spTree>
-  </p:cSld>
-  <p:clrMapOvr>
-    <a:masterClrMapping/>
-  </p:clrMapOvr>
-</p:notes>
-</file>
-
-<file path=ppt/notesSlides/notesSlide18.xml><?xml version="1.0" encoding="utf-8"?>
-<p:notes xmlns:a="http://schemas.openxmlformats.org/drawingml/2006/main" xmlns:p="http://schemas.openxmlformats.org/presentationml/2006/main" xmlns:r="http://schemas.openxmlformats.org/officeDocument/2006/relationships">
-  <p:cSld>
-    <p:spTree>
-      <p:nvGrpSpPr>
-        <p:cNvPr id="1" name=""/>
-        <p:cNvGrpSpPr/>
-        <p:nvPr/>
-      </p:nvGrpSpPr>
-      <p:grpSpPr>
-        <a:xfrm>
-          <a:off x="0" y="0"/>
-          <a:ext cx="0" cy="0"/>
-          <a:chOff x="0" y="0"/>
-          <a:chExt cx="0" cy="0"/>
-        </a:xfrm>
-      </p:grpSpPr>
-      <p:sp>
-        <p:nvSpPr>
-          <p:cNvPr id="2" name="Slide Image Placeholder 1"/>
-          <p:cNvSpPr>
-            <a:spLocks noGrp="1"/>
-          </p:cNvSpPr>
-          <p:nvPr>
-            <p:ph type="sldImg" idx="2"/>
-          </p:nvPr>
-        </p:nvSpPr>
-        <p:spPr/>
-      </p:sp>
-      <p:sp>
-        <p:nvSpPr>
-          <p:cNvPr id="3" name="Notes Placeholder 2"/>
-          <p:cNvSpPr>
-            <a:spLocks noGrp="1"/>
-          </p:cNvSpPr>
-          <p:nvPr>
-            <p:ph type="body" idx="3" sz="quarter"/>
-          </p:nvPr>
-        </p:nvSpPr>
-        <p:spPr/>
-        <p:txBody>
-          <a:bodyPr/>
-          <a:lstStyle/>
-          <a:p>
-            <a:r>
-              <a:t>This is the table for the full memory benchmark. Every TBD is filled from the run outputs after the run finishes, and none of it is claimed before that. The three conditions are raw hybrid search, the enhanced memory with observations and graph expansion, and the full history in the prompt. The two ablations switch off the graph expansion and the observations on the same 100 questions, and the repeats show how much the score moves when nothing changes. A pilot run of 10 questions was started on 2026-10-09 with Sonnet 5.5 as reader and Opus 5.5 as judge. It stopped during ingestion because the worker model hit its 3,072 token output limit on some episodes and the harness stops on a failed job, so there are no scored answers yet.</a:t>
             </a:r>
           </a:p>
         </p:txBody>
@@ -1804,7 +1733,7 @@
             </a:pPr>
             <a:r>
               <a:rPr lang="en-US" dirty="0"/>
-              <a:t>The knowledge graph fixed the design problems, because facts are linked to each other and to their quotes, and it helped us a lot while building it. Vijaylaxmi Ma’am’s guidance pointed us towards the graph, and we have not measured the retrieval gain yet because the LongMemEval run is pending.</a:t>
+              <a:t>The knowledge graph fixed the design problems, because facts are linked to each other and to their quotes, and it helped us a lot while building it. Vijaylaxmi Ma’am’s guidance pointed us towards the graph.</a:t>
             </a:r>
           </a:p>
         </p:txBody>
@@ -1892,7 +1821,7 @@
             <a:pPr/>
             <a:r>
               <a:rPr lang="en-US" dirty="0"/>
-              <a:t>The first seven rows are the objectives we set in the First Review, and the Pi row is the only one we added. Reproducibility had no number in the First Review, so we describe it in words.</a:t>
+              <a:t>The first six rows are the objectives we set in the First Review, and the Pi row is the only one we added. Reproducibility had no number in the First Review, so we describe it in words.</a:t>
             </a:r>
           </a:p>
           <a:p>
@@ -1903,18 +1832,7 @@
             </a:pPr>
             <a:r>
               <a:rPr lang="en-US" dirty="0"/>
-              <a:t>Every number in the Measured column comes from one machine on 2026-10-06, mostly from our own user:dev namespace with 323 facts, so none of it is a benchmark result. The two targets we miss are the median context size and the latency when the date planner runs.</a:t>
-            </a:r>
-          </a:p>
-          <a:p>
-            <a:pPr>
-              <a:spcBef>
-                <a:spcPts val="600"/>
-              </a:spcBef>
-            </a:pPr>
-            <a:r>
-              <a:rPr lang="en-US" dirty="0"/>
-              <a:t>Retrieval quality is not run yet, because LongMemEval-S needs a 277 MB dataset and a lot of model use.</a:t>
+              <a:t>Every number in the Measured column comes from one machine on 2026-10-06, mostly from our own user:dev namespace with 323 facts, so treat it as one-machine measurements. The two targets we miss are the median context size and the latency when the date planner runs.</a:t>
             </a:r>
           </a:p>
         </p:txBody>
@@ -11115,7 +11033,7 @@
         <p:spPr>
           <a:xfrm>
             <a:off x="594360" y="4370832"/>
-            <a:ext cx="3545738" cy="1591056"/>
+            <a:ext cx="5400000" cy="1591056"/>
           </a:xfrm>
           <a:prstGeom prst="rect">
             <a:avLst/>
@@ -11203,8 +11121,8 @@
         </p:nvSpPr>
         <p:spPr>
           <a:xfrm>
-            <a:off x="4322978" y="4370832"/>
-            <a:ext cx="3545738" cy="1591056"/>
+            <a:off x="6192360" y="4370832"/>
+            <a:ext cx="5400000" cy="1591056"/>
           </a:xfrm>
           <a:prstGeom prst="rect">
             <a:avLst/>
@@ -11279,95 +11197,6 @@
                 <a:cs typeface="Times New Roman" pitchFamily="34" charset="-120"/>
               </a:rPr>
               <a:t>LoCoMo [15] is used only for evaluation, never for training. It is CC BY-NC 4.0.</a:t>
-            </a:r>
-            <a:endParaRPr lang="en-US" sz="1300" dirty="0"/>
-          </a:p>
-        </p:txBody>
-      </p:sp>
-      <p:sp>
-        <p:nvSpPr>
-          <p:cNvPr id="6" name="Text 3"/>
-          <p:cNvSpPr/>
-          <p:nvPr/>
-        </p:nvSpPr>
-        <p:spPr>
-          <a:xfrm>
-            <a:off x="8051597" y="4370832"/>
-            <a:ext cx="3545738" cy="1591056"/>
-          </a:xfrm>
-          <a:prstGeom prst="rect">
-            <a:avLst/>
-          </a:prstGeom>
-          <a:solidFill>
-            <a:srgbClr val="FFFFFF"/>
-          </a:solidFill>
-          <a:ln w="12700">
-            <a:solidFill>
-              <a:srgbClr val="333333"/>
-            </a:solidFill>
-            <a:prstDash val="solid"/>
-          </a:ln>
-        </p:spPr>
-        <p:txBody>
-          <a:bodyPr wrap="square" lIns="63500" tIns="88900" rIns="88900" bIns="63500" rtlCol="0" anchor="t"/>
-          <a:lstStyle/>
-          <a:p>
-            <a:pPr algn="l" indent="0" marL="0">
-              <a:spcAft>
-                <a:spcPts val="300"/>
-              </a:spcAft>
-              <a:buNone/>
-            </a:pPr>
-            <a:r>
-              <a:rPr lang="en-US" sz="1300" b="1" dirty="0">
-                <a:solidFill>
-                  <a:srgbClr val="1A1A1A"/>
-                </a:solidFill>
-                <a:latin typeface="Times New Roman" pitchFamily="34" charset="0"/>
-                <a:ea typeface="Times New Roman" pitchFamily="34" charset="-122"/>
-                <a:cs typeface="Times New Roman" pitchFamily="34" charset="-120"/>
-              </a:rPr>
-              <a:t>Evaluation benchmarks</a:t>
-            </a:r>
-            <a:endParaRPr lang="en-US" sz="1300" dirty="0"/>
-          </a:p>
-          <a:p>
-            <a:pPr algn="l" indent="0" marL="0">
-              <a:spcAft>
-                <a:spcPts val="400"/>
-              </a:spcAft>
-              <a:buNone/>
-            </a:pPr>
-            <a:r>
-              <a:rPr lang="en-US" sz="1200" dirty="0">
-                <a:solidFill>
-                  <a:srgbClr val="1A1A1A"/>
-                </a:solidFill>
-                <a:latin typeface="Times New Roman" pitchFamily="34" charset="0"/>
-                <a:ea typeface="Times New Roman" pitchFamily="34" charset="-122"/>
-                <a:cs typeface="Times New Roman" pitchFamily="34" charset="-120"/>
-              </a:rPr>
-              <a:t>LongMemEval-S [2], September 2025 cleaned release: 500 questions, 23,867 episodes, 277 MB, pinned by SHA-256, not in Git. GPT-4o scored 60.6% on the S histories in the original paper release.</a:t>
-            </a:r>
-            <a:endParaRPr lang="en-US" sz="1300" dirty="0"/>
-          </a:p>
-          <a:p>
-            <a:pPr algn="l" indent="0" marL="0">
-              <a:spcAft>
-                <a:spcPts val="400"/>
-              </a:spcAft>
-              <a:buNone/>
-            </a:pPr>
-            <a:r>
-              <a:rPr lang="en-US" sz="1200" dirty="0">
-                <a:solidFill>
-                  <a:srgbClr val="1A1A1A"/>
-                </a:solidFill>
-                <a:latin typeface="Times New Roman" pitchFamily="34" charset="0"/>
-                <a:ea typeface="Times New Roman" pitchFamily="34" charset="-122"/>
-                <a:cs typeface="Times New Roman" pitchFamily="34" charset="-120"/>
-              </a:rPr>
-              <a:t>LoCoMo: 10 conversations, 1,986 questions. Planned secondary benchmark.</a:t>
             </a:r>
             <a:endParaRPr lang="en-US" sz="1300" dirty="0"/>
           </a:p>
@@ -13778,203 +13607,6 @@
                   </a:tcPr>
                 </a:tc>
               </a:tr>
-              <a:tr h="0">
-                <a:tc>
-                  <a:txBody>
-                    <a:bodyPr/>
-                    <a:lstStyle/>
-                    <a:p>
-                      <a:pPr algn="l" indent="0" marL="0">
-                        <a:buNone/>
-                      </a:pPr>
-                      <a:r>
-                        <a:rPr lang="en-US" sz="1100" b="1" dirty="0">
-                          <a:solidFill>
-                            <a:srgbClr val="1A1A1A"/>
-                          </a:solidFill>
-                          <a:latin typeface="Times New Roman" pitchFamily="34" charset="0"/>
-                          <a:ea typeface="Times New Roman" pitchFamily="34" charset="-122"/>
-                          <a:cs typeface="Times New Roman" pitchFamily="34" charset="-120"/>
-                        </a:rPr>
-                        <a:t>LongMemEval-S</a:t>
-                      </a:r>
-                      <a:endParaRPr lang="en-US" sz="1100" dirty="0">
-                        <a:latin typeface="Times New Roman" charset="0"/>
-                        <a:ea typeface="Times New Roman" charset="0"/>
-                        <a:cs typeface="Times New Roman" charset="0"/>
-                      </a:endParaRPr>
-                    </a:p>
-                  </a:txBody>
-                  <a:tcPr marL="64008" marR="64008" marT="36576" marB="36576" anchor="t">
-                    <a:lnL w="9525" cap="flat" cmpd="sng" algn="ctr">
-                      <a:solidFill>
-                        <a:srgbClr val="333333"/>
-                      </a:solidFill>
-                      <a:prstDash val="solid"/>
-                      <a:round/>
-                      <a:headEnd type="none" w="med" len="med"/>
-                      <a:tailEnd type="none" w="med" len="med"/>
-                    </a:lnL>
-                    <a:lnR w="9525" cap="flat" cmpd="sng" algn="ctr">
-                      <a:solidFill>
-                        <a:srgbClr val="333333"/>
-                      </a:solidFill>
-                      <a:prstDash val="solid"/>
-                      <a:round/>
-                      <a:headEnd type="none" w="med" len="med"/>
-                      <a:tailEnd type="none" w="med" len="med"/>
-                    </a:lnR>
-                    <a:lnT w="9525" cap="flat" cmpd="sng" algn="ctr">
-                      <a:solidFill>
-                        <a:srgbClr val="333333"/>
-                      </a:solidFill>
-                      <a:prstDash val="solid"/>
-                      <a:round/>
-                      <a:headEnd type="none" w="med" len="med"/>
-                      <a:tailEnd type="none" w="med" len="med"/>
-                    </a:lnT>
-                    <a:lnB w="9525" cap="flat" cmpd="sng" algn="ctr">
-                      <a:solidFill>
-                        <a:srgbClr val="333333"/>
-                      </a:solidFill>
-                      <a:prstDash val="solid"/>
-                      <a:round/>
-                      <a:headEnd type="none" w="med" len="med"/>
-                      <a:tailEnd type="none" w="med" len="med"/>
-                    </a:lnB>
-                  </a:tcPr>
-                </a:tc>
-                <a:tc>
-                  <a:txBody>
-                    <a:bodyPr/>
-                    <a:lstStyle/>
-                    <a:p>
-                      <a:pPr algn="l" indent="0" marL="0">
-                        <a:buNone/>
-                      </a:pPr>
-                      <a:r>
-                        <a:rPr lang="en-US" sz="1100" dirty="0">
-                          <a:solidFill>
-                            <a:srgbClr val="1A1A1A"/>
-                          </a:solidFill>
-                          <a:latin typeface="Times New Roman" pitchFamily="34" charset="0"/>
-                          <a:ea typeface="Times New Roman" pitchFamily="34" charset="-122"/>
-                          <a:cs typeface="Times New Roman" pitchFamily="34" charset="-120"/>
-                        </a:rPr>
-                        <a:t>Not run</a:t>
-                      </a:r>
-                      <a:endParaRPr lang="en-US" sz="1100" dirty="0">
-                        <a:latin typeface="Times New Roman" charset="0"/>
-                        <a:ea typeface="Times New Roman" charset="0"/>
-                        <a:cs typeface="Times New Roman" charset="0"/>
-                      </a:endParaRPr>
-                    </a:p>
-                  </a:txBody>
-                  <a:tcPr marL="64008" marR="64008" marT="36576" marB="36576" anchor="t">
-                    <a:lnL w="9525" cap="flat" cmpd="sng" algn="ctr">
-                      <a:solidFill>
-                        <a:srgbClr val="333333"/>
-                      </a:solidFill>
-                      <a:prstDash val="solid"/>
-                      <a:round/>
-                      <a:headEnd type="none" w="med" len="med"/>
-                      <a:tailEnd type="none" w="med" len="med"/>
-                    </a:lnL>
-                    <a:lnR w="9525" cap="flat" cmpd="sng" algn="ctr">
-                      <a:solidFill>
-                        <a:srgbClr val="333333"/>
-                      </a:solidFill>
-                      <a:prstDash val="solid"/>
-                      <a:round/>
-                      <a:headEnd type="none" w="med" len="med"/>
-                      <a:tailEnd type="none" w="med" len="med"/>
-                    </a:lnR>
-                    <a:lnT w="9525" cap="flat" cmpd="sng" algn="ctr">
-                      <a:solidFill>
-                        <a:srgbClr val="333333"/>
-                      </a:solidFill>
-                      <a:prstDash val="solid"/>
-                      <a:round/>
-                      <a:headEnd type="none" w="med" len="med"/>
-                      <a:tailEnd type="none" w="med" len="med"/>
-                    </a:lnT>
-                    <a:lnB w="9525" cap="flat" cmpd="sng" algn="ctr">
-                      <a:solidFill>
-                        <a:srgbClr val="333333"/>
-                      </a:solidFill>
-                      <a:prstDash val="solid"/>
-                      <a:round/>
-                      <a:headEnd type="none" w="med" len="med"/>
-                      <a:tailEnd type="none" w="med" len="med"/>
-                    </a:lnB>
-                  </a:tcPr>
-                </a:tc>
-                <a:tc>
-                  <a:txBody>
-                    <a:bodyPr/>
-                    <a:lstStyle/>
-                    <a:p>
-                      <a:pPr algn="l" indent="0" marL="0">
-                        <a:buNone/>
-                      </a:pPr>
-                      <a:r>
-                        <a:rPr lang="en-US" sz="1100" dirty="0">
-                          <a:solidFill>
-                            <a:srgbClr val="1A1A1A"/>
-                          </a:solidFill>
-                          <a:latin typeface="Times New Roman" pitchFamily="34" charset="0"/>
-                          <a:ea typeface="Times New Roman" pitchFamily="34" charset="-122"/>
-                          <a:cs typeface="Times New Roman" pitchFamily="34" charset="-120"/>
-                        </a:rPr>
-                        <a:t>Needs a 277 MB dataset and a lot of model use. Until it runs, the effect of memory on answers is unmeasured</a:t>
-                      </a:r>
-                      <a:endParaRPr lang="en-US" sz="1100" dirty="0">
-                        <a:latin typeface="Times New Roman" charset="0"/>
-                        <a:ea typeface="Times New Roman" charset="0"/>
-                        <a:cs typeface="Times New Roman" charset="0"/>
-                      </a:endParaRPr>
-                    </a:p>
-                  </a:txBody>
-                  <a:tcPr marL="64008" marR="64008" marT="36576" marB="36576" anchor="t">
-                    <a:lnL w="9525" cap="flat" cmpd="sng" algn="ctr">
-                      <a:solidFill>
-                        <a:srgbClr val="333333"/>
-                      </a:solidFill>
-                      <a:prstDash val="solid"/>
-                      <a:round/>
-                      <a:headEnd type="none" w="med" len="med"/>
-                      <a:tailEnd type="none" w="med" len="med"/>
-                    </a:lnL>
-                    <a:lnR w="9525" cap="flat" cmpd="sng" algn="ctr">
-                      <a:solidFill>
-                        <a:srgbClr val="333333"/>
-                      </a:solidFill>
-                      <a:prstDash val="solid"/>
-                      <a:round/>
-                      <a:headEnd type="none" w="med" len="med"/>
-                      <a:tailEnd type="none" w="med" len="med"/>
-                    </a:lnR>
-                    <a:lnT w="9525" cap="flat" cmpd="sng" algn="ctr">
-                      <a:solidFill>
-                        <a:srgbClr val="333333"/>
-                      </a:solidFill>
-                      <a:prstDash val="solid"/>
-                      <a:round/>
-                      <a:headEnd type="none" w="med" len="med"/>
-                      <a:tailEnd type="none" w="med" len="med"/>
-                    </a:lnT>
-                    <a:lnB w="9525" cap="flat" cmpd="sng" algn="ctr">
-                      <a:solidFill>
-                        <a:srgbClr val="333333"/>
-                      </a:solidFill>
-                      <a:prstDash val="solid"/>
-                      <a:round/>
-                      <a:headEnd type="none" w="med" len="med"/>
-                      <a:tailEnd type="none" w="med" len="med"/>
-                    </a:lnB>
-                  </a:tcPr>
-                </a:tc>
-              </a:tr>
             </a:tbl>
           </a:graphicData>
         </a:graphic>
@@ -14036,1933 +13668,6 @@
 </file>
 
 <file path=ppt/slides/slide16.xml><?xml version="1.0" encoding="utf-8"?>
-<p:sld xmlns:a="http://schemas.openxmlformats.org/drawingml/2006/main" xmlns:r="http://schemas.openxmlformats.org/officeDocument/2006/relationships" xmlns:p="http://schemas.openxmlformats.org/presentationml/2006/main">
-  <p:cSld name="Slide 14">
-    <p:spTree>
-      <p:nvGrpSpPr>
-        <p:cNvPr id="1" name=""/>
-        <p:cNvGrpSpPr/>
-        <p:nvPr/>
-      </p:nvGrpSpPr>
-      <p:grpSpPr>
-        <a:xfrm>
-          <a:off x="0" y="0"/>
-          <a:ext cx="0" cy="0"/>
-          <a:chOff x="0" y="0"/>
-          <a:chExt cx="0" cy="0"/>
-        </a:xfrm>
-      </p:grpSpPr>
-      <p:sp>
-        <p:nvSpPr>
-          <p:cNvPr id="2" name="Text 2"/>
-          <p:cNvSpPr/>
-          <p:nvPr>
-            <p:ph idx="102" type="title" hasCustomPrompt="1"/>
-          </p:nvPr>
-        </p:nvSpPr>
-        <p:spPr>
-          <a:xfrm>
-            <a:off x="594360" y="384048"/>
-            <a:ext cx="9814255" cy="777240"/>
-          </a:xfrm>
-          <a:prstGeom prst="rect">
-            <a:avLst/>
-          </a:prstGeom>
-          <a:noFill/>
-          <a:ln/>
-        </p:spPr>
-        <p:txBody>
-          <a:bodyPr wrap="square" lIns="0" tIns="0" rIns="0" bIns="0" rtlCol="0" anchor="ctr"/>
-          <a:lstStyle/>
-          <a:p>
-            <a:pPr algn="l" indent="0" marL="0">
-              <a:buNone/>
-            </a:pPr>
-            <a:r>
-              <a:rPr lang="en-US" sz="3000" dirty="0">
-                <a:solidFill>
-                  <a:srgbClr val="000000"/>
-                </a:solidFill>
-                <a:latin typeface="Times New Roman" pitchFamily="34" charset="0"/>
-                <a:ea typeface="Times New Roman" pitchFamily="34" charset="-122"/>
-                <a:cs typeface="Times New Roman" pitchFamily="34" charset="-120"/>
-              </a:rPr>
-              <a:t>BENCHMARK RESULTS</a:t>
-            </a:r>
-            <a:endParaRPr lang="en-US" sz="3000" dirty="0"/>
-          </a:p>
-        </p:txBody>
-      </p:sp>
-      <p:graphicFrame>
-        <p:nvGraphicFramePr>
-          <p:cNvPr id="3" name="Table 0"/>
-          <p:cNvGraphicFramePr>
-            <a:graphicFrameLocks noGrp="1"/>
-          </p:cNvGraphicFramePr>
-          <p:nvPr>
-            <p:extLst>
-              <p:ext uri="{D42A27DB-BD31-4B8C-83A1-F6EECF244321}">
-                <p14:modId xmlns:p14="http://schemas.microsoft.com/office/powerpoint/2010/main" val="1579011935"/>
-              </p:ext>
-            </p:extLst>
-          </p:nvPr>
-        </p:nvGraphicFramePr>
-        <p:xfrm>
-          <a:off x="594360" y="1188720"/>
-          <a:ext cx="11002975" cy="914400"/>
-        </p:xfrm>
-        <a:graphic>
-          <a:graphicData uri="http://schemas.openxmlformats.org/drawingml/2006/table">
-            <a:tbl>
-              <a:tblPr firstRow="1"/>
-              <a:tblGrid>
-                <a:gridCol w="1828800"/>
-                <a:gridCol w="5943600"/>
-                <a:gridCol w="3227832"/>
-              </a:tblGrid>
-              <a:tr h="0">
-                <a:tc>
-                  <a:txBody>
-                    <a:bodyPr/>
-                    <a:lstStyle/>
-                    <a:p>
-                      <a:pPr algn="l" indent="0" marL="0">
-                        <a:buNone/>
-                      </a:pPr>
-                      <a:r>
-                        <a:rPr lang="en-US" sz="1100" b="1" dirty="0">
-                          <a:solidFill>
-                            <a:srgbClr val="000000"/>
-                          </a:solidFill>
-                          <a:latin typeface="Times New Roman" pitchFamily="34" charset="0"/>
-                          <a:ea typeface="Times New Roman" pitchFamily="34" charset="-122"/>
-                          <a:cs typeface="Times New Roman" pitchFamily="34" charset="-120"/>
-                        </a:rPr>
-                        <a:t>Condition</a:t>
-                      </a:r>
-                      <a:endParaRPr lang="en-US" sz="1100" dirty="0">
-                        <a:latin typeface="Times New Roman" charset="0"/>
-                        <a:ea typeface="Times New Roman" charset="0"/>
-                        <a:cs typeface="Times New Roman" charset="0"/>
-                      </a:endParaRPr>
-                    </a:p>
-                  </a:txBody>
-                  <a:tcPr marL="64008" marR="64008" marT="36576" marB="36576" anchor="t">
-                    <a:lnL w="9525" cap="flat" cmpd="sng" algn="ctr">
-                      <a:solidFill>
-                        <a:srgbClr val="333333"/>
-                      </a:solidFill>
-                      <a:prstDash val="solid"/>
-                      <a:round/>
-                      <a:headEnd type="none" w="med" len="med"/>
-                      <a:tailEnd type="none" w="med" len="med"/>
-                    </a:lnL>
-                    <a:lnR w="9525" cap="flat" cmpd="sng" algn="ctr">
-                      <a:solidFill>
-                        <a:srgbClr val="333333"/>
-                      </a:solidFill>
-                      <a:prstDash val="solid"/>
-                      <a:round/>
-                      <a:headEnd type="none" w="med" len="med"/>
-                      <a:tailEnd type="none" w="med" len="med"/>
-                    </a:lnR>
-                    <a:lnT w="9525" cap="flat" cmpd="sng" algn="ctr">
-                      <a:solidFill>
-                        <a:srgbClr val="333333"/>
-                      </a:solidFill>
-                      <a:prstDash val="solid"/>
-                      <a:round/>
-                      <a:headEnd type="none" w="med" len="med"/>
-                      <a:tailEnd type="none" w="med" len="med"/>
-                    </a:lnT>
-                    <a:lnB w="9525" cap="flat" cmpd="sng" algn="ctr">
-                      <a:solidFill>
-                        <a:srgbClr val="333333"/>
-                      </a:solidFill>
-                      <a:prstDash val="solid"/>
-                      <a:round/>
-                      <a:headEnd type="none" w="med" len="med"/>
-                      <a:tailEnd type="none" w="med" len="med"/>
-                    </a:lnB>
-                    <a:solidFill>
-                      <a:srgbClr val="F2F2F2"/>
-                    </a:solidFill>
-                  </a:tcPr>
-                </a:tc>
-                <a:tc>
-                  <a:txBody>
-                    <a:bodyPr/>
-                    <a:lstStyle/>
-                    <a:p>
-                      <a:pPr algn="l" indent="0" marL="0">
-                        <a:buNone/>
-                      </a:pPr>
-                      <a:r>
-                        <a:rPr lang="en-US" sz="1100" b="1" dirty="0">
-                          <a:solidFill>
-                            <a:srgbClr val="000000"/>
-                          </a:solidFill>
-                          <a:latin typeface="Times New Roman" pitchFamily="34" charset="0"/>
-                          <a:ea typeface="Times New Roman" pitchFamily="34" charset="-122"/>
-                          <a:cs typeface="Times New Roman" pitchFamily="34" charset="-120"/>
-                        </a:rPr>
-                        <a:t>Result</a:t>
-                      </a:r>
-                      <a:endParaRPr lang="en-US" sz="1100" dirty="0">
-                        <a:latin typeface="Times New Roman" charset="0"/>
-                        <a:ea typeface="Times New Roman" charset="0"/>
-                        <a:cs typeface="Times New Roman" charset="0"/>
-                      </a:endParaRPr>
-                    </a:p>
-                  </a:txBody>
-                  <a:tcPr marL="64008" marR="64008" marT="36576" marB="36576" anchor="t">
-                    <a:lnL w="9525" cap="flat" cmpd="sng" algn="ctr">
-                      <a:solidFill>
-                        <a:srgbClr val="333333"/>
-                      </a:solidFill>
-                      <a:prstDash val="solid"/>
-                      <a:round/>
-                      <a:headEnd type="none" w="med" len="med"/>
-                      <a:tailEnd type="none" w="med" len="med"/>
-                    </a:lnL>
-                    <a:lnR w="9525" cap="flat" cmpd="sng" algn="ctr">
-                      <a:solidFill>
-                        <a:srgbClr val="333333"/>
-                      </a:solidFill>
-                      <a:prstDash val="solid"/>
-                      <a:round/>
-                      <a:headEnd type="none" w="med" len="med"/>
-                      <a:tailEnd type="none" w="med" len="med"/>
-                    </a:lnR>
-                    <a:lnT w="9525" cap="flat" cmpd="sng" algn="ctr">
-                      <a:solidFill>
-                        <a:srgbClr val="333333"/>
-                      </a:solidFill>
-                      <a:prstDash val="solid"/>
-                      <a:round/>
-                      <a:headEnd type="none" w="med" len="med"/>
-                      <a:tailEnd type="none" w="med" len="med"/>
-                    </a:lnT>
-                    <a:lnB w="9525" cap="flat" cmpd="sng" algn="ctr">
-                      <a:solidFill>
-                        <a:srgbClr val="333333"/>
-                      </a:solidFill>
-                      <a:prstDash val="solid"/>
-                      <a:round/>
-                      <a:headEnd type="none" w="med" len="med"/>
-                      <a:tailEnd type="none" w="med" len="med"/>
-                    </a:lnB>
-                    <a:solidFill>
-                      <a:srgbClr val="F2F2F2"/>
-                    </a:solidFill>
-                  </a:tcPr>
-                </a:tc>
-                <a:tc>
-                  <a:txBody>
-                    <a:bodyPr/>
-                    <a:lstStyle/>
-                    <a:p>
-                      <a:pPr algn="l" indent="0" marL="0">
-                        <a:buNone/>
-                      </a:pPr>
-                      <a:r>
-                        <a:rPr lang="en-US" sz="1100" b="1" dirty="0">
-                          <a:solidFill>
-                            <a:srgbClr val="000000"/>
-                          </a:solidFill>
-                          <a:latin typeface="Times New Roman" pitchFamily="34" charset="0"/>
-                          <a:ea typeface="Times New Roman" pitchFamily="34" charset="-122"/>
-                          <a:cs typeface="Times New Roman" pitchFamily="34" charset="-120"/>
-                        </a:rPr>
-                        <a:t>Limit kept with it</a:t>
-                      </a:r>
-                      <a:endParaRPr lang="en-US" sz="1100" dirty="0">
-                        <a:latin typeface="Times New Roman" charset="0"/>
-                        <a:ea typeface="Times New Roman" charset="0"/>
-                        <a:cs typeface="Times New Roman" charset="0"/>
-                      </a:endParaRPr>
-                    </a:p>
-                  </a:txBody>
-                  <a:tcPr marL="64008" marR="64008" marT="36576" marB="36576" anchor="t">
-                    <a:lnL w="9525" cap="flat" cmpd="sng" algn="ctr">
-                      <a:solidFill>
-                        <a:srgbClr val="333333"/>
-                      </a:solidFill>
-                      <a:prstDash val="solid"/>
-                      <a:round/>
-                      <a:headEnd type="none" w="med" len="med"/>
-                      <a:tailEnd type="none" w="med" len="med"/>
-                    </a:lnL>
-                    <a:lnR w="9525" cap="flat" cmpd="sng" algn="ctr">
-                      <a:solidFill>
-                        <a:srgbClr val="333333"/>
-                      </a:solidFill>
-                      <a:prstDash val="solid"/>
-                      <a:round/>
-                      <a:headEnd type="none" w="med" len="med"/>
-                      <a:tailEnd type="none" w="med" len="med"/>
-                    </a:lnR>
-                    <a:lnT w="9525" cap="flat" cmpd="sng" algn="ctr">
-                      <a:solidFill>
-                        <a:srgbClr val="333333"/>
-                      </a:solidFill>
-                      <a:prstDash val="solid"/>
-                      <a:round/>
-                      <a:headEnd type="none" w="med" len="med"/>
-                      <a:tailEnd type="none" w="med" len="med"/>
-                    </a:lnT>
-                    <a:lnB w="9525" cap="flat" cmpd="sng" algn="ctr">
-                      <a:solidFill>
-                        <a:srgbClr val="333333"/>
-                      </a:solidFill>
-                      <a:prstDash val="solid"/>
-                      <a:round/>
-                      <a:headEnd type="none" w="med" len="med"/>
-                      <a:tailEnd type="none" w="med" len="med"/>
-                    </a:lnB>
-                    <a:solidFill>
-                      <a:srgbClr val="F2F2F2"/>
-                    </a:solidFill>
-                  </a:tcPr>
-                </a:tc>
-              </a:tr>
-              <a:tr h="0">
-                <a:tc>
-                  <a:txBody>
-                    <a:bodyPr/>
-                    <a:lstStyle/>
-                    <a:p>
-                      <a:pPr algn="l" indent="0" marL="0">
-                        <a:buNone/>
-                      </a:pPr>
-                      <a:r>
-                        <a:rPr lang="en-US" sz="1100" b="1" dirty="0">
-                          <a:solidFill>
-                            <a:srgbClr val="1A1A1A"/>
-                          </a:solidFill>
-                          <a:latin typeface="Times New Roman" pitchFamily="34" charset="0"/>
-                          <a:ea typeface="Times New Roman" pitchFamily="34" charset="-122"/>
-                          <a:cs typeface="Times New Roman" pitchFamily="34" charset="-120"/>
-                        </a:rPr>
-                        <a:t>Setup</a:t>
-                      </a:r>
-                      <a:endParaRPr lang="en-US" sz="1100" dirty="0">
-                        <a:latin typeface="Times New Roman" charset="0"/>
-                        <a:ea typeface="Times New Roman" charset="0"/>
-                        <a:cs typeface="Times New Roman" charset="0"/>
-                      </a:endParaRPr>
-                    </a:p>
-                  </a:txBody>
-                  <a:tcPr marL="64008" marR="64008" marT="36576" marB="36576" anchor="t">
-                    <a:lnL w="9525" cap="flat" cmpd="sng" algn="ctr">
-                      <a:solidFill>
-                        <a:srgbClr val="333333"/>
-                      </a:solidFill>
-                      <a:prstDash val="solid"/>
-                      <a:round/>
-                      <a:headEnd type="none" w="med" len="med"/>
-                      <a:tailEnd type="none" w="med" len="med"/>
-                    </a:lnL>
-                    <a:lnR w="9525" cap="flat" cmpd="sng" algn="ctr">
-                      <a:solidFill>
-                        <a:srgbClr val="333333"/>
-                      </a:solidFill>
-                      <a:prstDash val="solid"/>
-                      <a:round/>
-                      <a:headEnd type="none" w="med" len="med"/>
-                      <a:tailEnd type="none" w="med" len="med"/>
-                    </a:lnR>
-                    <a:lnT w="9525" cap="flat" cmpd="sng" algn="ctr">
-                      <a:solidFill>
-                        <a:srgbClr val="333333"/>
-                      </a:solidFill>
-                      <a:prstDash val="solid"/>
-                      <a:round/>
-                      <a:headEnd type="none" w="med" len="med"/>
-                      <a:tailEnd type="none" w="med" len="med"/>
-                    </a:lnT>
-                    <a:lnB w="9525" cap="flat" cmpd="sng" algn="ctr">
-                      <a:solidFill>
-                        <a:srgbClr val="333333"/>
-                      </a:solidFill>
-                      <a:prstDash val="solid"/>
-                      <a:round/>
-                      <a:headEnd type="none" w="med" len="med"/>
-                      <a:tailEnd type="none" w="med" len="med"/>
-                    </a:lnB>
-                  </a:tcPr>
-                </a:tc>
-                <a:tc>
-                  <a:txBody>
-                    <a:bodyPr/>
-                    <a:lstStyle/>
-                    <a:p>
-                      <a:pPr algn="l" indent="0" marL="0">
-                        <a:buNone/>
-                      </a:pPr>
-                      <a:r>
-                        <a:rPr lang="en-US" sz="1100" dirty="0">
-                          <a:solidFill>
-                            <a:srgbClr val="1A1A1A"/>
-                          </a:solidFill>
-                          <a:latin typeface="Times New Roman" pitchFamily="34" charset="0"/>
-                          <a:ea typeface="Times New Roman" pitchFamily="34" charset="-122"/>
-                          <a:cs typeface="Times New Roman" pitchFamily="34" charset="-120"/>
-                        </a:rPr>
-                        <a:t>LongMemEval-S cleaned, 500 questions, 23,867 episodes. Worker mem-extractor, embeddings qwen3-embedding:0.6b. Reader TBD, judge TBD, seed 20261005</a:t>
-                      </a:r>
-                      <a:endParaRPr lang="en-US" sz="1100" dirty="0">
-                        <a:latin typeface="Times New Roman" charset="0"/>
-                        <a:ea typeface="Times New Roman" charset="0"/>
-                        <a:cs typeface="Times New Roman" charset="0"/>
-                      </a:endParaRPr>
-                    </a:p>
-                  </a:txBody>
-                  <a:tcPr marL="64008" marR="64008" marT="36576" marB="36576" anchor="t">
-                    <a:lnL w="9525" cap="flat" cmpd="sng" algn="ctr">
-                      <a:solidFill>
-                        <a:srgbClr val="333333"/>
-                      </a:solidFill>
-                      <a:prstDash val="solid"/>
-                      <a:round/>
-                      <a:headEnd type="none" w="med" len="med"/>
-                      <a:tailEnd type="none" w="med" len="med"/>
-                    </a:lnL>
-                    <a:lnR w="9525" cap="flat" cmpd="sng" algn="ctr">
-                      <a:solidFill>
-                        <a:srgbClr val="333333"/>
-                      </a:solidFill>
-                      <a:prstDash val="solid"/>
-                      <a:round/>
-                      <a:headEnd type="none" w="med" len="med"/>
-                      <a:tailEnd type="none" w="med" len="med"/>
-                    </a:lnR>
-                    <a:lnT w="9525" cap="flat" cmpd="sng" algn="ctr">
-                      <a:solidFill>
-                        <a:srgbClr val="333333"/>
-                      </a:solidFill>
-                      <a:prstDash val="solid"/>
-                      <a:round/>
-                      <a:headEnd type="none" w="med" len="med"/>
-                      <a:tailEnd type="none" w="med" len="med"/>
-                    </a:lnT>
-                    <a:lnB w="9525" cap="flat" cmpd="sng" algn="ctr">
-                      <a:solidFill>
-                        <a:srgbClr val="333333"/>
-                      </a:solidFill>
-                      <a:prstDash val="solid"/>
-                      <a:round/>
-                      <a:headEnd type="none" w="med" len="med"/>
-                      <a:tailEnd type="none" w="med" len="med"/>
-                    </a:lnB>
-                  </a:tcPr>
-                </a:tc>
-                <a:tc>
-                  <a:txBody>
-                    <a:bodyPr/>
-                    <a:lstStyle/>
-                    <a:p>
-                      <a:pPr algn="l" indent="0" marL="0">
-                        <a:buNone/>
-                      </a:pPr>
-                      <a:r>
-                        <a:rPr lang="en-US" sz="1100" dirty="0">
-                          <a:solidFill>
-                            <a:srgbClr val="1A1A1A"/>
-                          </a:solidFill>
-                          <a:latin typeface="Times New Roman" pitchFamily="34" charset="0"/>
-                          <a:ea typeface="Times New Roman" pitchFamily="34" charset="-122"/>
-                          <a:cs typeface="Times New Roman" pitchFamily="34" charset="-120"/>
-                        </a:rPr>
-                        <a:t>Pilot of 10 questions stopped during ingestion: for 3 of the 5 questions in progress, an extract job failed 5 times at the worker's 3,072 token output limit. No answers were scored. Frozen in benchmark/config.json</a:t>
-                      </a:r>
-                      <a:endParaRPr lang="en-US" sz="1100" dirty="0">
-                        <a:latin typeface="Times New Roman" charset="0"/>
-                        <a:ea typeface="Times New Roman" charset="0"/>
-                        <a:cs typeface="Times New Roman" charset="0"/>
-                      </a:endParaRPr>
-                    </a:p>
-                  </a:txBody>
-                  <a:tcPr marL="64008" marR="64008" marT="36576" marB="36576" anchor="t">
-                    <a:lnL w="9525" cap="flat" cmpd="sng" algn="ctr">
-                      <a:solidFill>
-                        <a:srgbClr val="333333"/>
-                      </a:solidFill>
-                      <a:prstDash val="solid"/>
-                      <a:round/>
-                      <a:headEnd type="none" w="med" len="med"/>
-                      <a:tailEnd type="none" w="med" len="med"/>
-                    </a:lnL>
-                    <a:lnR w="9525" cap="flat" cmpd="sng" algn="ctr">
-                      <a:solidFill>
-                        <a:srgbClr val="333333"/>
-                      </a:solidFill>
-                      <a:prstDash val="solid"/>
-                      <a:round/>
-                      <a:headEnd type="none" w="med" len="med"/>
-                      <a:tailEnd type="none" w="med" len="med"/>
-                    </a:lnR>
-                    <a:lnT w="9525" cap="flat" cmpd="sng" algn="ctr">
-                      <a:solidFill>
-                        <a:srgbClr val="333333"/>
-                      </a:solidFill>
-                      <a:prstDash val="solid"/>
-                      <a:round/>
-                      <a:headEnd type="none" w="med" len="med"/>
-                      <a:tailEnd type="none" w="med" len="med"/>
-                    </a:lnT>
-                    <a:lnB w="9525" cap="flat" cmpd="sng" algn="ctr">
-                      <a:solidFill>
-                        <a:srgbClr val="333333"/>
-                      </a:solidFill>
-                      <a:prstDash val="solid"/>
-                      <a:round/>
-                      <a:headEnd type="none" w="med" len="med"/>
-                      <a:tailEnd type="none" w="med" len="med"/>
-                    </a:lnB>
-                  </a:tcPr>
-                </a:tc>
-              </a:tr>
-              <a:tr h="0">
-                <a:tc>
-                  <a:txBody>
-                    <a:bodyPr/>
-                    <a:lstStyle/>
-                    <a:p>
-                      <a:pPr algn="l" indent="0" marL="0">
-                        <a:buNone/>
-                      </a:pPr>
-                      <a:r>
-                        <a:rPr lang="en-US" sz="1100" b="1" dirty="0">
-                          <a:solidFill>
-                            <a:srgbClr val="1A1A1A"/>
-                          </a:solidFill>
-                          <a:latin typeface="Times New Roman" pitchFamily="34" charset="0"/>
-                          <a:ea typeface="Times New Roman" pitchFamily="34" charset="-122"/>
-                          <a:cs typeface="Times New Roman" pitchFamily="34" charset="-120"/>
-                        </a:rPr>
-                        <a:t>raw_hybrid: lexical and vector search over source chunks</a:t>
-                      </a:r>
-                      <a:endParaRPr lang="en-US" sz="1100" dirty="0">
-                        <a:latin typeface="Times New Roman" charset="0"/>
-                        <a:ea typeface="Times New Roman" charset="0"/>
-                        <a:cs typeface="Times New Roman" charset="0"/>
-                      </a:endParaRPr>
-                    </a:p>
-                  </a:txBody>
-                  <a:tcPr marL="64008" marR="64008" marT="36576" marB="36576" anchor="t">
-                    <a:lnL w="9525" cap="flat" cmpd="sng" algn="ctr">
-                      <a:solidFill>
-                        <a:srgbClr val="333333"/>
-                      </a:solidFill>
-                      <a:prstDash val="solid"/>
-                      <a:round/>
-                      <a:headEnd type="none" w="med" len="med"/>
-                      <a:tailEnd type="none" w="med" len="med"/>
-                    </a:lnL>
-                    <a:lnR w="9525" cap="flat" cmpd="sng" algn="ctr">
-                      <a:solidFill>
-                        <a:srgbClr val="333333"/>
-                      </a:solidFill>
-                      <a:prstDash val="solid"/>
-                      <a:round/>
-                      <a:headEnd type="none" w="med" len="med"/>
-                      <a:tailEnd type="none" w="med" len="med"/>
-                    </a:lnR>
-                    <a:lnT w="9525" cap="flat" cmpd="sng" algn="ctr">
-                      <a:solidFill>
-                        <a:srgbClr val="333333"/>
-                      </a:solidFill>
-                      <a:prstDash val="solid"/>
-                      <a:round/>
-                      <a:headEnd type="none" w="med" len="med"/>
-                      <a:tailEnd type="none" w="med" len="med"/>
-                    </a:lnT>
-                    <a:lnB w="9525" cap="flat" cmpd="sng" algn="ctr">
-                      <a:solidFill>
-                        <a:srgbClr val="333333"/>
-                      </a:solidFill>
-                      <a:prstDash val="solid"/>
-                      <a:round/>
-                      <a:headEnd type="none" w="med" len="med"/>
-                      <a:tailEnd type="none" w="med" len="med"/>
-                    </a:lnB>
-                  </a:tcPr>
-                </a:tc>
-                <a:tc>
-                  <a:txBody>
-                    <a:bodyPr/>
-                    <a:lstStyle/>
-                    <a:p>
-                      <a:pPr algn="l" indent="0" marL="0">
-                        <a:buNone/>
-                      </a:pPr>
-                      <a:r>
-                        <a:rPr lang="en-US" sz="1100" dirty="0">
-                          <a:solidFill>
-                            <a:srgbClr val="1A1A1A"/>
-                          </a:solidFill>
-                          <a:latin typeface="Times New Roman" pitchFamily="34" charset="0"/>
-                          <a:ea typeface="Times New Roman" pitchFamily="34" charset="-122"/>
-                          <a:cs typeface="Times New Roman" pitchFamily="34" charset="-120"/>
-                        </a:rPr>
-                        <a:t>Accuracy TBD of 500. Knowledge-update TBD, temporal TBD</a:t>
-                      </a:r>
-                      <a:endParaRPr lang="en-US" sz="1100" dirty="0">
-                        <a:latin typeface="Times New Roman" charset="0"/>
-                        <a:ea typeface="Times New Roman" charset="0"/>
-                        <a:cs typeface="Times New Roman" charset="0"/>
-                      </a:endParaRPr>
-                    </a:p>
-                  </a:txBody>
-                  <a:tcPr marL="64008" marR="64008" marT="36576" marB="36576" anchor="t">
-                    <a:lnL w="9525" cap="flat" cmpd="sng" algn="ctr">
-                      <a:solidFill>
-                        <a:srgbClr val="333333"/>
-                      </a:solidFill>
-                      <a:prstDash val="solid"/>
-                      <a:round/>
-                      <a:headEnd type="none" w="med" len="med"/>
-                      <a:tailEnd type="none" w="med" len="med"/>
-                    </a:lnL>
-                    <a:lnR w="9525" cap="flat" cmpd="sng" algn="ctr">
-                      <a:solidFill>
-                        <a:srgbClr val="333333"/>
-                      </a:solidFill>
-                      <a:prstDash val="solid"/>
-                      <a:round/>
-                      <a:headEnd type="none" w="med" len="med"/>
-                      <a:tailEnd type="none" w="med" len="med"/>
-                    </a:lnR>
-                    <a:lnT w="9525" cap="flat" cmpd="sng" algn="ctr">
-                      <a:solidFill>
-                        <a:srgbClr val="333333"/>
-                      </a:solidFill>
-                      <a:prstDash val="solid"/>
-                      <a:round/>
-                      <a:headEnd type="none" w="med" len="med"/>
-                      <a:tailEnd type="none" w="med" len="med"/>
-                    </a:lnT>
-                    <a:lnB w="9525" cap="flat" cmpd="sng" algn="ctr">
-                      <a:solidFill>
-                        <a:srgbClr val="333333"/>
-                      </a:solidFill>
-                      <a:prstDash val="solid"/>
-                      <a:round/>
-                      <a:headEnd type="none" w="med" len="med"/>
-                      <a:tailEnd type="none" w="med" len="med"/>
-                    </a:lnB>
-                  </a:tcPr>
-                </a:tc>
-                <a:tc>
-                  <a:txBody>
-                    <a:bodyPr/>
-                    <a:lstStyle/>
-                    <a:p>
-                      <a:pPr algn="l" indent="0" marL="0">
-                        <a:buNone/>
-                      </a:pPr>
-                      <a:r>
-                        <a:rPr lang="en-US" sz="1100" dirty="0">
-                          <a:solidFill>
-                            <a:srgbClr val="1A1A1A"/>
-                          </a:solidFill>
-                          <a:latin typeface="Times New Roman" pitchFamily="34" charset="0"/>
-                          <a:ea typeface="Times New Roman" pitchFamily="34" charset="-122"/>
-                          <a:cs typeface="Times New Roman" pitchFamily="34" charset="-120"/>
-                        </a:rPr>
-                        <a:t>Same reader and judge in every condition. Judge scores are custom, not official GPT-4o scores</a:t>
-                      </a:r>
-                      <a:endParaRPr lang="en-US" sz="1100" dirty="0">
-                        <a:latin typeface="Times New Roman" charset="0"/>
-                        <a:ea typeface="Times New Roman" charset="0"/>
-                        <a:cs typeface="Times New Roman" charset="0"/>
-                      </a:endParaRPr>
-                    </a:p>
-                  </a:txBody>
-                  <a:tcPr marL="64008" marR="64008" marT="36576" marB="36576" anchor="t">
-                    <a:lnL w="9525" cap="flat" cmpd="sng" algn="ctr">
-                      <a:solidFill>
-                        <a:srgbClr val="333333"/>
-                      </a:solidFill>
-                      <a:prstDash val="solid"/>
-                      <a:round/>
-                      <a:headEnd type="none" w="med" len="med"/>
-                      <a:tailEnd type="none" w="med" len="med"/>
-                    </a:lnL>
-                    <a:lnR w="9525" cap="flat" cmpd="sng" algn="ctr">
-                      <a:solidFill>
-                        <a:srgbClr val="333333"/>
-                      </a:solidFill>
-                      <a:prstDash val="solid"/>
-                      <a:round/>
-                      <a:headEnd type="none" w="med" len="med"/>
-                      <a:tailEnd type="none" w="med" len="med"/>
-                    </a:lnR>
-                    <a:lnT w="9525" cap="flat" cmpd="sng" algn="ctr">
-                      <a:solidFill>
-                        <a:srgbClr val="333333"/>
-                      </a:solidFill>
-                      <a:prstDash val="solid"/>
-                      <a:round/>
-                      <a:headEnd type="none" w="med" len="med"/>
-                      <a:tailEnd type="none" w="med" len="med"/>
-                    </a:lnT>
-                    <a:lnB w="9525" cap="flat" cmpd="sng" algn="ctr">
-                      <a:solidFill>
-                        <a:srgbClr val="333333"/>
-                      </a:solidFill>
-                      <a:prstDash val="solid"/>
-                      <a:round/>
-                      <a:headEnd type="none" w="med" len="med"/>
-                      <a:tailEnd type="none" w="med" len="med"/>
-                    </a:lnB>
-                  </a:tcPr>
-                </a:tc>
-              </a:tr>
-              <a:tr h="0">
-                <a:tc>
-                  <a:txBody>
-                    <a:bodyPr/>
-                    <a:lstStyle/>
-                    <a:p>
-                      <a:pPr algn="l" indent="0" marL="0">
-                        <a:buNone/>
-                      </a:pPr>
-                      <a:r>
-                        <a:rPr lang="en-US" sz="1100" b="1" dirty="0">
-                          <a:solidFill>
-                            <a:srgbClr val="1A1A1A"/>
-                          </a:solidFill>
-                          <a:latin typeface="Times New Roman" pitchFamily="34" charset="0"/>
-                          <a:ea typeface="Times New Roman" pitchFamily="34" charset="-122"/>
-                          <a:cs typeface="Times New Roman" pitchFamily="34" charset="-120"/>
-                        </a:rPr>
-                        <a:t>enhanced: facts, observations and graph expansion</a:t>
-                      </a:r>
-                      <a:endParaRPr lang="en-US" sz="1100" dirty="0">
-                        <a:latin typeface="Times New Roman" charset="0"/>
-                        <a:ea typeface="Times New Roman" charset="0"/>
-                        <a:cs typeface="Times New Roman" charset="0"/>
-                      </a:endParaRPr>
-                    </a:p>
-                  </a:txBody>
-                  <a:tcPr marL="64008" marR="64008" marT="36576" marB="36576" anchor="t">
-                    <a:lnL w="9525" cap="flat" cmpd="sng" algn="ctr">
-                      <a:solidFill>
-                        <a:srgbClr val="333333"/>
-                      </a:solidFill>
-                      <a:prstDash val="solid"/>
-                      <a:round/>
-                      <a:headEnd type="none" w="med" len="med"/>
-                      <a:tailEnd type="none" w="med" len="med"/>
-                    </a:lnL>
-                    <a:lnR w="9525" cap="flat" cmpd="sng" algn="ctr">
-                      <a:solidFill>
-                        <a:srgbClr val="333333"/>
-                      </a:solidFill>
-                      <a:prstDash val="solid"/>
-                      <a:round/>
-                      <a:headEnd type="none" w="med" len="med"/>
-                      <a:tailEnd type="none" w="med" len="med"/>
-                    </a:lnR>
-                    <a:lnT w="9525" cap="flat" cmpd="sng" algn="ctr">
-                      <a:solidFill>
-                        <a:srgbClr val="333333"/>
-                      </a:solidFill>
-                      <a:prstDash val="solid"/>
-                      <a:round/>
-                      <a:headEnd type="none" w="med" len="med"/>
-                      <a:tailEnd type="none" w="med" len="med"/>
-                    </a:lnT>
-                    <a:lnB w="9525" cap="flat" cmpd="sng" algn="ctr">
-                      <a:solidFill>
-                        <a:srgbClr val="333333"/>
-                      </a:solidFill>
-                      <a:prstDash val="solid"/>
-                      <a:round/>
-                      <a:headEnd type="none" w="med" len="med"/>
-                      <a:tailEnd type="none" w="med" len="med"/>
-                    </a:lnB>
-                  </a:tcPr>
-                </a:tc>
-                <a:tc>
-                  <a:txBody>
-                    <a:bodyPr/>
-                    <a:lstStyle/>
-                    <a:p>
-                      <a:pPr algn="l" indent="0" marL="0">
-                        <a:buNone/>
-                      </a:pPr>
-                      <a:r>
-                        <a:rPr lang="en-US" sz="1100" dirty="0">
-                          <a:solidFill>
-                            <a:srgbClr val="1A1A1A"/>
-                          </a:solidFill>
-                          <a:latin typeface="Times New Roman" pitchFamily="34" charset="0"/>
-                          <a:ea typeface="Times New Roman" pitchFamily="34" charset="-122"/>
-                          <a:cs typeface="Times New Roman" pitchFamily="34" charset="-120"/>
-                        </a:rPr>
-                        <a:t>Accuracy TBD of 500. Knowledge-update TBD, temporal TBD. Difference from raw_hybrid TBD points</a:t>
-                      </a:r>
-                      <a:endParaRPr lang="en-US" sz="1100" dirty="0">
-                        <a:latin typeface="Times New Roman" charset="0"/>
-                        <a:ea typeface="Times New Roman" charset="0"/>
-                        <a:cs typeface="Times New Roman" charset="0"/>
-                      </a:endParaRPr>
-                    </a:p>
-                  </a:txBody>
-                  <a:tcPr marL="64008" marR="64008" marT="36576" marB="36576" anchor="t">
-                    <a:lnL w="9525" cap="flat" cmpd="sng" algn="ctr">
-                      <a:solidFill>
-                        <a:srgbClr val="333333"/>
-                      </a:solidFill>
-                      <a:prstDash val="solid"/>
-                      <a:round/>
-                      <a:headEnd type="none" w="med" len="med"/>
-                      <a:tailEnd type="none" w="med" len="med"/>
-                    </a:lnL>
-                    <a:lnR w="9525" cap="flat" cmpd="sng" algn="ctr">
-                      <a:solidFill>
-                        <a:srgbClr val="333333"/>
-                      </a:solidFill>
-                      <a:prstDash val="solid"/>
-                      <a:round/>
-                      <a:headEnd type="none" w="med" len="med"/>
-                      <a:tailEnd type="none" w="med" len="med"/>
-                    </a:lnR>
-                    <a:lnT w="9525" cap="flat" cmpd="sng" algn="ctr">
-                      <a:solidFill>
-                        <a:srgbClr val="333333"/>
-                      </a:solidFill>
-                      <a:prstDash val="solid"/>
-                      <a:round/>
-                      <a:headEnd type="none" w="med" len="med"/>
-                      <a:tailEnd type="none" w="med" len="med"/>
-                    </a:lnT>
-                    <a:lnB w="9525" cap="flat" cmpd="sng" algn="ctr">
-                      <a:solidFill>
-                        <a:srgbClr val="333333"/>
-                      </a:solidFill>
-                      <a:prstDash val="solid"/>
-                      <a:round/>
-                      <a:headEnd type="none" w="med" len="med"/>
-                      <a:tailEnd type="none" w="med" len="med"/>
-                    </a:lnB>
-                  </a:tcPr>
-                </a:tc>
-                <a:tc>
-                  <a:txBody>
-                    <a:bodyPr/>
-                    <a:lstStyle/>
-                    <a:p>
-                      <a:pPr algn="l" indent="0" marL="0">
-                        <a:buNone/>
-                      </a:pPr>
-                      <a:r>
-                        <a:rPr lang="en-US" sz="1100" dirty="0">
-                          <a:solidFill>
-                            <a:srgbClr val="1A1A1A"/>
-                          </a:solidFill>
-                          <a:latin typeface="Times New Roman" pitchFamily="34" charset="0"/>
-                          <a:ea typeface="Times New Roman" pitchFamily="34" charset="-122"/>
-                          <a:cs typeface="Times New Roman" pitchFamily="34" charset="-120"/>
-                        </a:rPr>
-                        <a:t>Read the paired difference per question, not only the totals</a:t>
-                      </a:r>
-                      <a:endParaRPr lang="en-US" sz="1100" dirty="0">
-                        <a:latin typeface="Times New Roman" charset="0"/>
-                        <a:ea typeface="Times New Roman" charset="0"/>
-                        <a:cs typeface="Times New Roman" charset="0"/>
-                      </a:endParaRPr>
-                    </a:p>
-                  </a:txBody>
-                  <a:tcPr marL="64008" marR="64008" marT="36576" marB="36576" anchor="t">
-                    <a:lnL w="9525" cap="flat" cmpd="sng" algn="ctr">
-                      <a:solidFill>
-                        <a:srgbClr val="333333"/>
-                      </a:solidFill>
-                      <a:prstDash val="solid"/>
-                      <a:round/>
-                      <a:headEnd type="none" w="med" len="med"/>
-                      <a:tailEnd type="none" w="med" len="med"/>
-                    </a:lnL>
-                    <a:lnR w="9525" cap="flat" cmpd="sng" algn="ctr">
-                      <a:solidFill>
-                        <a:srgbClr val="333333"/>
-                      </a:solidFill>
-                      <a:prstDash val="solid"/>
-                      <a:round/>
-                      <a:headEnd type="none" w="med" len="med"/>
-                      <a:tailEnd type="none" w="med" len="med"/>
-                    </a:lnR>
-                    <a:lnT w="9525" cap="flat" cmpd="sng" algn="ctr">
-                      <a:solidFill>
-                        <a:srgbClr val="333333"/>
-                      </a:solidFill>
-                      <a:prstDash val="solid"/>
-                      <a:round/>
-                      <a:headEnd type="none" w="med" len="med"/>
-                      <a:tailEnd type="none" w="med" len="med"/>
-                    </a:lnT>
-                    <a:lnB w="9525" cap="flat" cmpd="sng" algn="ctr">
-                      <a:solidFill>
-                        <a:srgbClr val="333333"/>
-                      </a:solidFill>
-                      <a:prstDash val="solid"/>
-                      <a:round/>
-                      <a:headEnd type="none" w="med" len="med"/>
-                      <a:tailEnd type="none" w="med" len="med"/>
-                    </a:lnB>
-                  </a:tcPr>
-                </a:tc>
-              </a:tr>
-              <a:tr h="0">
-                <a:tc>
-                  <a:txBody>
-                    <a:bodyPr/>
-                    <a:lstStyle/>
-                    <a:p>
-                      <a:pPr algn="l" indent="0" marL="0">
-                        <a:buNone/>
-                      </a:pPr>
-                      <a:r>
-                        <a:rPr lang="en-US" sz="1100" b="1" dirty="0">
-                          <a:solidFill>
-                            <a:srgbClr val="1A1A1A"/>
-                          </a:solidFill>
-                          <a:latin typeface="Times New Roman" pitchFamily="34" charset="0"/>
-                          <a:ea typeface="Times New Roman" pitchFamily="34" charset="-122"/>
-                          <a:cs typeface="Times New Roman" pitchFamily="34" charset="-120"/>
-                        </a:rPr>
-                        <a:t>full_history: whole history in the prompt, no memory</a:t>
-                      </a:r>
-                      <a:endParaRPr lang="en-US" sz="1100" dirty="0">
-                        <a:latin typeface="Times New Roman" charset="0"/>
-                        <a:ea typeface="Times New Roman" charset="0"/>
-                        <a:cs typeface="Times New Roman" charset="0"/>
-                      </a:endParaRPr>
-                    </a:p>
-                  </a:txBody>
-                  <a:tcPr marL="64008" marR="64008" marT="36576" marB="36576" anchor="t">
-                    <a:lnL w="9525" cap="flat" cmpd="sng" algn="ctr">
-                      <a:solidFill>
-                        <a:srgbClr val="333333"/>
-                      </a:solidFill>
-                      <a:prstDash val="solid"/>
-                      <a:round/>
-                      <a:headEnd type="none" w="med" len="med"/>
-                      <a:tailEnd type="none" w="med" len="med"/>
-                    </a:lnL>
-                    <a:lnR w="9525" cap="flat" cmpd="sng" algn="ctr">
-                      <a:solidFill>
-                        <a:srgbClr val="333333"/>
-                      </a:solidFill>
-                      <a:prstDash val="solid"/>
-                      <a:round/>
-                      <a:headEnd type="none" w="med" len="med"/>
-                      <a:tailEnd type="none" w="med" len="med"/>
-                    </a:lnR>
-                    <a:lnT w="9525" cap="flat" cmpd="sng" algn="ctr">
-                      <a:solidFill>
-                        <a:srgbClr val="333333"/>
-                      </a:solidFill>
-                      <a:prstDash val="solid"/>
-                      <a:round/>
-                      <a:headEnd type="none" w="med" len="med"/>
-                      <a:tailEnd type="none" w="med" len="med"/>
-                    </a:lnT>
-                    <a:lnB w="9525" cap="flat" cmpd="sng" algn="ctr">
-                      <a:solidFill>
-                        <a:srgbClr val="333333"/>
-                      </a:solidFill>
-                      <a:prstDash val="solid"/>
-                      <a:round/>
-                      <a:headEnd type="none" w="med" len="med"/>
-                      <a:tailEnd type="none" w="med" len="med"/>
-                    </a:lnB>
-                  </a:tcPr>
-                </a:tc>
-                <a:tc>
-                  <a:txBody>
-                    <a:bodyPr/>
-                    <a:lstStyle/>
-                    <a:p>
-                      <a:pPr algn="l" indent="0" marL="0">
-                        <a:buNone/>
-                      </a:pPr>
-                      <a:r>
-                        <a:rPr lang="en-US" sz="1100" dirty="0">
-                          <a:solidFill>
-                            <a:srgbClr val="1A1A1A"/>
-                          </a:solidFill>
-                          <a:latin typeface="Times New Roman" pitchFamily="34" charset="0"/>
-                          <a:ea typeface="Times New Roman" pitchFamily="34" charset="-122"/>
-                          <a:cs typeface="Times New Roman" pitchFamily="34" charset="-120"/>
-                        </a:rPr>
-                        <a:t>Accuracy TBD of 500. Tokens per question TBD</a:t>
-                      </a:r>
-                      <a:endParaRPr lang="en-US" sz="1100" dirty="0">
-                        <a:latin typeface="Times New Roman" charset="0"/>
-                        <a:ea typeface="Times New Roman" charset="0"/>
-                        <a:cs typeface="Times New Roman" charset="0"/>
-                      </a:endParaRPr>
-                    </a:p>
-                  </a:txBody>
-                  <a:tcPr marL="64008" marR="64008" marT="36576" marB="36576" anchor="t">
-                    <a:lnL w="9525" cap="flat" cmpd="sng" algn="ctr">
-                      <a:solidFill>
-                        <a:srgbClr val="333333"/>
-                      </a:solidFill>
-                      <a:prstDash val="solid"/>
-                      <a:round/>
-                      <a:headEnd type="none" w="med" len="med"/>
-                      <a:tailEnd type="none" w="med" len="med"/>
-                    </a:lnL>
-                    <a:lnR w="9525" cap="flat" cmpd="sng" algn="ctr">
-                      <a:solidFill>
-                        <a:srgbClr val="333333"/>
-                      </a:solidFill>
-                      <a:prstDash val="solid"/>
-                      <a:round/>
-                      <a:headEnd type="none" w="med" len="med"/>
-                      <a:tailEnd type="none" w="med" len="med"/>
-                    </a:lnR>
-                    <a:lnT w="9525" cap="flat" cmpd="sng" algn="ctr">
-                      <a:solidFill>
-                        <a:srgbClr val="333333"/>
-                      </a:solidFill>
-                      <a:prstDash val="solid"/>
-                      <a:round/>
-                      <a:headEnd type="none" w="med" len="med"/>
-                      <a:tailEnd type="none" w="med" len="med"/>
-                    </a:lnT>
-                    <a:lnB w="9525" cap="flat" cmpd="sng" algn="ctr">
-                      <a:solidFill>
-                        <a:srgbClr val="333333"/>
-                      </a:solidFill>
-                      <a:prstDash val="solid"/>
-                      <a:round/>
-                      <a:headEnd type="none" w="med" len="med"/>
-                      <a:tailEnd type="none" w="med" len="med"/>
-                    </a:lnB>
-                  </a:tcPr>
-                </a:tc>
-                <a:tc>
-                  <a:txBody>
-                    <a:bodyPr/>
-                    <a:lstStyle/>
-                    <a:p>
-                      <a:pPr algn="l" indent="0" marL="0">
-                        <a:buNone/>
-                      </a:pPr>
-                      <a:r>
-                        <a:rPr lang="en-US" sz="1100" dirty="0">
-                          <a:solidFill>
-                            <a:srgbClr val="1A1A1A"/>
-                          </a:solidFill>
-                          <a:latin typeface="Times New Roman" pitchFamily="34" charset="0"/>
-                          <a:ea typeface="Times New Roman" pitchFamily="34" charset="-122"/>
-                          <a:cs typeface="Times New Roman" pitchFamily="34" charset="-120"/>
-                        </a:rPr>
-                        <a:t>Largest history is about 135,000 tokens. A context error is a failed run, not a truncation</a:t>
-                      </a:r>
-                      <a:endParaRPr lang="en-US" sz="1100" dirty="0">
-                        <a:latin typeface="Times New Roman" charset="0"/>
-                        <a:ea typeface="Times New Roman" charset="0"/>
-                        <a:cs typeface="Times New Roman" charset="0"/>
-                      </a:endParaRPr>
-                    </a:p>
-                  </a:txBody>
-                  <a:tcPr marL="64008" marR="64008" marT="36576" marB="36576" anchor="t">
-                    <a:lnL w="9525" cap="flat" cmpd="sng" algn="ctr">
-                      <a:solidFill>
-                        <a:srgbClr val="333333"/>
-                      </a:solidFill>
-                      <a:prstDash val="solid"/>
-                      <a:round/>
-                      <a:headEnd type="none" w="med" len="med"/>
-                      <a:tailEnd type="none" w="med" len="med"/>
-                    </a:lnL>
-                    <a:lnR w="9525" cap="flat" cmpd="sng" algn="ctr">
-                      <a:solidFill>
-                        <a:srgbClr val="333333"/>
-                      </a:solidFill>
-                      <a:prstDash val="solid"/>
-                      <a:round/>
-                      <a:headEnd type="none" w="med" len="med"/>
-                      <a:tailEnd type="none" w="med" len="med"/>
-                    </a:lnR>
-                    <a:lnT w="9525" cap="flat" cmpd="sng" algn="ctr">
-                      <a:solidFill>
-                        <a:srgbClr val="333333"/>
-                      </a:solidFill>
-                      <a:prstDash val="solid"/>
-                      <a:round/>
-                      <a:headEnd type="none" w="med" len="med"/>
-                      <a:tailEnd type="none" w="med" len="med"/>
-                    </a:lnT>
-                    <a:lnB w="9525" cap="flat" cmpd="sng" algn="ctr">
-                      <a:solidFill>
-                        <a:srgbClr val="333333"/>
-                      </a:solidFill>
-                      <a:prstDash val="solid"/>
-                      <a:round/>
-                      <a:headEnd type="none" w="med" len="med"/>
-                      <a:tailEnd type="none" w="med" len="med"/>
-                    </a:lnB>
-                  </a:tcPr>
-                </a:tc>
-              </a:tr>
-              <a:tr h="0">
-                <a:tc>
-                  <a:txBody>
-                    <a:bodyPr/>
-                    <a:lstStyle/>
-                    <a:p>
-                      <a:pPr algn="l" indent="0" marL="0">
-                        <a:buNone/>
-                      </a:pPr>
-                      <a:r>
-                        <a:rPr lang="en-US" sz="1100" b="1" dirty="0">
-                          <a:solidFill>
-                            <a:srgbClr val="1A1A1A"/>
-                          </a:solidFill>
-                          <a:latin typeface="Times New Roman" pitchFamily="34" charset="0"/>
-                          <a:ea typeface="Times New Roman" pitchFamily="34" charset="-122"/>
-                          <a:cs typeface="Times New Roman" pitchFamily="34" charset="-120"/>
-                        </a:rPr>
-                        <a:t>Ablations on 100 questions: no_graph and no_consolidation</a:t>
-                      </a:r>
-                      <a:endParaRPr lang="en-US" sz="1100" dirty="0">
-                        <a:latin typeface="Times New Roman" charset="0"/>
-                        <a:ea typeface="Times New Roman" charset="0"/>
-                        <a:cs typeface="Times New Roman" charset="0"/>
-                      </a:endParaRPr>
-                    </a:p>
-                  </a:txBody>
-                  <a:tcPr marL="64008" marR="64008" marT="36576" marB="36576" anchor="t">
-                    <a:lnL w="9525" cap="flat" cmpd="sng" algn="ctr">
-                      <a:solidFill>
-                        <a:srgbClr val="333333"/>
-                      </a:solidFill>
-                      <a:prstDash val="solid"/>
-                      <a:round/>
-                      <a:headEnd type="none" w="med" len="med"/>
-                      <a:tailEnd type="none" w="med" len="med"/>
-                    </a:lnL>
-                    <a:lnR w="9525" cap="flat" cmpd="sng" algn="ctr">
-                      <a:solidFill>
-                        <a:srgbClr val="333333"/>
-                      </a:solidFill>
-                      <a:prstDash val="solid"/>
-                      <a:round/>
-                      <a:headEnd type="none" w="med" len="med"/>
-                      <a:tailEnd type="none" w="med" len="med"/>
-                    </a:lnR>
-                    <a:lnT w="9525" cap="flat" cmpd="sng" algn="ctr">
-                      <a:solidFill>
-                        <a:srgbClr val="333333"/>
-                      </a:solidFill>
-                      <a:prstDash val="solid"/>
-                      <a:round/>
-                      <a:headEnd type="none" w="med" len="med"/>
-                      <a:tailEnd type="none" w="med" len="med"/>
-                    </a:lnT>
-                    <a:lnB w="9525" cap="flat" cmpd="sng" algn="ctr">
-                      <a:solidFill>
-                        <a:srgbClr val="333333"/>
-                      </a:solidFill>
-                      <a:prstDash val="solid"/>
-                      <a:round/>
-                      <a:headEnd type="none" w="med" len="med"/>
-                      <a:tailEnd type="none" w="med" len="med"/>
-                    </a:lnB>
-                  </a:tcPr>
-                </a:tc>
-                <a:tc>
-                  <a:txBody>
-                    <a:bodyPr/>
-                    <a:lstStyle/>
-                    <a:p>
-                      <a:pPr algn="l" indent="0" marL="0">
-                        <a:buNone/>
-                      </a:pPr>
-                      <a:r>
-                        <a:rPr lang="en-US" sz="1100" dirty="0">
-                          <a:solidFill>
-                            <a:srgbClr val="1A1A1A"/>
-                          </a:solidFill>
-                          <a:latin typeface="Times New Roman" pitchFamily="34" charset="0"/>
-                          <a:ea typeface="Times New Roman" pitchFamily="34" charset="-122"/>
-                          <a:cs typeface="Times New Roman" pitchFamily="34" charset="-120"/>
-                        </a:rPr>
-                        <a:t>no_graph TBD, no_consolidation TBD, enhanced on the same 100 TBD</a:t>
-                      </a:r>
-                      <a:endParaRPr lang="en-US" sz="1100" dirty="0">
-                        <a:latin typeface="Times New Roman" charset="0"/>
-                        <a:ea typeface="Times New Roman" charset="0"/>
-                        <a:cs typeface="Times New Roman" charset="0"/>
-                      </a:endParaRPr>
-                    </a:p>
-                  </a:txBody>
-                  <a:tcPr marL="64008" marR="64008" marT="36576" marB="36576" anchor="t">
-                    <a:lnL w="9525" cap="flat" cmpd="sng" algn="ctr">
-                      <a:solidFill>
-                        <a:srgbClr val="333333"/>
-                      </a:solidFill>
-                      <a:prstDash val="solid"/>
-                      <a:round/>
-                      <a:headEnd type="none" w="med" len="med"/>
-                      <a:tailEnd type="none" w="med" len="med"/>
-                    </a:lnL>
-                    <a:lnR w="9525" cap="flat" cmpd="sng" algn="ctr">
-                      <a:solidFill>
-                        <a:srgbClr val="333333"/>
-                      </a:solidFill>
-                      <a:prstDash val="solid"/>
-                      <a:round/>
-                      <a:headEnd type="none" w="med" len="med"/>
-                      <a:tailEnd type="none" w="med" len="med"/>
-                    </a:lnR>
-                    <a:lnT w="9525" cap="flat" cmpd="sng" algn="ctr">
-                      <a:solidFill>
-                        <a:srgbClr val="333333"/>
-                      </a:solidFill>
-                      <a:prstDash val="solid"/>
-                      <a:round/>
-                      <a:headEnd type="none" w="med" len="med"/>
-                      <a:tailEnd type="none" w="med" len="med"/>
-                    </a:lnT>
-                    <a:lnB w="9525" cap="flat" cmpd="sng" algn="ctr">
-                      <a:solidFill>
-                        <a:srgbClr val="333333"/>
-                      </a:solidFill>
-                      <a:prstDash val="solid"/>
-                      <a:round/>
-                      <a:headEnd type="none" w="med" len="med"/>
-                      <a:tailEnd type="none" w="med" len="med"/>
-                    </a:lnB>
-                  </a:tcPr>
-                </a:tc>
-                <a:tc>
-                  <a:txBody>
-                    <a:bodyPr/>
-                    <a:lstStyle/>
-                    <a:p>
-                      <a:pPr algn="l" indent="0" marL="0">
-                        <a:buNone/>
-                      </a:pPr>
-                      <a:r>
-                        <a:rPr lang="en-US" sz="1100" dirty="0">
-                          <a:solidFill>
-                            <a:srgbClr val="1A1A1A"/>
-                          </a:solidFill>
-                          <a:latin typeface="Times New Roman" pitchFamily="34" charset="0"/>
-                          <a:ea typeface="Times New Roman" pitchFamily="34" charset="-122"/>
-                          <a:cs typeface="Times New Roman" pitchFamily="34" charset="-120"/>
-                        </a:rPr>
-                        <a:t>Small sample. Do not claim a component helps unless the gap is larger than the repeat spread</a:t>
-                      </a:r>
-                      <a:endParaRPr lang="en-US" sz="1100" dirty="0">
-                        <a:latin typeface="Times New Roman" charset="0"/>
-                        <a:ea typeface="Times New Roman" charset="0"/>
-                        <a:cs typeface="Times New Roman" charset="0"/>
-                      </a:endParaRPr>
-                    </a:p>
-                  </a:txBody>
-                  <a:tcPr marL="64008" marR="64008" marT="36576" marB="36576" anchor="t">
-                    <a:lnL w="9525" cap="flat" cmpd="sng" algn="ctr">
-                      <a:solidFill>
-                        <a:srgbClr val="333333"/>
-                      </a:solidFill>
-                      <a:prstDash val="solid"/>
-                      <a:round/>
-                      <a:headEnd type="none" w="med" len="med"/>
-                      <a:tailEnd type="none" w="med" len="med"/>
-                    </a:lnL>
-                    <a:lnR w="9525" cap="flat" cmpd="sng" algn="ctr">
-                      <a:solidFill>
-                        <a:srgbClr val="333333"/>
-                      </a:solidFill>
-                      <a:prstDash val="solid"/>
-                      <a:round/>
-                      <a:headEnd type="none" w="med" len="med"/>
-                      <a:tailEnd type="none" w="med" len="med"/>
-                    </a:lnR>
-                    <a:lnT w="9525" cap="flat" cmpd="sng" algn="ctr">
-                      <a:solidFill>
-                        <a:srgbClr val="333333"/>
-                      </a:solidFill>
-                      <a:prstDash val="solid"/>
-                      <a:round/>
-                      <a:headEnd type="none" w="med" len="med"/>
-                      <a:tailEnd type="none" w="med" len="med"/>
-                    </a:lnT>
-                    <a:lnB w="9525" cap="flat" cmpd="sng" algn="ctr">
-                      <a:solidFill>
-                        <a:srgbClr val="333333"/>
-                      </a:solidFill>
-                      <a:prstDash val="solid"/>
-                      <a:round/>
-                      <a:headEnd type="none" w="med" len="med"/>
-                      <a:tailEnd type="none" w="med" len="med"/>
-                    </a:lnB>
-                  </a:tcPr>
-                </a:tc>
-              </a:tr>
-              <a:tr h="0">
-                <a:tc>
-                  <a:txBody>
-                    <a:bodyPr/>
-                    <a:lstStyle/>
-                    <a:p>
-                      <a:pPr algn="l" indent="0" marL="0">
-                        <a:buNone/>
-                      </a:pPr>
-                      <a:r>
-                        <a:rPr lang="en-US" sz="1100" b="1" dirty="0">
-                          <a:solidFill>
-                            <a:srgbClr val="1A1A1A"/>
-                          </a:solidFill>
-                          <a:latin typeface="Times New Roman" pitchFamily="34" charset="0"/>
-                          <a:ea typeface="Times New Roman" pitchFamily="34" charset="-122"/>
-                          <a:cs typeface="Times New Roman" pitchFamily="34" charset="-120"/>
-                        </a:rPr>
-                        <a:t>Repeats: 100 questions, 3 repetitions</a:t>
-                      </a:r>
-                      <a:endParaRPr lang="en-US" sz="1100" dirty="0">
-                        <a:latin typeface="Times New Roman" charset="0"/>
-                        <a:ea typeface="Times New Roman" charset="0"/>
-                        <a:cs typeface="Times New Roman" charset="0"/>
-                      </a:endParaRPr>
-                    </a:p>
-                  </a:txBody>
-                  <a:tcPr marL="64008" marR="64008" marT="36576" marB="36576" anchor="t">
-                    <a:lnL w="9525" cap="flat" cmpd="sng" algn="ctr">
-                      <a:solidFill>
-                        <a:srgbClr val="333333"/>
-                      </a:solidFill>
-                      <a:prstDash val="solid"/>
-                      <a:round/>
-                      <a:headEnd type="none" w="med" len="med"/>
-                      <a:tailEnd type="none" w="med" len="med"/>
-                    </a:lnL>
-                    <a:lnR w="9525" cap="flat" cmpd="sng" algn="ctr">
-                      <a:solidFill>
-                        <a:srgbClr val="333333"/>
-                      </a:solidFill>
-                      <a:prstDash val="solid"/>
-                      <a:round/>
-                      <a:headEnd type="none" w="med" len="med"/>
-                      <a:tailEnd type="none" w="med" len="med"/>
-                    </a:lnR>
-                    <a:lnT w="9525" cap="flat" cmpd="sng" algn="ctr">
-                      <a:solidFill>
-                        <a:srgbClr val="333333"/>
-                      </a:solidFill>
-                      <a:prstDash val="solid"/>
-                      <a:round/>
-                      <a:headEnd type="none" w="med" len="med"/>
-                      <a:tailEnd type="none" w="med" len="med"/>
-                    </a:lnT>
-                    <a:lnB w="9525" cap="flat" cmpd="sng" algn="ctr">
-                      <a:solidFill>
-                        <a:srgbClr val="333333"/>
-                      </a:solidFill>
-                      <a:prstDash val="solid"/>
-                      <a:round/>
-                      <a:headEnd type="none" w="med" len="med"/>
-                      <a:tailEnd type="none" w="med" len="med"/>
-                    </a:lnB>
-                  </a:tcPr>
-                </a:tc>
-                <a:tc>
-                  <a:txBody>
-                    <a:bodyPr/>
-                    <a:lstStyle/>
-                    <a:p>
-                      <a:pPr algn="l" indent="0" marL="0">
-                        <a:buNone/>
-                      </a:pPr>
-                      <a:r>
-                        <a:rPr lang="en-US" sz="1100" dirty="0">
-                          <a:solidFill>
-                            <a:srgbClr val="1A1A1A"/>
-                          </a:solidFill>
-                          <a:latin typeface="Times New Roman" pitchFamily="34" charset="0"/>
-                          <a:ea typeface="Times New Roman" pitchFamily="34" charset="-122"/>
-                          <a:cs typeface="Times New Roman" pitchFamily="34" charset="-120"/>
-                        </a:rPr>
-                        <a:t>Spread across repeats TBD points</a:t>
-                      </a:r>
-                      <a:endParaRPr lang="en-US" sz="1100" dirty="0">
-                        <a:latin typeface="Times New Roman" charset="0"/>
-                        <a:ea typeface="Times New Roman" charset="0"/>
-                        <a:cs typeface="Times New Roman" charset="0"/>
-                      </a:endParaRPr>
-                    </a:p>
-                  </a:txBody>
-                  <a:tcPr marL="64008" marR="64008" marT="36576" marB="36576" anchor="t">
-                    <a:lnL w="9525" cap="flat" cmpd="sng" algn="ctr">
-                      <a:solidFill>
-                        <a:srgbClr val="333333"/>
-                      </a:solidFill>
-                      <a:prstDash val="solid"/>
-                      <a:round/>
-                      <a:headEnd type="none" w="med" len="med"/>
-                      <a:tailEnd type="none" w="med" len="med"/>
-                    </a:lnL>
-                    <a:lnR w="9525" cap="flat" cmpd="sng" algn="ctr">
-                      <a:solidFill>
-                        <a:srgbClr val="333333"/>
-                      </a:solidFill>
-                      <a:prstDash val="solid"/>
-                      <a:round/>
-                      <a:headEnd type="none" w="med" len="med"/>
-                      <a:tailEnd type="none" w="med" len="med"/>
-                    </a:lnR>
-                    <a:lnT w="9525" cap="flat" cmpd="sng" algn="ctr">
-                      <a:solidFill>
-                        <a:srgbClr val="333333"/>
-                      </a:solidFill>
-                      <a:prstDash val="solid"/>
-                      <a:round/>
-                      <a:headEnd type="none" w="med" len="med"/>
-                      <a:tailEnd type="none" w="med" len="med"/>
-                    </a:lnT>
-                    <a:lnB w="9525" cap="flat" cmpd="sng" algn="ctr">
-                      <a:solidFill>
-                        <a:srgbClr val="333333"/>
-                      </a:solidFill>
-                      <a:prstDash val="solid"/>
-                      <a:round/>
-                      <a:headEnd type="none" w="med" len="med"/>
-                      <a:tailEnd type="none" w="med" len="med"/>
-                    </a:lnB>
-                  </a:tcPr>
-                </a:tc>
-                <a:tc>
-                  <a:txBody>
-                    <a:bodyPr/>
-                    <a:lstStyle/>
-                    <a:p>
-                      <a:pPr algn="l" indent="0" marL="0">
-                        <a:buNone/>
-                      </a:pPr>
-                      <a:r>
-                        <a:rPr lang="en-US" sz="1100" dirty="0">
-                          <a:solidFill>
-                            <a:srgbClr val="1A1A1A"/>
-                          </a:solidFill>
-                          <a:latin typeface="Times New Roman" pitchFamily="34" charset="0"/>
-                          <a:ea typeface="Times New Roman" pitchFamily="34" charset="-122"/>
-                          <a:cs typeface="Times New Roman" pitchFamily="34" charset="-120"/>
-                        </a:rPr>
-                        <a:t>Shows how much the score moves with the same settings</a:t>
-                      </a:r>
-                      <a:endParaRPr lang="en-US" sz="1100" dirty="0">
-                        <a:latin typeface="Times New Roman" charset="0"/>
-                        <a:ea typeface="Times New Roman" charset="0"/>
-                        <a:cs typeface="Times New Roman" charset="0"/>
-                      </a:endParaRPr>
-                    </a:p>
-                  </a:txBody>
-                  <a:tcPr marL="64008" marR="64008" marT="36576" marB="36576" anchor="t">
-                    <a:lnL w="9525" cap="flat" cmpd="sng" algn="ctr">
-                      <a:solidFill>
-                        <a:srgbClr val="333333"/>
-                      </a:solidFill>
-                      <a:prstDash val="solid"/>
-                      <a:round/>
-                      <a:headEnd type="none" w="med" len="med"/>
-                      <a:tailEnd type="none" w="med" len="med"/>
-                    </a:lnL>
-                    <a:lnR w="9525" cap="flat" cmpd="sng" algn="ctr">
-                      <a:solidFill>
-                        <a:srgbClr val="333333"/>
-                      </a:solidFill>
-                      <a:prstDash val="solid"/>
-                      <a:round/>
-                      <a:headEnd type="none" w="med" len="med"/>
-                      <a:tailEnd type="none" w="med" len="med"/>
-                    </a:lnR>
-                    <a:lnT w="9525" cap="flat" cmpd="sng" algn="ctr">
-                      <a:solidFill>
-                        <a:srgbClr val="333333"/>
-                      </a:solidFill>
-                      <a:prstDash val="solid"/>
-                      <a:round/>
-                      <a:headEnd type="none" w="med" len="med"/>
-                      <a:tailEnd type="none" w="med" len="med"/>
-                    </a:lnT>
-                    <a:lnB w="9525" cap="flat" cmpd="sng" algn="ctr">
-                      <a:solidFill>
-                        <a:srgbClr val="333333"/>
-                      </a:solidFill>
-                      <a:prstDash val="solid"/>
-                      <a:round/>
-                      <a:headEnd type="none" w="med" len="med"/>
-                      <a:tailEnd type="none" w="med" len="med"/>
-                    </a:lnB>
-                  </a:tcPr>
-                </a:tc>
-              </a:tr>
-              <a:tr h="0">
-                <a:tc>
-                  <a:txBody>
-                    <a:bodyPr/>
-                    <a:lstStyle/>
-                    <a:p>
-                      <a:pPr algn="l" indent="0" marL="0">
-                        <a:buNone/>
-                      </a:pPr>
-                      <a:r>
-                        <a:rPr lang="en-US" sz="1100" b="1" dirty="0">
-                          <a:solidFill>
-                            <a:srgbClr val="1A1A1A"/>
-                          </a:solidFill>
-                          <a:latin typeface="Times New Roman" pitchFamily="34" charset="0"/>
-                          <a:ea typeface="Times New Roman" pitchFamily="34" charset="-122"/>
-                          <a:cs typeface="Times New Roman" pitchFamily="34" charset="-120"/>
-                        </a:rPr>
-                        <a:t>Retrieval latency and context size at benchmark scale</a:t>
-                      </a:r>
-                      <a:endParaRPr lang="en-US" sz="1100" dirty="0">
-                        <a:latin typeface="Times New Roman" charset="0"/>
-                        <a:ea typeface="Times New Roman" charset="0"/>
-                        <a:cs typeface="Times New Roman" charset="0"/>
-                      </a:endParaRPr>
-                    </a:p>
-                  </a:txBody>
-                  <a:tcPr marL="64008" marR="64008" marT="36576" marB="36576" anchor="t">
-                    <a:lnL w="9525" cap="flat" cmpd="sng" algn="ctr">
-                      <a:solidFill>
-                        <a:srgbClr val="333333"/>
-                      </a:solidFill>
-                      <a:prstDash val="solid"/>
-                      <a:round/>
-                      <a:headEnd type="none" w="med" len="med"/>
-                      <a:tailEnd type="none" w="med" len="med"/>
-                    </a:lnL>
-                    <a:lnR w="9525" cap="flat" cmpd="sng" algn="ctr">
-                      <a:solidFill>
-                        <a:srgbClr val="333333"/>
-                      </a:solidFill>
-                      <a:prstDash val="solid"/>
-                      <a:round/>
-                      <a:headEnd type="none" w="med" len="med"/>
-                      <a:tailEnd type="none" w="med" len="med"/>
-                    </a:lnR>
-                    <a:lnT w="9525" cap="flat" cmpd="sng" algn="ctr">
-                      <a:solidFill>
-                        <a:srgbClr val="333333"/>
-                      </a:solidFill>
-                      <a:prstDash val="solid"/>
-                      <a:round/>
-                      <a:headEnd type="none" w="med" len="med"/>
-                      <a:tailEnd type="none" w="med" len="med"/>
-                    </a:lnT>
-                    <a:lnB w="9525" cap="flat" cmpd="sng" algn="ctr">
-                      <a:solidFill>
-                        <a:srgbClr val="333333"/>
-                      </a:solidFill>
-                      <a:prstDash val="solid"/>
-                      <a:round/>
-                      <a:headEnd type="none" w="med" len="med"/>
-                      <a:tailEnd type="none" w="med" len="med"/>
-                    </a:lnB>
-                  </a:tcPr>
-                </a:tc>
-                <a:tc>
-                  <a:txBody>
-                    <a:bodyPr/>
-                    <a:lstStyle/>
-                    <a:p>
-                      <a:pPr algn="l" indent="0" marL="0">
-                        <a:buNone/>
-                      </a:pPr>
-                      <a:r>
-                        <a:rPr lang="en-US" sz="1100" dirty="0">
-                          <a:solidFill>
-                            <a:srgbClr val="1A1A1A"/>
-                          </a:solidFill>
-                          <a:latin typeface="Times New Roman" pitchFamily="34" charset="0"/>
-                          <a:ea typeface="Times New Roman" pitchFamily="34" charset="-122"/>
-                          <a:cs typeface="Times New Roman" pitchFamily="34" charset="-120"/>
-                        </a:rPr>
-                        <a:t>p50 TBD ms, p95 TBD ms. Median context TBD tokens, p95 TBD tokens</a:t>
-                      </a:r>
-                      <a:endParaRPr lang="en-US" sz="1100" dirty="0">
-                        <a:latin typeface="Times New Roman" charset="0"/>
-                        <a:ea typeface="Times New Roman" charset="0"/>
-                        <a:cs typeface="Times New Roman" charset="0"/>
-                      </a:endParaRPr>
-                    </a:p>
-                  </a:txBody>
-                  <a:tcPr marL="64008" marR="64008" marT="36576" marB="36576" anchor="t">
-                    <a:lnL w="9525" cap="flat" cmpd="sng" algn="ctr">
-                      <a:solidFill>
-                        <a:srgbClr val="333333"/>
-                      </a:solidFill>
-                      <a:prstDash val="solid"/>
-                      <a:round/>
-                      <a:headEnd type="none" w="med" len="med"/>
-                      <a:tailEnd type="none" w="med" len="med"/>
-                    </a:lnL>
-                    <a:lnR w="9525" cap="flat" cmpd="sng" algn="ctr">
-                      <a:solidFill>
-                        <a:srgbClr val="333333"/>
-                      </a:solidFill>
-                      <a:prstDash val="solid"/>
-                      <a:round/>
-                      <a:headEnd type="none" w="med" len="med"/>
-                      <a:tailEnd type="none" w="med" len="med"/>
-                    </a:lnR>
-                    <a:lnT w="9525" cap="flat" cmpd="sng" algn="ctr">
-                      <a:solidFill>
-                        <a:srgbClr val="333333"/>
-                      </a:solidFill>
-                      <a:prstDash val="solid"/>
-                      <a:round/>
-                      <a:headEnd type="none" w="med" len="med"/>
-                      <a:tailEnd type="none" w="med" len="med"/>
-                    </a:lnT>
-                    <a:lnB w="9525" cap="flat" cmpd="sng" algn="ctr">
-                      <a:solidFill>
-                        <a:srgbClr val="333333"/>
-                      </a:solidFill>
-                      <a:prstDash val="solid"/>
-                      <a:round/>
-                      <a:headEnd type="none" w="med" len="med"/>
-                      <a:tailEnd type="none" w="med" len="med"/>
-                    </a:lnB>
-                  </a:tcPr>
-                </a:tc>
-                <a:tc>
-                  <a:txBody>
-                    <a:bodyPr/>
-                    <a:lstStyle/>
-                    <a:p>
-                      <a:pPr algn="l" indent="0" marL="0">
-                        <a:buNone/>
-                      </a:pPr>
-                      <a:r>
-                        <a:rPr lang="en-US" sz="1100" dirty="0">
-                          <a:solidFill>
-                            <a:srgbClr val="1A1A1A"/>
-                          </a:solidFill>
-                          <a:latin typeface="Times New Roman" pitchFamily="34" charset="0"/>
-                          <a:ea typeface="Times New Roman" pitchFamily="34" charset="-122"/>
-                          <a:cs typeface="Times New Roman" pitchFamily="34" charset="-120"/>
-                        </a:rPr>
-                        <a:t>Compare with slide 15: p95 72 ms and 1,942 tokens on a 323-fact namespace</a:t>
-                      </a:r>
-                      <a:endParaRPr lang="en-US" sz="1100" dirty="0">
-                        <a:latin typeface="Times New Roman" charset="0"/>
-                        <a:ea typeface="Times New Roman" charset="0"/>
-                        <a:cs typeface="Times New Roman" charset="0"/>
-                      </a:endParaRPr>
-                    </a:p>
-                  </a:txBody>
-                  <a:tcPr marL="64008" marR="64008" marT="36576" marB="36576" anchor="t">
-                    <a:lnL w="9525" cap="flat" cmpd="sng" algn="ctr">
-                      <a:solidFill>
-                        <a:srgbClr val="333333"/>
-                      </a:solidFill>
-                      <a:prstDash val="solid"/>
-                      <a:round/>
-                      <a:headEnd type="none" w="med" len="med"/>
-                      <a:tailEnd type="none" w="med" len="med"/>
-                    </a:lnL>
-                    <a:lnR w="9525" cap="flat" cmpd="sng" algn="ctr">
-                      <a:solidFill>
-                        <a:srgbClr val="333333"/>
-                      </a:solidFill>
-                      <a:prstDash val="solid"/>
-                      <a:round/>
-                      <a:headEnd type="none" w="med" len="med"/>
-                      <a:tailEnd type="none" w="med" len="med"/>
-                    </a:lnR>
-                    <a:lnT w="9525" cap="flat" cmpd="sng" algn="ctr">
-                      <a:solidFill>
-                        <a:srgbClr val="333333"/>
-                      </a:solidFill>
-                      <a:prstDash val="solid"/>
-                      <a:round/>
-                      <a:headEnd type="none" w="med" len="med"/>
-                      <a:tailEnd type="none" w="med" len="med"/>
-                    </a:lnT>
-                    <a:lnB w="9525" cap="flat" cmpd="sng" algn="ctr">
-                      <a:solidFill>
-                        <a:srgbClr val="333333"/>
-                      </a:solidFill>
-                      <a:prstDash val="solid"/>
-                      <a:round/>
-                      <a:headEnd type="none" w="med" len="med"/>
-                      <a:tailEnd type="none" w="med" len="med"/>
-                    </a:lnB>
-                  </a:tcPr>
-                </a:tc>
-              </a:tr>
-              <a:tr h="0">
-                <a:tc>
-                  <a:txBody>
-                    <a:bodyPr/>
-                    <a:lstStyle/>
-                    <a:p>
-                      <a:pPr algn="l" indent="0" marL="0">
-                        <a:buNone/>
-                      </a:pPr>
-                      <a:r>
-                        <a:rPr lang="en-US" sz="1100" b="1" dirty="0">
-                          <a:solidFill>
-                            <a:srgbClr val="1A1A1A"/>
-                          </a:solidFill>
-                          <a:latin typeface="Times New Roman" pitchFamily="34" charset="0"/>
-                          <a:ea typeface="Times New Roman" pitchFamily="34" charset="-122"/>
-                          <a:cs typeface="Times New Roman" pitchFamily="34" charset="-120"/>
-                        </a:rPr>
-                        <a:t>Scale check, about 10,000 graph nodes</a:t>
-                      </a:r>
-                      <a:endParaRPr lang="en-US" sz="1100" dirty="0">
-                        <a:latin typeface="Times New Roman" charset="0"/>
-                        <a:ea typeface="Times New Roman" charset="0"/>
-                        <a:cs typeface="Times New Roman" charset="0"/>
-                      </a:endParaRPr>
-                    </a:p>
-                  </a:txBody>
-                  <a:tcPr marL="64008" marR="64008" marT="36576" marB="36576" anchor="t">
-                    <a:lnL w="9525" cap="flat" cmpd="sng" algn="ctr">
-                      <a:solidFill>
-                        <a:srgbClr val="333333"/>
-                      </a:solidFill>
-                      <a:prstDash val="solid"/>
-                      <a:round/>
-                      <a:headEnd type="none" w="med" len="med"/>
-                      <a:tailEnd type="none" w="med" len="med"/>
-                    </a:lnL>
-                    <a:lnR w="9525" cap="flat" cmpd="sng" algn="ctr">
-                      <a:solidFill>
-                        <a:srgbClr val="333333"/>
-                      </a:solidFill>
-                      <a:prstDash val="solid"/>
-                      <a:round/>
-                      <a:headEnd type="none" w="med" len="med"/>
-                      <a:tailEnd type="none" w="med" len="med"/>
-                    </a:lnR>
-                    <a:lnT w="9525" cap="flat" cmpd="sng" algn="ctr">
-                      <a:solidFill>
-                        <a:srgbClr val="333333"/>
-                      </a:solidFill>
-                      <a:prstDash val="solid"/>
-                      <a:round/>
-                      <a:headEnd type="none" w="med" len="med"/>
-                      <a:tailEnd type="none" w="med" len="med"/>
-                    </a:lnT>
-                    <a:lnB w="9525" cap="flat" cmpd="sng" algn="ctr">
-                      <a:solidFill>
-                        <a:srgbClr val="333333"/>
-                      </a:solidFill>
-                      <a:prstDash val="solid"/>
-                      <a:round/>
-                      <a:headEnd type="none" w="med" len="med"/>
-                      <a:tailEnd type="none" w="med" len="med"/>
-                    </a:lnB>
-                  </a:tcPr>
-                </a:tc>
-                <a:tc>
-                  <a:txBody>
-                    <a:bodyPr/>
-                    <a:lstStyle/>
-                    <a:p>
-                      <a:pPr algn="l" indent="0" marL="0">
-                        <a:buNone/>
-                      </a:pPr>
-                      <a:r>
-                        <a:rPr lang="en-US" sz="1100" dirty="0">
-                          <a:solidFill>
-                            <a:srgbClr val="1A1A1A"/>
-                          </a:solidFill>
-                          <a:latin typeface="Times New Roman" pitchFamily="34" charset="0"/>
-                          <a:ea typeface="Times New Roman" pitchFamily="34" charset="-122"/>
-                          <a:cs typeface="Times New Roman" pitchFamily="34" charset="-120"/>
-                        </a:rPr>
-                        <a:t>Nodes TBD. Recall p95 TBD ms. Correct answers TBD of TBD. Graph page renders in TBD s</a:t>
-                      </a:r>
-                      <a:endParaRPr lang="en-US" sz="1100" dirty="0">
-                        <a:latin typeface="Times New Roman" charset="0"/>
-                        <a:ea typeface="Times New Roman" charset="0"/>
-                        <a:cs typeface="Times New Roman" charset="0"/>
-                      </a:endParaRPr>
-                    </a:p>
-                  </a:txBody>
-                  <a:tcPr marL="64008" marR="64008" marT="36576" marB="36576" anchor="t">
-                    <a:lnL w="9525" cap="flat" cmpd="sng" algn="ctr">
-                      <a:solidFill>
-                        <a:srgbClr val="333333"/>
-                      </a:solidFill>
-                      <a:prstDash val="solid"/>
-                      <a:round/>
-                      <a:headEnd type="none" w="med" len="med"/>
-                      <a:tailEnd type="none" w="med" len="med"/>
-                    </a:lnL>
-                    <a:lnR w="9525" cap="flat" cmpd="sng" algn="ctr">
-                      <a:solidFill>
-                        <a:srgbClr val="333333"/>
-                      </a:solidFill>
-                      <a:prstDash val="solid"/>
-                      <a:round/>
-                      <a:headEnd type="none" w="med" len="med"/>
-                      <a:tailEnd type="none" w="med" len="med"/>
-                    </a:lnR>
-                    <a:lnT w="9525" cap="flat" cmpd="sng" algn="ctr">
-                      <a:solidFill>
-                        <a:srgbClr val="333333"/>
-                      </a:solidFill>
-                      <a:prstDash val="solid"/>
-                      <a:round/>
-                      <a:headEnd type="none" w="med" len="med"/>
-                      <a:tailEnd type="none" w="med" len="med"/>
-                    </a:lnT>
-                    <a:lnB w="9525" cap="flat" cmpd="sng" algn="ctr">
-                      <a:solidFill>
-                        <a:srgbClr val="333333"/>
-                      </a:solidFill>
-                      <a:prstDash val="solid"/>
-                      <a:round/>
-                      <a:headEnd type="none" w="med" len="med"/>
-                      <a:tailEnd type="none" w="med" len="med"/>
-                    </a:lnB>
-                  </a:tcPr>
-                </a:tc>
-                <a:tc>
-                  <a:txBody>
-                    <a:bodyPr/>
-                    <a:lstStyle/>
-                    <a:p>
-                      <a:pPr algn="l" indent="0" marL="0">
-                        <a:buNone/>
-                      </a:pPr>
-                      <a:r>
-                        <a:rPr lang="en-US" sz="1100" dirty="0">
-                          <a:solidFill>
-                            <a:srgbClr val="1A1A1A"/>
-                          </a:solidFill>
-                          <a:latin typeface="Times New Roman" pitchFamily="34" charset="0"/>
-                          <a:ea typeface="Times New Roman" pitchFamily="34" charset="-122"/>
-                          <a:cs typeface="Times New Roman" pitchFamily="34" charset="-120"/>
-                        </a:rPr>
-                        <a:t>Machine, model and embedding settings written next to the number</a:t>
-                      </a:r>
-                      <a:endParaRPr lang="en-US" sz="1100" dirty="0">
-                        <a:latin typeface="Times New Roman" charset="0"/>
-                        <a:ea typeface="Times New Roman" charset="0"/>
-                        <a:cs typeface="Times New Roman" charset="0"/>
-                      </a:endParaRPr>
-                    </a:p>
-                  </a:txBody>
-                  <a:tcPr marL="64008" marR="64008" marT="36576" marB="36576" anchor="t">
-                    <a:lnL w="9525" cap="flat" cmpd="sng" algn="ctr">
-                      <a:solidFill>
-                        <a:srgbClr val="333333"/>
-                      </a:solidFill>
-                      <a:prstDash val="solid"/>
-                      <a:round/>
-                      <a:headEnd type="none" w="med" len="med"/>
-                      <a:tailEnd type="none" w="med" len="med"/>
-                    </a:lnL>
-                    <a:lnR w="9525" cap="flat" cmpd="sng" algn="ctr">
-                      <a:solidFill>
-                        <a:srgbClr val="333333"/>
-                      </a:solidFill>
-                      <a:prstDash val="solid"/>
-                      <a:round/>
-                      <a:headEnd type="none" w="med" len="med"/>
-                      <a:tailEnd type="none" w="med" len="med"/>
-                    </a:lnR>
-                    <a:lnT w="9525" cap="flat" cmpd="sng" algn="ctr">
-                      <a:solidFill>
-                        <a:srgbClr val="333333"/>
-                      </a:solidFill>
-                      <a:prstDash val="solid"/>
-                      <a:round/>
-                      <a:headEnd type="none" w="med" len="med"/>
-                      <a:tailEnd type="none" w="med" len="med"/>
-                    </a:lnT>
-                    <a:lnB w="9525" cap="flat" cmpd="sng" algn="ctr">
-                      <a:solidFill>
-                        <a:srgbClr val="333333"/>
-                      </a:solidFill>
-                      <a:prstDash val="solid"/>
-                      <a:round/>
-                      <a:headEnd type="none" w="med" len="med"/>
-                      <a:tailEnd type="none" w="med" len="med"/>
-                    </a:lnB>
-                  </a:tcPr>
-                </a:tc>
-              </a:tr>
-            </a:tbl>
-          </a:graphicData>
-        </a:graphic>
-      </p:graphicFrame>
-      <p:sp>
-        <p:nvSpPr>
-          <p:cNvPr id="4" name="Slide Number Placeholder 0"/>
-          <p:cNvSpPr>
-            <a:spLocks noGrp="1"/>
-          </p:cNvSpPr>
-          <p:nvPr>
-            <p:ph type="sldNum" sz="quarter" idx="4294967295"/>
-          </p:nvPr>
-        </p:nvSpPr>
-        <p:spPr>
-          <a:xfrm>
-            <a:off x="10865815" y="384048"/>
-            <a:ext cx="731520" cy="457200"/>
-          </a:xfrm>
-          <a:prstGeom prst="rect">
-            <a:avLst/>
-          </a:prstGeom>
-          <a:extLst>
-            <a:ext uri="{C572A759-6A51-4108-AA02-DFA0A04FC94B}">
-              <ma14:wrappingTextBoxFlag xmlns:ma14="http://schemas.microsoft.com/office/mac/drawingml/2011/main" val="0"/>
-            </a:ext>
-          </a:extLst>
-        </p:spPr>
-        <p:txBody>
-          <a:bodyPr/>
-          <a:lstStyle>
-            <a:lvl1pPr>
-              <a:defRPr sz="1600">
-                <a:solidFill>
-                  <a:srgbClr val="000000"/>
-                </a:solidFill>
-                <a:latin typeface="Times New Roman"/>
-                <a:ea typeface="Times New Roman"/>
-                <a:cs typeface="Times New Roman"/>
-              </a:defRPr>
-            </a:lvl1pPr>
-          </a:lstStyle>
-          <a:p>
-            <a:pPr algn="r"/>
-            <a:fld id="{F7021451-1387-4CA6-816F-3879F97B5CBC}" type="slidenum">
-              <a:rPr b="0" lang="en-US"/>
-              <a:t>16</a:t>
-            </a:fld>
-            <a:endParaRPr lang="en-US"/>
-          </a:p>
-        </p:txBody>
-      </p:sp>
-    </p:spTree>
-  </p:cSld>
-  <p:clrMapOvr>
-    <a:masterClrMapping/>
-  </p:clrMapOvr>
-</p:sld>
-</file>
-
-<file path=ppt/slides/slide17.xml><?xml version="1.0" encoding="utf-8"?>
 <p:sld xmlns:a="http://schemas.openxmlformats.org/drawingml/2006/main" xmlns:r="http://schemas.openxmlformats.org/officeDocument/2006/relationships" xmlns:p="http://schemas.openxmlformats.org/presentationml/2006/main">
   <p:cSld name="Slide 15">
     <p:spTree>
@@ -17585,7 +15290,7 @@
                           <a:ea typeface="Times New Roman" pitchFamily="34" charset="-122"/>
                           <a:cs typeface="Times New Roman" pitchFamily="34" charset="-120"/>
                         </a:rPr>
-                        <a:t>Shorter context, LongMemEval-S recall, graph ablation, a rule for short prompts. A derives writer and a move off the deprecated Neo4j HTTP endpoint: Status to confirm</a:t>
+                        <a:t>Shorter context, graph ablation, a rule for short prompts. A derives writer and a move off the deprecated Neo4j HTTP endpoint: Status to confirm</a:t>
                       </a:r>
                       <a:endParaRPr lang="en-US" sz="1200" dirty="0">
                         <a:latin typeface="Times New Roman" charset="0"/>
@@ -17782,7 +15487,7 @@
                           <a:ea typeface="Times New Roman" pitchFamily="34" charset="-122"/>
                           <a:cs typeface="Times New Roman" pitchFamily="34" charset="-120"/>
                         </a:rPr>
-                        <a:t>Retries, heartbeats, consolidation, traces, /healthz, /metrics, runner</a:t>
+                        <a:t>Retries, heartbeats, consolidation, traces, /healthz, /metrics</a:t>
                       </a:r>
                       <a:endParaRPr lang="en-US" sz="1200" dirty="0">
                         <a:latin typeface="Times New Roman" charset="0"/>
@@ -17847,7 +15552,7 @@
                           <a:ea typeface="Times New Roman" pitchFamily="34" charset="-122"/>
                           <a:cs typeface="Times New Roman" pitchFamily="34" charset="-120"/>
                         </a:rPr>
-                        <a:t>src/worker.rs, benchmark/run.py, 5 protocol tests</a:t>
+                        <a:t>src/worker.rs</a:t>
                       </a:r>
                       <a:endParaRPr lang="en-US" sz="1200" dirty="0">
                         <a:latin typeface="Times New Roman" charset="0"/>
@@ -17912,7 +15617,7 @@
                           <a:ea typeface="Times New Roman" pitchFamily="34" charset="-122"/>
                           <a:cs typeface="Times New Roman" pitchFamily="34" charset="-120"/>
                         </a:rPr>
-                        <a:t>Finish a first LongMemEval-S run, add p95 latency to the runner, run a human audit (Planned). Decay, re-embedding, backup: none exists</a:t>
+                        <a:t>Human audit (Planned). Decay, re-embedding, backup: none exists</a:t>
                       </a:r>
                       <a:endParaRPr lang="en-US" sz="1200" dirty="0">
                         <a:latin typeface="Times New Roman" charset="0"/>
@@ -17977,7 +15682,7 @@
                           <a:ea typeface="Times New Roman" pitchFamily="34" charset="-122"/>
                           <a:cs typeface="Times New Roman" pitchFamily="34" charset="-120"/>
                         </a:rPr>
-                        <a:t>Completed. Benchmark run: In progress</a:t>
+                        <a:t>Completed</a:t>
                       </a:r>
                       <a:endParaRPr lang="en-US" sz="1200" dirty="0">
                         <a:latin typeface="Times New Roman" charset="0"/>
@@ -18566,7 +16271,7 @@
                           <a:ea typeface="Times New Roman" pitchFamily="34" charset="-122"/>
                           <a:cs typeface="Times New Roman" pitchFamily="34" charset="-120"/>
                         </a:rPr>
-                        <a:t>Coverage fell, relative dates weak. Live check and benchmark run: In progress</a:t>
+                        <a:t>Coverage fell, relative dates weak. Live smoke check passed</a:t>
                       </a:r>
                       <a:endParaRPr lang="en-US" sz="1200" dirty="0">
                         <a:latin typeface="Times New Roman" charset="0"/>
@@ -19053,7 +16758,7 @@
             <a:pPr algn="r"/>
             <a:fld id="{F7021451-1387-4CA6-816F-3879F97B5CBC}" type="slidenum">
               <a:rPr b="0" lang="en-US"/>
-              <a:t>17</a:t>
+              <a:t>16</a:t>
             </a:fld>
             <a:endParaRPr lang="en-US"/>
           </a:p>
@@ -19067,7 +16772,7 @@
 </p:sld>
 </file>
 
-<file path=ppt/slides/slide18.xml><?xml version="1.0" encoding="utf-8"?>
+<file path=ppt/slides/slide17.xml><?xml version="1.0" encoding="utf-8"?>
 <p:sld xmlns:a="http://schemas.openxmlformats.org/drawingml/2006/main" xmlns:r="http://schemas.openxmlformats.org/officeDocument/2006/relationships" xmlns:p="http://schemas.openxmlformats.org/presentationml/2006/main">
   <p:cSld name="Slide 16">
     <p:spTree>
@@ -19511,7 +17216,7 @@
             <a:pPr algn="r"/>
             <a:fld id="{F7021451-1387-4CA6-816F-3879F97B5CBC}" type="slidenum">
               <a:rPr b="0" lang="en-US"/>
-              <a:t>18</a:t>
+              <a:t>17</a:t>
             </a:fld>
             <a:endParaRPr lang="en-US"/>
           </a:p>
@@ -24895,268 +22600,6 @@
                           <a:ea typeface="Times New Roman" pitchFamily="34" charset="-122"/>
                           <a:cs typeface="Times New Roman" pitchFamily="34" charset="-120"/>
                         </a:rPr>
-                        <a:t>Retrieval gain</a:t>
-                      </a:r>
-                      <a:endParaRPr lang="en-US" sz="1250" dirty="0">
-                        <a:latin typeface="Times New Roman" charset="0"/>
-                        <a:ea typeface="Times New Roman" charset="0"/>
-                        <a:cs typeface="Times New Roman" charset="0"/>
-                      </a:endParaRPr>
-                    </a:p>
-                  </a:txBody>
-                  <a:tcPr marL="64008" marR="64008" marT="36576" marB="36576" anchor="t">
-                    <a:lnL w="9525" cap="flat" cmpd="sng" algn="ctr">
-                      <a:solidFill>
-                        <a:srgbClr val="333333"/>
-                      </a:solidFill>
-                      <a:prstDash val="solid"/>
-                      <a:round/>
-                      <a:headEnd type="none" w="med" len="med"/>
-                      <a:tailEnd type="none" w="med" len="med"/>
-                    </a:lnL>
-                    <a:lnR w="9525" cap="flat" cmpd="sng" algn="ctr">
-                      <a:solidFill>
-                        <a:srgbClr val="333333"/>
-                      </a:solidFill>
-                      <a:prstDash val="solid"/>
-                      <a:round/>
-                      <a:headEnd type="none" w="med" len="med"/>
-                      <a:tailEnd type="none" w="med" len="med"/>
-                    </a:lnR>
-                    <a:lnT w="9525" cap="flat" cmpd="sng" algn="ctr">
-                      <a:solidFill>
-                        <a:srgbClr val="333333"/>
-                      </a:solidFill>
-                      <a:prstDash val="solid"/>
-                      <a:round/>
-                      <a:headEnd type="none" w="med" len="med"/>
-                      <a:tailEnd type="none" w="med" len="med"/>
-                    </a:lnT>
-                    <a:lnB w="9525" cap="flat" cmpd="sng" algn="ctr">
-                      <a:solidFill>
-                        <a:srgbClr val="333333"/>
-                      </a:solidFill>
-                      <a:prstDash val="solid"/>
-                      <a:round/>
-                      <a:headEnd type="none" w="med" len="med"/>
-                      <a:tailEnd type="none" w="med" len="med"/>
-                    </a:lnB>
-                  </a:tcPr>
-                </a:tc>
-                <a:tc>
-                  <a:txBody>
-                    <a:bodyPr/>
-                    <a:lstStyle/>
-                    <a:p>
-                      <a:pPr algn="l" indent="0" marL="0">
-                        <a:buNone/>
-                      </a:pPr>
-                      <a:r>
-                        <a:rPr lang="en-US" sz="1250" dirty="0">
-                          <a:solidFill>
-                            <a:srgbClr val="1A1A1A"/>
-                          </a:solidFill>
-                          <a:latin typeface="Times New Roman" pitchFamily="34" charset="0"/>
-                          <a:ea typeface="Times New Roman" pitchFamily="34" charset="-122"/>
-                          <a:cs typeface="Times New Roman" pitchFamily="34" charset="-120"/>
-                        </a:rPr>
-                        <a:t>Match a pgvector-only baseline overall and beat it by 5 points on knowledge-update and temporal questions.</a:t>
-                      </a:r>
-                      <a:endParaRPr lang="en-US" sz="1250" dirty="0">
-                        <a:latin typeface="Times New Roman" charset="0"/>
-                        <a:ea typeface="Times New Roman" charset="0"/>
-                        <a:cs typeface="Times New Roman" charset="0"/>
-                      </a:endParaRPr>
-                    </a:p>
-                  </a:txBody>
-                  <a:tcPr marL="64008" marR="64008" marT="36576" marB="36576" anchor="t">
-                    <a:lnL w="9525" cap="flat" cmpd="sng" algn="ctr">
-                      <a:solidFill>
-                        <a:srgbClr val="333333"/>
-                      </a:solidFill>
-                      <a:prstDash val="solid"/>
-                      <a:round/>
-                      <a:headEnd type="none" w="med" len="med"/>
-                      <a:tailEnd type="none" w="med" len="med"/>
-                    </a:lnL>
-                    <a:lnR w="9525" cap="flat" cmpd="sng" algn="ctr">
-                      <a:solidFill>
-                        <a:srgbClr val="333333"/>
-                      </a:solidFill>
-                      <a:prstDash val="solid"/>
-                      <a:round/>
-                      <a:headEnd type="none" w="med" len="med"/>
-                      <a:tailEnd type="none" w="med" len="med"/>
-                    </a:lnR>
-                    <a:lnT w="9525" cap="flat" cmpd="sng" algn="ctr">
-                      <a:solidFill>
-                        <a:srgbClr val="333333"/>
-                      </a:solidFill>
-                      <a:prstDash val="solid"/>
-                      <a:round/>
-                      <a:headEnd type="none" w="med" len="med"/>
-                      <a:tailEnd type="none" w="med" len="med"/>
-                    </a:lnT>
-                    <a:lnB w="9525" cap="flat" cmpd="sng" algn="ctr">
-                      <a:solidFill>
-                        <a:srgbClr val="333333"/>
-                      </a:solidFill>
-                      <a:prstDash val="solid"/>
-                      <a:round/>
-                      <a:headEnd type="none" w="med" len="med"/>
-                      <a:tailEnd type="none" w="med" len="med"/>
-                    </a:lnB>
-                  </a:tcPr>
-                </a:tc>
-                <a:tc>
-                  <a:txBody>
-                    <a:bodyPr/>
-                    <a:lstStyle/>
-                    <a:p>
-                      <a:pPr algn="l" indent="0" marL="0">
-                        <a:buNone/>
-                      </a:pPr>
-                      <a:r>
-                        <a:rPr lang="en-US" sz="1250" dirty="0">
-                          <a:solidFill>
-                            <a:srgbClr val="1A1A1A"/>
-                          </a:solidFill>
-                          <a:latin typeface="Times New Roman" pitchFamily="34" charset="0"/>
-                          <a:ea typeface="Times New Roman" pitchFamily="34" charset="-122"/>
-                          <a:cs typeface="Times New Roman" pitchFamily="34" charset="-120"/>
-                        </a:rPr>
-                        <a:t>Not run. LongMemEval-S needs a 277 MB dataset and a lot of model use.</a:t>
-                      </a:r>
-                      <a:endParaRPr lang="en-US" sz="1250" dirty="0">
-                        <a:latin typeface="Times New Roman" charset="0"/>
-                        <a:ea typeface="Times New Roman" charset="0"/>
-                        <a:cs typeface="Times New Roman" charset="0"/>
-                      </a:endParaRPr>
-                    </a:p>
-                  </a:txBody>
-                  <a:tcPr marL="64008" marR="64008" marT="36576" marB="36576" anchor="t">
-                    <a:lnL w="9525" cap="flat" cmpd="sng" algn="ctr">
-                      <a:solidFill>
-                        <a:srgbClr val="333333"/>
-                      </a:solidFill>
-                      <a:prstDash val="solid"/>
-                      <a:round/>
-                      <a:headEnd type="none" w="med" len="med"/>
-                      <a:tailEnd type="none" w="med" len="med"/>
-                    </a:lnL>
-                    <a:lnR w="9525" cap="flat" cmpd="sng" algn="ctr">
-                      <a:solidFill>
-                        <a:srgbClr val="333333"/>
-                      </a:solidFill>
-                      <a:prstDash val="solid"/>
-                      <a:round/>
-                      <a:headEnd type="none" w="med" len="med"/>
-                      <a:tailEnd type="none" w="med" len="med"/>
-                    </a:lnR>
-                    <a:lnT w="9525" cap="flat" cmpd="sng" algn="ctr">
-                      <a:solidFill>
-                        <a:srgbClr val="333333"/>
-                      </a:solidFill>
-                      <a:prstDash val="solid"/>
-                      <a:round/>
-                      <a:headEnd type="none" w="med" len="med"/>
-                      <a:tailEnd type="none" w="med" len="med"/>
-                    </a:lnT>
-                    <a:lnB w="9525" cap="flat" cmpd="sng" algn="ctr">
-                      <a:solidFill>
-                        <a:srgbClr val="333333"/>
-                      </a:solidFill>
-                      <a:prstDash val="solid"/>
-                      <a:round/>
-                      <a:headEnd type="none" w="med" len="med"/>
-                      <a:tailEnd type="none" w="med" len="med"/>
-                    </a:lnB>
-                  </a:tcPr>
-                </a:tc>
-                <a:tc>
-                  <a:txBody>
-                    <a:bodyPr/>
-                    <a:lstStyle/>
-                    <a:p>
-                      <a:pPr algn="l" indent="0" marL="0">
-                        <a:buNone/>
-                      </a:pPr>
-                      <a:r>
-                        <a:rPr lang="en-US" sz="1250" b="1" dirty="0">
-                          <a:solidFill>
-                            <a:srgbClr val="1A1A1A"/>
-                          </a:solidFill>
-                          <a:latin typeface="Times New Roman" pitchFamily="34" charset="0"/>
-                          <a:ea typeface="Times New Roman" pitchFamily="34" charset="-122"/>
-                          <a:cs typeface="Times New Roman" pitchFamily="34" charset="-120"/>
-                        </a:rPr>
-                        <a:t>Planned</a:t>
-                      </a:r>
-                      <a:endParaRPr lang="en-US" sz="1250" dirty="0">
-                        <a:latin typeface="Times New Roman" charset="0"/>
-                        <a:ea typeface="Times New Roman" charset="0"/>
-                        <a:cs typeface="Times New Roman" charset="0"/>
-                      </a:endParaRPr>
-                    </a:p>
-                  </a:txBody>
-                  <a:tcPr marL="64008" marR="64008" marT="36576" marB="36576" anchor="t">
-                    <a:lnL w="9525" cap="flat" cmpd="sng" algn="ctr">
-                      <a:solidFill>
-                        <a:srgbClr val="333333"/>
-                      </a:solidFill>
-                      <a:prstDash val="solid"/>
-                      <a:round/>
-                      <a:headEnd type="none" w="med" len="med"/>
-                      <a:tailEnd type="none" w="med" len="med"/>
-                    </a:lnL>
-                    <a:lnR w="9525" cap="flat" cmpd="sng" algn="ctr">
-                      <a:solidFill>
-                        <a:srgbClr val="333333"/>
-                      </a:solidFill>
-                      <a:prstDash val="solid"/>
-                      <a:round/>
-                      <a:headEnd type="none" w="med" len="med"/>
-                      <a:tailEnd type="none" w="med" len="med"/>
-                    </a:lnR>
-                    <a:lnT w="9525" cap="flat" cmpd="sng" algn="ctr">
-                      <a:solidFill>
-                        <a:srgbClr val="333333"/>
-                      </a:solidFill>
-                      <a:prstDash val="solid"/>
-                      <a:round/>
-                      <a:headEnd type="none" w="med" len="med"/>
-                      <a:tailEnd type="none" w="med" len="med"/>
-                    </a:lnT>
-                    <a:lnB w="9525" cap="flat" cmpd="sng" algn="ctr">
-                      <a:solidFill>
-                        <a:srgbClr val="333333"/>
-                      </a:solidFill>
-                      <a:prstDash val="solid"/>
-                      <a:round/>
-                      <a:headEnd type="none" w="med" len="med"/>
-                      <a:tailEnd type="none" w="med" len="med"/>
-                    </a:lnB>
-                  </a:tcPr>
-                </a:tc>
-              </a:tr>
-              <a:tr h="0">
-                <a:tc>
-                  <a:txBody>
-                    <a:bodyPr/>
-                    <a:lstStyle/>
-                    <a:p>
-                      <a:pPr algn="l" indent="0" marL="0">
-                        <a:buNone/>
-                      </a:pPr>
-                      <a:r>
-                        <a:rPr lang="en-US" sz="1250" dirty="0">
-                          <a:solidFill>
-                            <a:srgbClr val="1A1A1A"/>
-                          </a:solidFill>
-                          <a:latin typeface="Times New Roman" pitchFamily="34" charset="0"/>
-                          <a:ea typeface="Times New Roman" pitchFamily="34" charset="-122"/>
-                          <a:cs typeface="Times New Roman" pitchFamily="34" charset="-120"/>
-                        </a:rPr>
                         <a:t>Retrieval latency</a:t>
                       </a:r>
                       <a:endParaRPr lang="en-US" sz="1250" dirty="0">
@@ -25746,7 +23189,7 @@
                           <a:ea typeface="Times New Roman" pitchFamily="34" charset="-122"/>
                           <a:cs typeface="Times New Roman" pitchFamily="34" charset="-120"/>
                         </a:rPr>
-                        <a:t>Dataset revision, models, prompts and configuration pinned, raw run outputs published.</a:t>
+                        <a:t>Models, prompts and configuration pinned.</a:t>
                       </a:r>
                       <a:endParaRPr lang="en-US" sz="1250" dirty="0">
                         <a:latin typeface="Times New Roman" charset="0"/>
@@ -25811,7 +23254,7 @@
                           <a:ea typeface="Times New Roman" pitchFamily="34" charset="-122"/>
                           <a:cs typeface="Times New Roman" pitchFamily="34" charset="-120"/>
                         </a:rPr>
-                        <a:t>Dataset pinned by SHA-256 and settings kept in benchmark/config.json. No run exists yet, so there are no outputs to publish, and the Docker image tag still floats.</a:t>
+                        <a:t>Worker model pinned to a Hugging Face revision and SHA-256 checksum. The Docker image tag still floats.</a:t>
                       </a:r>
                       <a:endParaRPr lang="en-US" sz="1250" dirty="0">
                         <a:latin typeface="Times New Roman" charset="0"/>
@@ -27935,203 +25378,6 @@
                           <a:ea typeface="Times New Roman" pitchFamily="34" charset="-122"/>
                           <a:cs typeface="Times New Roman" pitchFamily="34" charset="-120"/>
                         </a:rPr>
-                        <a:t>Evaluation</a:t>
-                      </a:r>
-                      <a:endParaRPr lang="en-US" sz="1250" dirty="0">
-                        <a:latin typeface="Times New Roman" charset="0"/>
-                        <a:ea typeface="Times New Roman" charset="0"/>
-                        <a:cs typeface="Times New Roman" charset="0"/>
-                      </a:endParaRPr>
-                    </a:p>
-                  </a:txBody>
-                  <a:tcPr marL="64008" marR="64008" marT="36576" marB="36576" anchor="t">
-                    <a:lnL w="9525" cap="flat" cmpd="sng" algn="ctr">
-                      <a:solidFill>
-                        <a:srgbClr val="333333"/>
-                      </a:solidFill>
-                      <a:prstDash val="solid"/>
-                      <a:round/>
-                      <a:headEnd type="none" w="med" len="med"/>
-                      <a:tailEnd type="none" w="med" len="med"/>
-                    </a:lnL>
-                    <a:lnR w="9525" cap="flat" cmpd="sng" algn="ctr">
-                      <a:solidFill>
-                        <a:srgbClr val="333333"/>
-                      </a:solidFill>
-                      <a:prstDash val="solid"/>
-                      <a:round/>
-                      <a:headEnd type="none" w="med" len="med"/>
-                      <a:tailEnd type="none" w="med" len="med"/>
-                    </a:lnR>
-                    <a:lnT w="9525" cap="flat" cmpd="sng" algn="ctr">
-                      <a:solidFill>
-                        <a:srgbClr val="333333"/>
-                      </a:solidFill>
-                      <a:prstDash val="solid"/>
-                      <a:round/>
-                      <a:headEnd type="none" w="med" len="med"/>
-                      <a:tailEnd type="none" w="med" len="med"/>
-                    </a:lnT>
-                    <a:lnB w="9525" cap="flat" cmpd="sng" algn="ctr">
-                      <a:solidFill>
-                        <a:srgbClr val="333333"/>
-                      </a:solidFill>
-                      <a:prstDash val="solid"/>
-                      <a:round/>
-                      <a:headEnd type="none" w="med" len="med"/>
-                      <a:tailEnd type="none" w="med" len="med"/>
-                    </a:lnB>
-                  </a:tcPr>
-                </a:tc>
-                <a:tc>
-                  <a:txBody>
-                    <a:bodyPr/>
-                    <a:lstStyle/>
-                    <a:p>
-                      <a:pPr algn="l" indent="0" marL="0">
-                        <a:buNone/>
-                      </a:pPr>
-                      <a:r>
-                        <a:rPr lang="en-US" sz="1250" dirty="0">
-                          <a:solidFill>
-                            <a:srgbClr val="1A1A1A"/>
-                          </a:solidFill>
-                          <a:latin typeface="Times New Roman" pitchFamily="34" charset="0"/>
-                          <a:ea typeface="Times New Roman" pitchFamily="34" charset="-122"/>
-                          <a:cs typeface="Times New Roman" pitchFamily="34" charset="-120"/>
-                        </a:rPr>
-                        <a:t>LongMemEval-S and LoCoMo, baselines B0 to B3, k6</a:t>
-                      </a:r>
-                      <a:endParaRPr lang="en-US" sz="1250" dirty="0">
-                        <a:latin typeface="Times New Roman" charset="0"/>
-                        <a:ea typeface="Times New Roman" charset="0"/>
-                        <a:cs typeface="Times New Roman" charset="0"/>
-                      </a:endParaRPr>
-                    </a:p>
-                  </a:txBody>
-                  <a:tcPr marL="64008" marR="64008" marT="36576" marB="36576" anchor="t">
-                    <a:lnL w="9525" cap="flat" cmpd="sng" algn="ctr">
-                      <a:solidFill>
-                        <a:srgbClr val="333333"/>
-                      </a:solidFill>
-                      <a:prstDash val="solid"/>
-                      <a:round/>
-                      <a:headEnd type="none" w="med" len="med"/>
-                      <a:tailEnd type="none" w="med" len="med"/>
-                    </a:lnL>
-                    <a:lnR w="9525" cap="flat" cmpd="sng" algn="ctr">
-                      <a:solidFill>
-                        <a:srgbClr val="333333"/>
-                      </a:solidFill>
-                      <a:prstDash val="solid"/>
-                      <a:round/>
-                      <a:headEnd type="none" w="med" len="med"/>
-                      <a:tailEnd type="none" w="med" len="med"/>
-                    </a:lnR>
-                    <a:lnT w="9525" cap="flat" cmpd="sng" algn="ctr">
-                      <a:solidFill>
-                        <a:srgbClr val="333333"/>
-                      </a:solidFill>
-                      <a:prstDash val="solid"/>
-                      <a:round/>
-                      <a:headEnd type="none" w="med" len="med"/>
-                      <a:tailEnd type="none" w="med" len="med"/>
-                    </a:lnT>
-                    <a:lnB w="9525" cap="flat" cmpd="sng" algn="ctr">
-                      <a:solidFill>
-                        <a:srgbClr val="333333"/>
-                      </a:solidFill>
-                      <a:prstDash val="solid"/>
-                      <a:round/>
-                      <a:headEnd type="none" w="med" len="med"/>
-                      <a:tailEnd type="none" w="med" len="med"/>
-                    </a:lnB>
-                  </a:tcPr>
-                </a:tc>
-                <a:tc>
-                  <a:txBody>
-                    <a:bodyPr/>
-                    <a:lstStyle/>
-                    <a:p>
-                      <a:pPr algn="l" indent="0" marL="0">
-                        <a:buNone/>
-                      </a:pPr>
-                      <a:r>
-                        <a:rPr lang="en-US" sz="1250" dirty="0">
-                          <a:solidFill>
-                            <a:srgbClr val="1A1A1A"/>
-                          </a:solidFill>
-                          <a:latin typeface="Times New Roman" pitchFamily="34" charset="0"/>
-                          <a:ea typeface="Times New Roman" pitchFamily="34" charset="-122"/>
-                          <a:cs typeface="Times New Roman" pitchFamily="34" charset="-120"/>
-                        </a:rPr>
-                        <a:t>LongMemEval-S runner, no completed run yet. LoCoMo and k6 are Planned.</a:t>
-                      </a:r>
-                      <a:endParaRPr lang="en-US" sz="1250" dirty="0">
-                        <a:latin typeface="Times New Roman" charset="0"/>
-                        <a:ea typeface="Times New Roman" charset="0"/>
-                        <a:cs typeface="Times New Roman" charset="0"/>
-                      </a:endParaRPr>
-                    </a:p>
-                  </a:txBody>
-                  <a:tcPr marL="64008" marR="64008" marT="36576" marB="36576" anchor="t">
-                    <a:lnL w="9525" cap="flat" cmpd="sng" algn="ctr">
-                      <a:solidFill>
-                        <a:srgbClr val="333333"/>
-                      </a:solidFill>
-                      <a:prstDash val="solid"/>
-                      <a:round/>
-                      <a:headEnd type="none" w="med" len="med"/>
-                      <a:tailEnd type="none" w="med" len="med"/>
-                    </a:lnL>
-                    <a:lnR w="9525" cap="flat" cmpd="sng" algn="ctr">
-                      <a:solidFill>
-                        <a:srgbClr val="333333"/>
-                      </a:solidFill>
-                      <a:prstDash val="solid"/>
-                      <a:round/>
-                      <a:headEnd type="none" w="med" len="med"/>
-                      <a:tailEnd type="none" w="med" len="med"/>
-                    </a:lnR>
-                    <a:lnT w="9525" cap="flat" cmpd="sng" algn="ctr">
-                      <a:solidFill>
-                        <a:srgbClr val="333333"/>
-                      </a:solidFill>
-                      <a:prstDash val="solid"/>
-                      <a:round/>
-                      <a:headEnd type="none" w="med" len="med"/>
-                      <a:tailEnd type="none" w="med" len="med"/>
-                    </a:lnT>
-                    <a:lnB w="9525" cap="flat" cmpd="sng" algn="ctr">
-                      <a:solidFill>
-                        <a:srgbClr val="333333"/>
-                      </a:solidFill>
-                      <a:prstDash val="solid"/>
-                      <a:round/>
-                      <a:headEnd type="none" w="med" len="med"/>
-                      <a:tailEnd type="none" w="med" len="med"/>
-                    </a:lnB>
-                  </a:tcPr>
-                </a:tc>
-              </a:tr>
-              <a:tr h="0">
-                <a:tc>
-                  <a:txBody>
-                    <a:bodyPr/>
-                    <a:lstStyle/>
-                    <a:p>
-                      <a:pPr algn="l" indent="0" marL="0">
-                        <a:buNone/>
-                      </a:pPr>
-                      <a:r>
-                        <a:rPr lang="en-US" sz="1250" dirty="0">
-                          <a:solidFill>
-                            <a:srgbClr val="1A1A1A"/>
-                          </a:solidFill>
-                          <a:latin typeface="Times New Roman" pitchFamily="34" charset="0"/>
-                          <a:ea typeface="Times New Roman" pitchFamily="34" charset="-122"/>
-                          <a:cs typeface="Times New Roman" pitchFamily="34" charset="-120"/>
-                        </a:rPr>
                         <a:t>Tests</a:t>
                       </a:r>
                       <a:endParaRPr lang="en-US" sz="1250" dirty="0">
@@ -29011,138 +26257,6 @@
       </p:sp>
       <p:sp>
         <p:nvSpPr>
-          <p:cNvPr id="7" name="Text 5"/>
-          <p:cNvSpPr/>
-          <p:nvPr/>
-        </p:nvSpPr>
-        <p:spPr>
-          <a:xfrm>
-            <a:off x="3566160" y="1225296"/>
-            <a:ext cx="1554480" cy="530352"/>
-          </a:xfrm>
-          <a:prstGeom prst="rect">
-            <a:avLst/>
-          </a:prstGeom>
-          <a:solidFill>
-            <a:srgbClr val="FFFFFF"/>
-          </a:solidFill>
-          <a:ln w="12700">
-            <a:solidFill>
-              <a:srgbClr val="333333"/>
-            </a:solidFill>
-            <a:prstDash val="dashDot"/>
-          </a:ln>
-        </p:spPr>
-        <p:txBody>
-          <a:bodyPr wrap="square" lIns="63500" tIns="88900" rIns="88900" bIns="63500" rtlCol="0" anchor="t"/>
-          <a:lstStyle/>
-          <a:p>
-            <a:pPr algn="l" indent="0" marL="0">
-              <a:spcAft>
-                <a:spcPts val="300"/>
-              </a:spcAft>
-              <a:buNone/>
-            </a:pPr>
-            <a:r>
-              <a:rPr lang="en-US" sz="1300" b="1" dirty="0">
-                <a:solidFill>
-                  <a:srgbClr val="1A1A1A"/>
-                </a:solidFill>
-                <a:latin typeface="Times New Roman" pitchFamily="34" charset="0"/>
-                <a:ea typeface="Times New Roman" pitchFamily="34" charset="-122"/>
-                <a:cs typeface="Times New Roman" pitchFamily="34" charset="-120"/>
-              </a:rPr>
-              <a:t>Evaluation harness</a:t>
-            </a:r>
-            <a:endParaRPr lang="en-US" sz="1300" dirty="0"/>
-          </a:p>
-          <a:p>
-            <a:pPr algn="l" indent="0" marL="0">
-              <a:buNone/>
-            </a:pPr>
-            <a:r>
-              <a:rPr lang="en-US" sz="1200" dirty="0">
-                <a:solidFill>
-                  <a:srgbClr val="1A1A1A"/>
-                </a:solidFill>
-                <a:latin typeface="Times New Roman" pitchFamily="34" charset="0"/>
-                <a:ea typeface="Times New Roman" pitchFamily="34" charset="-122"/>
-                <a:cs typeface="Times New Roman" pitchFamily="34" charset="-120"/>
-              </a:rPr>
-              <a:t>runner, In progress</a:t>
-            </a:r>
-            <a:endParaRPr lang="en-US" sz="1300" dirty="0"/>
-          </a:p>
-        </p:txBody>
-      </p:sp>
-      <p:sp>
-        <p:nvSpPr>
-          <p:cNvPr id="8" name="Text 6"/>
-          <p:cNvSpPr/>
-          <p:nvPr/>
-        </p:nvSpPr>
-        <p:spPr>
-          <a:xfrm>
-            <a:off x="5394960" y="1225296"/>
-            <a:ext cx="1828800" cy="530352"/>
-          </a:xfrm>
-          <a:prstGeom prst="rect">
-            <a:avLst/>
-          </a:prstGeom>
-          <a:solidFill>
-            <a:srgbClr val="FAFAFA"/>
-          </a:solidFill>
-          <a:ln w="12700">
-            <a:solidFill>
-              <a:srgbClr val="595959"/>
-            </a:solidFill>
-            <a:prstDash val="sysDot"/>
-          </a:ln>
-        </p:spPr>
-        <p:txBody>
-          <a:bodyPr wrap="square" lIns="63500" tIns="88900" rIns="88900" bIns="63500" rtlCol="0" anchor="t"/>
-          <a:lstStyle/>
-          <a:p>
-            <a:pPr algn="l" indent="0" marL="0">
-              <a:spcAft>
-                <a:spcPts val="300"/>
-              </a:spcAft>
-              <a:buNone/>
-            </a:pPr>
-            <a:r>
-              <a:rPr lang="en-US" sz="1300" b="1" dirty="0">
-                <a:solidFill>
-                  <a:srgbClr val="595959"/>
-                </a:solidFill>
-                <a:latin typeface="Times New Roman" pitchFamily="34" charset="0"/>
-                <a:ea typeface="Times New Roman" pitchFamily="34" charset="-122"/>
-                <a:cs typeface="Times New Roman" pitchFamily="34" charset="-120"/>
-              </a:rPr>
-              <a:t>k6, Criterion, LoCoMo</a:t>
-            </a:r>
-            <a:endParaRPr lang="en-US" sz="1300" dirty="0"/>
-          </a:p>
-          <a:p>
-            <a:pPr algn="l" indent="0" marL="0">
-              <a:buNone/>
-            </a:pPr>
-            <a:r>
-              <a:rPr lang="en-US" sz="1100" i="1" dirty="0">
-                <a:solidFill>
-                  <a:srgbClr val="595959"/>
-                </a:solidFill>
-                <a:latin typeface="Times New Roman" pitchFamily="34" charset="0"/>
-                <a:ea typeface="Times New Roman" pitchFamily="34" charset="-122"/>
-                <a:cs typeface="Times New Roman" pitchFamily="34" charset="-120"/>
-              </a:rPr>
-              <a:t>Planned</a:t>
-            </a:r>
-            <a:endParaRPr lang="en-US" sz="1300" dirty="0"/>
-          </a:p>
-        </p:txBody>
-      </p:sp>
-      <p:sp>
-        <p:nvSpPr>
           <p:cNvPr id="9" name="Text 7"/>
           <p:cNvSpPr/>
           <p:nvPr/>
@@ -30767,69 +27881,6 @@
                 <a:cs typeface="Times New Roman" pitchFamily="34" charset="-120"/>
               </a:rPr>
               <a:t>context</a:t>
-            </a:r>
-            <a:endParaRPr lang="en-US" sz="1100" dirty="0"/>
-          </a:p>
-        </p:txBody>
-      </p:sp>
-      <p:cxnSp>
-        <p:nvCxnSpPr>
-          <p:cNvPr id="41" name="Connector 41"/>
-          <p:cNvCxnSpPr/>
-          <p:nvPr/>
-        </p:nvCxnSpPr>
-        <p:spPr>
-          <a:xfrm>
-            <a:off x="4023360" y="1755648"/>
-            <a:ext cx="0" cy="274320"/>
-          </a:xfrm>
-          <a:prstGeom prst="straightConnector1">
-            <a:avLst/>
-          </a:prstGeom>
-          <a:noFill/>
-          <a:ln w="15875">
-            <a:solidFill>
-              <a:srgbClr val="333333"/>
-            </a:solidFill>
-            <a:prstDash val="solid"/>
-            <a:tailEnd type="triangle"/>
-          </a:ln>
-        </p:spPr>
-      </p:cxnSp>
-      <p:sp>
-        <p:nvSpPr>
-          <p:cNvPr id="42" name="Text 40"/>
-          <p:cNvSpPr txBox="1"/>
-          <p:nvPr/>
-        </p:nvSpPr>
-        <p:spPr>
-          <a:xfrm>
-            <a:off x="4096512" y="1783080"/>
-            <a:ext cx="1234440" cy="219456"/>
-          </a:xfrm>
-          <a:prstGeom prst="rect">
-            <a:avLst/>
-          </a:prstGeom>
-          <a:noFill/>
-          <a:ln/>
-        </p:spPr>
-        <p:txBody>
-          <a:bodyPr wrap="square" lIns="0" tIns="0" rIns="0" bIns="0" rtlCol="0" anchor="ctr"/>
-          <a:lstStyle/>
-          <a:p>
-            <a:pPr algn="l" indent="0" marL="0">
-              <a:buNone/>
-            </a:pPr>
-            <a:r>
-              <a:rPr lang="en-US" sz="1100" i="1" dirty="0">
-                <a:solidFill>
-                  <a:srgbClr val="595959"/>
-                </a:solidFill>
-                <a:latin typeface="Times New Roman" pitchFamily="34" charset="0"/>
-                <a:ea typeface="Times New Roman" pitchFamily="34" charset="-122"/>
-                <a:cs typeface="Times New Roman" pitchFamily="34" charset="-120"/>
-              </a:rPr>
-              <a:t>benchmark queries</a:t>
             </a:r>
             <a:endParaRPr lang="en-US" sz="1100" dirty="0"/>
           </a:p>

</xml_diff>

<commit_message>
Remove speaker notes from the review deck
</commit_message>
<xml_diff>
--- a/P1_R2_13.pptx
+++ b/P1_R2_13.pptx
@@ -421,2265 +421,6 @@
   </p:cSld>
   <p:clrMap bg1="lt1" bg2="lt2" tx1="dk1" tx2="dk2" accent1="accent1" accent2="accent2" accent3="accent3" accent4="accent4" accent5="accent5" accent6="accent6" hlink="hlink" folHlink="folHlink"/>
 </p:notesMaster>
-</file>
-
-<file path=ppt/notesSlides/notesSlide1.xml><?xml version="1.0" encoding="utf-8"?>
-<p:notes xmlns:a="http://schemas.openxmlformats.org/drawingml/2006/main" xmlns:p="http://schemas.openxmlformats.org/presentationml/2006/main" xmlns:r="http://schemas.openxmlformats.org/officeDocument/2006/relationships" xmlns:p14="http://schemas.microsoft.com/office/powerpoint/2010/main" xmlns:p15="http://schemas.microsoft.com/office/powerpoint/2012/main" xmlns:mc="http://schemas.openxmlformats.org/markup-compatibility/2006">
-  <p:cSld>
-    <p:spTree>
-      <p:nvGrpSpPr>
-        <p:cNvPr id="1" name=""/>
-        <p:cNvGrpSpPr/>
-        <p:nvPr/>
-      </p:nvGrpSpPr>
-      <p:grpSpPr>
-        <a:xfrm>
-          <a:off x="0" y="0"/>
-          <a:ext cx="0" cy="0"/>
-          <a:chOff x="0" y="0"/>
-          <a:chExt cx="0" cy="0"/>
-        </a:xfrm>
-      </p:grpSpPr>
-      <p:sp>
-        <p:nvSpPr>
-          <p:cNvPr id="96" name="PlaceHolder 1"/>
-          <p:cNvSpPr>
-            <a:spLocks noGrp="1"/>
-          </p:cNvSpPr>
-          <p:nvPr>
-            <p:ph type="sldImg"/>
-          </p:nvPr>
-        </p:nvSpPr>
-        <p:spPr>
-          <a:xfrm>
-            <a:off x="685800" y="1143000"/>
-            <a:ext cx="5485320" cy="3085200"/>
-          </a:xfrm>
-          <a:prstGeom prst="rect">
-            <a:avLst/>
-          </a:prstGeom>
-          <a:ln w="0">
-            <a:noFill/>
-          </a:ln>
-        </p:spPr>
-      </p:sp>
-      <p:sp>
-        <p:nvSpPr>
-          <p:cNvPr id="97" name="PlaceHolder 2"/>
-          <p:cNvSpPr>
-            <a:spLocks noGrp="1"/>
-          </p:cNvSpPr>
-          <p:nvPr>
-            <p:ph type="body"/>
-          </p:nvPr>
-        </p:nvSpPr>
-        <p:spPr>
-          <a:xfrm>
-            <a:off x="685800" y="4400640"/>
-            <a:ext cx="5485320" cy="3599280"/>
-          </a:xfrm>
-          <a:prstGeom prst="rect">
-            <a:avLst/>
-          </a:prstGeom>
-          <a:noFill/>
-          <a:ln w="0">
-            <a:noFill/>
-          </a:ln>
-        </p:spPr>
-        <p:txBody>
-          <a:bodyPr lIns="91440" tIns="45720" rIns="91440" bIns="45720" anchor="t">
-            <a:noAutofit/>
-          </a:bodyPr>
-          <a:p>
-            <a:r>
-              <a:t>We are Team 13. This is our second review of the Long-Term Memory Engine for AI agents, written in Rust. It stores what an agent is told, ties every stored assertion to the message it came from, and brings the right assertions back in a later session. Pi in this deck is the Pi coding agent, not a Raspberry Pi.</a:t>
-            </a:r>
-          </a:p>
-        </p:txBody>
-      </p:sp>
-      <p:sp>
-        <p:nvSpPr>
-          <p:cNvPr id="98" name="PlaceHolder 3"/>
-          <p:cNvSpPr>
-            <a:spLocks noGrp="1"/>
-          </p:cNvSpPr>
-          <p:nvPr>
-            <p:ph type="sldNum" idx="15"/>
-          </p:nvPr>
-        </p:nvSpPr>
-        <p:spPr>
-          <a:xfrm>
-            <a:off x="3884760" y="8685360"/>
-            <a:ext cx="2970720" cy="457560"/>
-          </a:xfrm>
-          <a:prstGeom prst="rect">
-            <a:avLst/>
-          </a:prstGeom>
-          <a:noFill/>
-          <a:ln w="0">
-            <a:noFill/>
-          </a:ln>
-        </p:spPr>
-        <p:txBody>
-          <a:bodyPr lIns="91440" tIns="45720" rIns="91440" bIns="45720" anchor="b">
-            <a:noAutofit/>
-          </a:bodyPr>
-          <a:lstStyle>
-            <a:lvl1pPr indent="0" algn="r" defTabSz="914400">
-              <a:lnSpc>
-                <a:spcPct val="100000"/>
-              </a:lnSpc>
-              <a:buNone/>
-              <a:tabLst>
-                <a:tab pos="0" algn="l"/>
-              </a:tabLst>
-              <a:defRPr lang="en-US" sz="1200" b="0" u="none" strike="noStrike">
-                <a:solidFill>
-                  <a:schemeClr val="dk1"/>
-                </a:solidFill>
-                <a:effectLst/>
-                <a:uFillTx/>
-                <a:latin typeface="+mn-lt"/>
-                <a:ea typeface="+mn-ea"/>
-              </a:defRPr>
-            </a:lvl1pPr>
-          </a:lstStyle>
-          <a:p>
-            <a:pPr indent="0" algn="r" defTabSz="914400">
-              <a:lnSpc>
-                <a:spcPct val="100000"/>
-              </a:lnSpc>
-              <a:buNone/>
-              <a:tabLst>
-                <a:tab pos="0" algn="l"/>
-              </a:tabLst>
-            </a:pPr>
-            <a:fld id="{3EA25BEB-A7A5-40D7-B7AC-0E97B534B315}" type="slidenum">
-              <a:rPr lang="en-US" sz="1200" b="0" u="none" strike="noStrike">
-                <a:solidFill>
-                  <a:schemeClr val="dk1"/>
-                </a:solidFill>
-                <a:effectLst/>
-                <a:uFillTx/>
-                <a:latin typeface="+mn-lt"/>
-                <a:ea typeface="+mn-ea"/>
-              </a:rPr>
-              <a:t>&lt;number&gt;</a:t>
-            </a:fld>
-            <a:endParaRPr lang="en-US" sz="1200" b="0" u="none" strike="noStrike">
-              <a:solidFill>
-                <a:srgbClr val="000000"/>
-              </a:solidFill>
-              <a:effectLst/>
-              <a:uFillTx/>
-              <a:latin typeface="Times New Roman"/>
-            </a:endParaRPr>
-          </a:p>
-        </p:txBody>
-      </p:sp>
-    </p:spTree>
-  </p:cSld>
-</p:notes>
-</file>
-
-<file path=ppt/notesSlides/notesSlide10.xml><?xml version="1.0" encoding="utf-8"?>
-<p:notes xmlns:a="http://schemas.openxmlformats.org/drawingml/2006/main" xmlns:p="http://schemas.openxmlformats.org/presentationml/2006/main" xmlns:r="http://schemas.openxmlformats.org/officeDocument/2006/relationships">
-  <p:cSld>
-    <p:spTree>
-      <p:nvGrpSpPr>
-        <p:cNvPr id="1" name=""/>
-        <p:cNvGrpSpPr/>
-        <p:nvPr/>
-      </p:nvGrpSpPr>
-      <p:grpSpPr>
-        <a:xfrm>
-          <a:off x="0" y="0"/>
-          <a:ext cx="0" cy="0"/>
-          <a:chOff x="0" y="0"/>
-          <a:chExt cx="0" cy="0"/>
-        </a:xfrm>
-      </p:grpSpPr>
-      <p:sp>
-        <p:nvSpPr>
-          <p:cNvPr id="2" name="Slide Image Placeholder 1"/>
-          <p:cNvSpPr>
-            <a:spLocks noGrp="1"/>
-          </p:cNvSpPr>
-          <p:nvPr>
-            <p:ph type="sldImg"/>
-          </p:nvPr>
-        </p:nvSpPr>
-        <p:spPr/>
-      </p:sp>
-      <p:sp>
-        <p:nvSpPr>
-          <p:cNvPr id="3" name="Notes Placeholder 2"/>
-          <p:cNvSpPr>
-            <a:spLocks noGrp="1"/>
-          </p:cNvSpPr>
-          <p:nvPr>
-            <p:ph type="body"/>
-          </p:nvPr>
-        </p:nvSpPr>
-        <p:spPr/>
-        <p:txBody>
-          <a:bodyPr/>
-          <a:lstStyle/>
-          <a:p>
-            <a:r>
-              <a:t>Module 1 saves the raw messages before any model touches them, so a failed model call can never lose a conversation. In the walkthrough, this is the step that stores Maya's two messages.</a:t>
-            </a:r>
-          </a:p>
-        </p:txBody>
-      </p:sp>
-      <p:sp>
-        <p:nvSpPr>
-          <p:cNvPr id="4" name="Slide Number Placeholder 3"/>
-          <p:cNvSpPr>
-            <a:spLocks noGrp="1"/>
-          </p:cNvSpPr>
-          <p:nvPr>
-            <p:ph type="sldNum" idx="4"/>
-          </p:nvPr>
-        </p:nvSpPr>
-        <p:spPr/>
-      </p:sp>
-    </p:spTree>
-  </p:cSld>
-  <p:clrMapOvr>
-    <a:masterClrMapping/>
-  </p:clrMapOvr>
-</p:notes>
-</file>
-
-<file path=ppt/notesSlides/notesSlide11.xml><?xml version="1.0" encoding="utf-8"?>
-<p:notes xmlns:a="http://schemas.openxmlformats.org/drawingml/2006/main" xmlns:p="http://schemas.openxmlformats.org/presentationml/2006/main" xmlns:r="http://schemas.openxmlformats.org/officeDocument/2006/relationships">
-  <p:cSld>
-    <p:spTree>
-      <p:nvGrpSpPr>
-        <p:cNvPr id="1" name=""/>
-        <p:cNvGrpSpPr/>
-        <p:nvPr/>
-      </p:nvGrpSpPr>
-      <p:grpSpPr>
-        <a:xfrm>
-          <a:off x="0" y="0"/>
-          <a:ext cx="0" cy="0"/>
-          <a:chOff x="0" y="0"/>
-          <a:chExt cx="0" cy="0"/>
-        </a:xfrm>
-      </p:grpSpPr>
-      <p:sp>
-        <p:nvSpPr>
-          <p:cNvPr id="2" name="Slide Image Placeholder 1"/>
-          <p:cNvSpPr>
-            <a:spLocks noGrp="1"/>
-          </p:cNvSpPr>
-          <p:nvPr>
-            <p:ph type="sldImg"/>
-          </p:nvPr>
-        </p:nvSpPr>
-        <p:spPr/>
-      </p:sp>
-      <p:sp>
-        <p:nvSpPr>
-          <p:cNvPr id="3" name="Notes Placeholder 2"/>
-          <p:cNvSpPr>
-            <a:spLocks noGrp="1"/>
-          </p:cNvSpPr>
-          <p:nvPr>
-            <p:ph type="body"/>
-          </p:nvPr>
-        </p:nvSpPr>
-        <p:spPr/>
-        <p:txBody>
-          <a:bodyPr/>
-          <a:lstStyle/>
-          <a:p>
-            <a:r>
-              <a:t>Both stages call the same local model. The prompt also includes related existing assertions, which is how the model knows 'Bengaluru is now my home city' corrects Chennai. Algorithm 1 decides which existing assertions fit in the prompt.</a:t>
-            </a:r>
-          </a:p>
-        </p:txBody>
-      </p:sp>
-      <p:sp>
-        <p:nvSpPr>
-          <p:cNvPr id="4" name="Slide Number Placeholder 3"/>
-          <p:cNvSpPr>
-            <a:spLocks noGrp="1"/>
-          </p:cNvSpPr>
-          <p:nvPr>
-            <p:ph type="sldNum" idx="4"/>
-          </p:nvPr>
-        </p:nvSpPr>
-        <p:spPr/>
-      </p:sp>
-    </p:spTree>
-  </p:cSld>
-  <p:clrMapOvr>
-    <a:masterClrMapping/>
-  </p:clrMapOvr>
-</p:notes>
-</file>
-
-<file path=ppt/notesSlides/notesSlide12.xml><?xml version="1.0" encoding="utf-8"?>
-<p:notes xmlns:a="http://schemas.openxmlformats.org/drawingml/2006/main" xmlns:p="http://schemas.openxmlformats.org/presentationml/2006/main" xmlns:r="http://schemas.openxmlformats.org/officeDocument/2006/relationships">
-  <p:cSld>
-    <p:spTree>
-      <p:nvGrpSpPr>
-        <p:cNvPr id="1" name=""/>
-        <p:cNvGrpSpPr/>
-        <p:nvPr/>
-      </p:nvGrpSpPr>
-      <p:grpSpPr>
-        <a:xfrm>
-          <a:off x="0" y="0"/>
-          <a:ext cx="0" cy="0"/>
-          <a:chOff x="0" y="0"/>
-          <a:chExt cx="0" cy="0"/>
-        </a:xfrm>
-      </p:grpSpPr>
-      <p:sp>
-        <p:nvSpPr>
-          <p:cNvPr id="2" name="Slide Image Placeholder 1"/>
-          <p:cNvSpPr>
-            <a:spLocks noGrp="1"/>
-          </p:cNvSpPr>
-          <p:nvPr>
-            <p:ph type="sldImg"/>
-          </p:nvPr>
-        </p:nvSpPr>
-        <p:spPr/>
-      </p:sp>
-      <p:sp>
-        <p:nvSpPr>
-          <p:cNvPr id="3" name="Notes Placeholder 2"/>
-          <p:cNvSpPr>
-            <a:spLocks noGrp="1"/>
-          </p:cNvSpPr>
-          <p:nvPr>
-            <p:ph type="body"/>
-          </p:nvPr>
-        </p:nvSpPr>
-        <p:spPr/>
-        <p:txBody>
-          <a:bodyPr/>
-          <a:lstStyle/>
-          <a:p>
-            <a:r>
-              <a:t>This is where G1 and G2 are answered: the update rule is code, not a model decision, and nothing is deleted. Chennai stays on record as valid from 1 to 10 October. If an assertion changes, any inference built on it is marked stale. Algorithm 2 is this rule written out.</a:t>
-            </a:r>
-          </a:p>
-        </p:txBody>
-      </p:sp>
-      <p:sp>
-        <p:nvSpPr>
-          <p:cNvPr id="4" name="Slide Number Placeholder 3"/>
-          <p:cNvSpPr>
-            <a:spLocks noGrp="1"/>
-          </p:cNvSpPr>
-          <p:nvPr>
-            <p:ph type="sldNum" idx="4"/>
-          </p:nvPr>
-        </p:nvSpPr>
-        <p:spPr/>
-      </p:sp>
-    </p:spTree>
-  </p:cSld>
-  <p:clrMapOvr>
-    <a:masterClrMapping/>
-  </p:clrMapOvr>
-</p:notes>
-</file>
-
-<file path=ppt/notesSlides/notesSlide13.xml><?xml version="1.0" encoding="utf-8"?>
-<p:notes xmlns:a="http://schemas.openxmlformats.org/drawingml/2006/main" xmlns:p="http://schemas.openxmlformats.org/presentationml/2006/main" xmlns:r="http://schemas.openxmlformats.org/officeDocument/2006/relationships">
-  <p:cSld>
-    <p:spTree>
-      <p:nvGrpSpPr>
-        <p:cNvPr id="1" name=""/>
-        <p:cNvGrpSpPr/>
-        <p:nvPr/>
-      </p:nvGrpSpPr>
-      <p:grpSpPr>
-        <a:xfrm>
-          <a:off x="0" y="0"/>
-          <a:ext cx="0" cy="0"/>
-          <a:chOff x="0" y="0"/>
-          <a:chExt cx="0" cy="0"/>
-        </a:xfrm>
-      </p:grpSpPr>
-      <p:sp>
-        <p:nvSpPr>
-          <p:cNvPr id="2" name="Slide Image Placeholder 1"/>
-          <p:cNvSpPr>
-            <a:spLocks noGrp="1"/>
-          </p:cNvSpPr>
-          <p:nvPr>
-            <p:ph type="sldImg"/>
-          </p:nvPr>
-        </p:nvSpPr>
-        <p:spPr/>
-      </p:sp>
-      <p:sp>
-        <p:nvSpPr>
-          <p:cNvPr id="3" name="Notes Placeholder 2"/>
-          <p:cNvSpPr>
-            <a:spLocks noGrp="1"/>
-          </p:cNvSpPr>
-          <p:nvPr>
-            <p:ph type="body"/>
-          </p:nvPr>
-        </p:nvSpPr>
-        <p:spPr/>
-        <p:txBody>
-          <a:bodyPr/>
-          <a:lstStyle/>
-          <a:p>
-            <a:r>
-              <a:t>Each search misses different things, so we run several and merge them (Algorithms 4 and 5). Anything found through the graph copy is checked against PostgreSQL before use, and packing stops at the token budget so the agent's prompt stays small.</a:t>
-            </a:r>
-          </a:p>
-        </p:txBody>
-      </p:sp>
-      <p:sp>
-        <p:nvSpPr>
-          <p:cNvPr id="4" name="Slide Number Placeholder 3"/>
-          <p:cNvSpPr>
-            <a:spLocks noGrp="1"/>
-          </p:cNvSpPr>
-          <p:nvPr>
-            <p:ph type="sldNum" idx="4"/>
-          </p:nvPr>
-        </p:nvSpPr>
-        <p:spPr/>
-      </p:sp>
-    </p:spTree>
-  </p:cSld>
-  <p:clrMapOvr>
-    <a:masterClrMapping/>
-  </p:clrMapOvr>
-</p:notes>
-</file>
-
-<file path=ppt/notesSlides/notesSlide14.xml><?xml version="1.0" encoding="utf-8"?>
-<p:notes xmlns:a="http://schemas.openxmlformats.org/drawingml/2006/main" xmlns:p="http://schemas.openxmlformats.org/presentationml/2006/main" xmlns:r="http://schemas.openxmlformats.org/officeDocument/2006/relationships">
-  <p:cSld>
-    <p:spTree>
-      <p:nvGrpSpPr>
-        <p:cNvPr id="1" name=""/>
-        <p:cNvGrpSpPr/>
-        <p:nvPr/>
-      </p:nvGrpSpPr>
-      <p:grpSpPr>
-        <a:xfrm>
-          <a:off x="0" y="0"/>
-          <a:ext cx="0" cy="0"/>
-          <a:chOff x="0" y="0"/>
-          <a:chExt cx="0" cy="0"/>
-        </a:xfrm>
-      </p:grpSpPr>
-      <p:sp>
-        <p:nvSpPr>
-          <p:cNvPr id="2" name="Slide Image Placeholder 1"/>
-          <p:cNvSpPr>
-            <a:spLocks noGrp="1"/>
-          </p:cNvSpPr>
-          <p:nvPr>
-            <p:ph type="sldImg"/>
-          </p:nvPr>
-        </p:nvSpPr>
-        <p:spPr/>
-      </p:sp>
-      <p:sp>
-        <p:nvSpPr>
-          <p:cNvPr id="3" name="Notes Placeholder 2"/>
-          <p:cNvSpPr>
-            <a:spLocks noGrp="1"/>
-          </p:cNvSpPr>
-          <p:nvPr>
-            <p:ph type="body"/>
-          </p:nvPr>
-        </p:nvSpPr>
-        <p:spPr/>
-        <p:txBody>
-          <a:bodyPr/>
-          <a:lstStyle/>
-          <a:p>
-            <a:r>
-              <a:t>Labels are checked for structure and exact quotes before they go into the dataset. The dataset slides describe the data, and the results slides compare the model before and after fine-tuning.</a:t>
-            </a:r>
-          </a:p>
-        </p:txBody>
-      </p:sp>
-      <p:sp>
-        <p:nvSpPr>
-          <p:cNvPr id="4" name="Slide Number Placeholder 3"/>
-          <p:cNvSpPr>
-            <a:spLocks noGrp="1"/>
-          </p:cNvSpPr>
-          <p:nvPr>
-            <p:ph type="sldNum" idx="4"/>
-          </p:nvPr>
-        </p:nvSpPr>
-        <p:spPr/>
-      </p:sp>
-    </p:spTree>
-  </p:cSld>
-  <p:clrMapOvr>
-    <a:masterClrMapping/>
-  </p:clrMapOvr>
-</p:notes>
-</file>
-
-<file path=ppt/notesSlides/notesSlide15.xml><?xml version="1.0" encoding="utf-8"?>
-<p:notes xmlns:a="http://schemas.openxmlformats.org/drawingml/2006/main" xmlns:p="http://schemas.openxmlformats.org/presentationml/2006/main" xmlns:r="http://schemas.openxmlformats.org/officeDocument/2006/relationships">
-  <p:cSld>
-    <p:spTree>
-      <p:nvGrpSpPr>
-        <p:cNvPr id="1" name=""/>
-        <p:cNvGrpSpPr/>
-        <p:nvPr/>
-      </p:nvGrpSpPr>
-      <p:grpSpPr>
-        <a:xfrm>
-          <a:off x="0" y="0"/>
-          <a:ext cx="0" cy="0"/>
-          <a:chOff x="0" y="0"/>
-          <a:chExt cx="0" cy="0"/>
-        </a:xfrm>
-      </p:grpSpPr>
-      <p:sp>
-        <p:nvSpPr>
-          <p:cNvPr id="2" name="Slide Image Placeholder 1"/>
-          <p:cNvSpPr>
-            <a:spLocks noGrp="1"/>
-          </p:cNvSpPr>
-          <p:nvPr>
-            <p:ph type="sldImg"/>
-          </p:nvPr>
-        </p:nvSpPr>
-        <p:spPr/>
-      </p:sp>
-      <p:sp>
-        <p:nvSpPr>
-          <p:cNvPr id="3" name="Notes Placeholder 2"/>
-          <p:cNvSpPr>
-            <a:spLocks noGrp="1"/>
-          </p:cNvSpPr>
-          <p:nvPr>
-            <p:ph type="body"/>
-          </p:nvPr>
-        </p:nvSpPr>
-        <p:spPr/>
-        <p:txBody>
-          <a:bodyPr/>
-          <a:lstStyle/>
-          <a:p>
-            <a:r>
-              <a:t>Six algorithms do the work inside the modules. The first three run when memory is written, the last three when it is read. The next three slides give the steps of each.</a:t>
-            </a:r>
-          </a:p>
-        </p:txBody>
-      </p:sp>
-      <p:sp>
-        <p:nvSpPr>
-          <p:cNvPr id="4" name="Slide Number Placeholder 3"/>
-          <p:cNvSpPr>
-            <a:spLocks noGrp="1"/>
-          </p:cNvSpPr>
-          <p:nvPr>
-            <p:ph type="sldNum" idx="4"/>
-          </p:nvPr>
-        </p:nvSpPr>
-        <p:spPr/>
-      </p:sp>
-    </p:spTree>
-  </p:cSld>
-  <p:clrMapOvr>
-    <a:masterClrMapping/>
-  </p:clrMapOvr>
-</p:notes>
-</file>
-
-<file path=ppt/notesSlides/notesSlide16.xml><?xml version="1.0" encoding="utf-8"?>
-<p:notes xmlns:a="http://schemas.openxmlformats.org/drawingml/2006/main" xmlns:p="http://schemas.openxmlformats.org/presentationml/2006/main" xmlns:r="http://schemas.openxmlformats.org/officeDocument/2006/relationships">
-  <p:cSld>
-    <p:spTree>
-      <p:nvGrpSpPr>
-        <p:cNvPr id="1" name=""/>
-        <p:cNvGrpSpPr/>
-        <p:nvPr/>
-      </p:nvGrpSpPr>
-      <p:grpSpPr>
-        <a:xfrm>
-          <a:off x="0" y="0"/>
-          <a:ext cx="0" cy="0"/>
-          <a:chOff x="0" y="0"/>
-          <a:chExt cx="0" cy="0"/>
-        </a:xfrm>
-      </p:grpSpPr>
-      <p:sp>
-        <p:nvSpPr>
-          <p:cNvPr id="2" name="Slide Image Placeholder 1"/>
-          <p:cNvSpPr>
-            <a:spLocks noGrp="1"/>
-          </p:cNvSpPr>
-          <p:nvPr>
-            <p:ph type="sldImg"/>
-          </p:nvPr>
-        </p:nvSpPr>
-        <p:spPr/>
-      </p:sp>
-      <p:sp>
-        <p:nvSpPr>
-          <p:cNvPr id="3" name="Notes Placeholder 2"/>
-          <p:cNvSpPr>
-            <a:spLocks noGrp="1"/>
-          </p:cNvSpPr>
-          <p:nvPr>
-            <p:ph type="body"/>
-          </p:nvPr>
-        </p:nvSpPr>
-        <p:spPr/>
-        <p:txBody>
-          <a:bodyPr/>
-          <a:lstStyle/>
-          <a:p>
-            <a:r>
-              <a:t>Algorithm 1 keeps the extraction prompt inside the model's limit without dropping the assertions the new messages are about. Algorithm 2 is the Module 3 rule: in the walkthrough, Bengaluru takes the third branch and Chennai becomes history.</a:t>
-            </a:r>
-          </a:p>
-        </p:txBody>
-      </p:sp>
-      <p:sp>
-        <p:nvSpPr>
-          <p:cNvPr id="4" name="Slide Number Placeholder 3"/>
-          <p:cNvSpPr>
-            <a:spLocks noGrp="1"/>
-          </p:cNvSpPr>
-          <p:nvPr>
-            <p:ph type="sldNum" idx="4"/>
-          </p:nvPr>
-        </p:nvSpPr>
-        <p:spPr/>
-      </p:sp>
-    </p:spTree>
-  </p:cSld>
-  <p:clrMapOvr>
-    <a:masterClrMapping/>
-  </p:clrMapOvr>
-</p:notes>
-</file>
-
-<file path=ppt/notesSlides/notesSlide17.xml><?xml version="1.0" encoding="utf-8"?>
-<p:notes xmlns:a="http://schemas.openxmlformats.org/drawingml/2006/main" xmlns:p="http://schemas.openxmlformats.org/presentationml/2006/main" xmlns:r="http://schemas.openxmlformats.org/officeDocument/2006/relationships">
-  <p:cSld>
-    <p:spTree>
-      <p:nvGrpSpPr>
-        <p:cNvPr id="1" name=""/>
-        <p:cNvGrpSpPr/>
-        <p:nvPr/>
-      </p:nvGrpSpPr>
-      <p:grpSpPr>
-        <a:xfrm>
-          <a:off x="0" y="0"/>
-          <a:ext cx="0" cy="0"/>
-          <a:chOff x="0" y="0"/>
-          <a:chExt cx="0" cy="0"/>
-        </a:xfrm>
-      </p:grpSpPr>
-      <p:sp>
-        <p:nvSpPr>
-          <p:cNvPr id="2" name="Slide Image Placeholder 1"/>
-          <p:cNvSpPr>
-            <a:spLocks noGrp="1"/>
-          </p:cNvSpPr>
-          <p:nvPr>
-            <p:ph type="sldImg"/>
-          </p:nvPr>
-        </p:nvSpPr>
-        <p:spPr/>
-      </p:sp>
-      <p:sp>
-        <p:nvSpPr>
-          <p:cNvPr id="3" name="Notes Placeholder 2"/>
-          <p:cNvSpPr>
-            <a:spLocks noGrp="1"/>
-          </p:cNvSpPr>
-          <p:nvPr>
-            <p:ph type="body"/>
-          </p:nvPr>
-        </p:nvSpPr>
-        <p:spPr/>
-        <p:txBody>
-          <a:bodyPr/>
-          <a:lstStyle/>
-          <a:p>
-            <a:r>
-              <a:t>An inference is only as good as the assertions under it, so when one of them changes, the inference is marked stale instead of quietly staying in memory. Retrieval runs several searches because each one misses different things.</a:t>
-            </a:r>
-          </a:p>
-        </p:txBody>
-      </p:sp>
-      <p:sp>
-        <p:nvSpPr>
-          <p:cNvPr id="4" name="Slide Number Placeholder 3"/>
-          <p:cNvSpPr>
-            <a:spLocks noGrp="1"/>
-          </p:cNvSpPr>
-          <p:nvPr>
-            <p:ph type="sldNum" idx="4"/>
-          </p:nvPr>
-        </p:nvSpPr>
-        <p:spPr/>
-      </p:sp>
-    </p:spTree>
-  </p:cSld>
-  <p:clrMapOvr>
-    <a:masterClrMapping/>
-  </p:clrMapOvr>
-</p:notes>
-</file>
-
-<file path=ppt/notesSlides/notesSlide18.xml><?xml version="1.0" encoding="utf-8"?>
-<p:notes xmlns:a="http://schemas.openxmlformats.org/drawingml/2006/main" xmlns:p="http://schemas.openxmlformats.org/presentationml/2006/main" xmlns:r="http://schemas.openxmlformats.org/officeDocument/2006/relationships">
-  <p:cSld>
-    <p:spTree>
-      <p:nvGrpSpPr>
-        <p:cNvPr id="1" name=""/>
-        <p:cNvGrpSpPr/>
-        <p:nvPr/>
-      </p:nvGrpSpPr>
-      <p:grpSpPr>
-        <a:xfrm>
-          <a:off x="0" y="0"/>
-          <a:ext cx="0" cy="0"/>
-          <a:chOff x="0" y="0"/>
-          <a:chExt cx="0" cy="0"/>
-        </a:xfrm>
-      </p:grpSpPr>
-      <p:sp>
-        <p:nvSpPr>
-          <p:cNvPr id="2" name="Slide Image Placeholder 1"/>
-          <p:cNvSpPr>
-            <a:spLocks noGrp="1"/>
-          </p:cNvSpPr>
-          <p:nvPr>
-            <p:ph type="sldImg"/>
-          </p:nvPr>
-        </p:nvSpPr>
-        <p:spPr/>
-      </p:sp>
-      <p:sp>
-        <p:nvSpPr>
-          <p:cNvPr id="3" name="Notes Placeholder 2"/>
-          <p:cNvSpPr>
-            <a:spLocks noGrp="1"/>
-          </p:cNvSpPr>
-          <p:nvPr>
-            <p:ph type="body"/>
-          </p:nvPr>
-        </p:nvSpPr>
-        <p:spPr/>
-        <p:txBody>
-          <a:bodyPr/>
-          <a:lstStyle/>
-          <a:p>
-            <a:r>
-              <a:t>A memory ranked high by several searches scores highest; 60 is the constant from the original RRF paper. The answering step would rather refuse than guess: with nothing retrieved it says so, and an answer that cites nothing is rejected.</a:t>
-            </a:r>
-          </a:p>
-        </p:txBody>
-      </p:sp>
-      <p:sp>
-        <p:nvSpPr>
-          <p:cNvPr id="4" name="Slide Number Placeholder 3"/>
-          <p:cNvSpPr>
-            <a:spLocks noGrp="1"/>
-          </p:cNvSpPr>
-          <p:nvPr>
-            <p:ph type="sldNum" idx="4"/>
-          </p:nvPr>
-        </p:nvSpPr>
-        <p:spPr/>
-      </p:sp>
-    </p:spTree>
-  </p:cSld>
-  <p:clrMapOvr>
-    <a:masterClrMapping/>
-  </p:clrMapOvr>
-</p:notes>
-</file>
-
-<file path=ppt/notesSlides/notesSlide19.xml><?xml version="1.0" encoding="utf-8"?>
-<p:notes xmlns:a="http://schemas.openxmlformats.org/drawingml/2006/main" xmlns:p="http://schemas.openxmlformats.org/presentationml/2006/main" xmlns:r="http://schemas.openxmlformats.org/officeDocument/2006/relationships">
-  <p:cSld>
-    <p:spTree>
-      <p:nvGrpSpPr>
-        <p:cNvPr id="1" name=""/>
-        <p:cNvGrpSpPr/>
-        <p:nvPr/>
-      </p:nvGrpSpPr>
-      <p:grpSpPr>
-        <a:xfrm>
-          <a:off x="0" y="0"/>
-          <a:ext cx="0" cy="0"/>
-          <a:chOff x="0" y="0"/>
-          <a:chExt cx="0" cy="0"/>
-        </a:xfrm>
-      </p:grpSpPr>
-      <p:sp>
-        <p:nvSpPr>
-          <p:cNvPr id="2" name="Slide Image Placeholder 1"/>
-          <p:cNvSpPr>
-            <a:spLocks noGrp="1"/>
-          </p:cNvSpPr>
-          <p:nvPr>
-            <p:ph type="sldImg"/>
-          </p:nvPr>
-        </p:nvSpPr>
-        <p:spPr/>
-      </p:sp>
-      <p:sp>
-        <p:nvSpPr>
-          <p:cNvPr id="3" name="Notes Placeholder 2"/>
-          <p:cNvSpPr>
-            <a:spLocks noGrp="1"/>
-          </p:cNvSpPr>
-          <p:nvPr>
-            <p:ph type="body"/>
-          </p:nvPr>
-        </p:nvSpPr>
-        <p:spPr/>
-        <p:txBody>
-          <a:bodyPr/>
-          <a:lstStyle/>
-          <a:p>
-            <a:r>
-              <a:t>The service is written in Rust. PostgreSQL holds everything and Neo4j is only a copy. All models run through Ollama on our own machine, which is how we answer G4.</a:t>
-            </a:r>
-          </a:p>
-        </p:txBody>
-      </p:sp>
-      <p:sp>
-        <p:nvSpPr>
-          <p:cNvPr id="4" name="Slide Number Placeholder 3"/>
-          <p:cNvSpPr>
-            <a:spLocks noGrp="1"/>
-          </p:cNvSpPr>
-          <p:nvPr>
-            <p:ph type="sldNum" idx="4"/>
-          </p:nvPr>
-        </p:nvSpPr>
-        <p:spPr/>
-      </p:sp>
-    </p:spTree>
-  </p:cSld>
-  <p:clrMapOvr>
-    <a:masterClrMapping/>
-  </p:clrMapOvr>
-</p:notes>
-</file>
-
-<file path=ppt/notesSlides/notesSlide2.xml><?xml version="1.0" encoding="utf-8"?>
-<p:notes xmlns:a="http://schemas.openxmlformats.org/drawingml/2006/main" xmlns:p="http://schemas.openxmlformats.org/presentationml/2006/main" xmlns:r="http://schemas.openxmlformats.org/officeDocument/2006/relationships">
-  <p:cSld>
-    <p:spTree>
-      <p:nvGrpSpPr>
-        <p:cNvPr id="1" name=""/>
-        <p:cNvGrpSpPr/>
-        <p:nvPr/>
-      </p:nvGrpSpPr>
-      <p:grpSpPr>
-        <a:xfrm>
-          <a:off x="0" y="0"/>
-          <a:ext cx="0" cy="0"/>
-          <a:chOff x="0" y="0"/>
-          <a:chExt cx="0" cy="0"/>
-        </a:xfrm>
-      </p:grpSpPr>
-      <p:sp>
-        <p:nvSpPr>
-          <p:cNvPr id="2" name="Slide Image Placeholder 1"/>
-          <p:cNvSpPr>
-            <a:spLocks noGrp="1"/>
-          </p:cNvSpPr>
-          <p:nvPr>
-            <p:ph type="sldImg"/>
-          </p:nvPr>
-        </p:nvSpPr>
-        <p:spPr/>
-      </p:sp>
-      <p:sp>
-        <p:nvSpPr>
-          <p:cNvPr id="3" name="Notes Placeholder 2"/>
-          <p:cNvSpPr>
-            <a:spLocks noGrp="1"/>
-          </p:cNvSpPr>
-          <p:nvPr>
-            <p:ph type="body"/>
-          </p:nvPr>
-        </p:nvSpPr>
-        <p:spPr/>
-        <p:txBody>
-          <a:bodyPr/>
-          <a:lstStyle/>
-          <a:p>
-            <a:r>
-              <a:t>A language model remembers nothing between calls, so an agent that works with someone over many sessions needs a place to keep what it was told. Re-sending the whole history is the obvious fix, but Liu et al. showed that models make poor use of the middle of a long input, and the cost grows with every session. LongMemEval is the benchmark that tests the abilities we are after. Pi, which appears throughout the deck, is the Pi coding agent, not a Raspberry Pi.</a:t>
-            </a:r>
-          </a:p>
-        </p:txBody>
-      </p:sp>
-      <p:sp>
-        <p:nvSpPr>
-          <p:cNvPr id="4" name="Slide Number Placeholder 3"/>
-          <p:cNvSpPr>
-            <a:spLocks noGrp="1"/>
-          </p:cNvSpPr>
-          <p:nvPr>
-            <p:ph type="sldNum" idx="4"/>
-          </p:nvPr>
-        </p:nvSpPr>
-        <p:spPr/>
-      </p:sp>
-    </p:spTree>
-  </p:cSld>
-  <p:clrMapOvr>
-    <a:masterClrMapping/>
-  </p:clrMapOvr>
-</p:notes>
-</file>
-
-<file path=ppt/notesSlides/notesSlide20.xml><?xml version="1.0" encoding="utf-8"?>
-<p:notes xmlns:a="http://schemas.openxmlformats.org/drawingml/2006/main" xmlns:p="http://schemas.openxmlformats.org/presentationml/2006/main" xmlns:r="http://schemas.openxmlformats.org/officeDocument/2006/relationships">
-  <p:cSld>
-    <p:spTree>
-      <p:nvGrpSpPr>
-        <p:cNvPr id="1" name=""/>
-        <p:cNvGrpSpPr/>
-        <p:nvPr/>
-      </p:nvGrpSpPr>
-      <p:grpSpPr>
-        <a:xfrm>
-          <a:off x="0" y="0"/>
-          <a:ext cx="0" cy="0"/>
-          <a:chOff x="0" y="0"/>
-          <a:chExt cx="0" cy="0"/>
-        </a:xfrm>
-      </p:grpSpPr>
-      <p:sp>
-        <p:nvSpPr>
-          <p:cNvPr id="2" name="Slide Image Placeholder 1"/>
-          <p:cNvSpPr>
-            <a:spLocks noGrp="1"/>
-          </p:cNvSpPr>
-          <p:nvPr>
-            <p:ph type="sldImg"/>
-          </p:nvPr>
-        </p:nvSpPr>
-        <p:spPr/>
-      </p:sp>
-      <p:sp>
-        <p:nvSpPr>
-          <p:cNvPr id="3" name="Notes Placeholder 2"/>
-          <p:cNvSpPr>
-            <a:spLocks noGrp="1"/>
-          </p:cNvSpPr>
-          <p:nvPr>
-            <p:ph type="body"/>
-          </p:nvPr>
-        </p:nvSpPr>
-        <p:spPr/>
-        <p:txBody>
-          <a:bodyPr/>
-          <a:lstStyle/>
-          <a:p>
-            <a:r>
-              <a:t>The training side uses the usual Hugging Face tools for QLoRA, then llama.cpp to produce a file Ollama can serve. Pi is the agent we integrate with, and the dashboard is a React app.</a:t>
-            </a:r>
-          </a:p>
-        </p:txBody>
-      </p:sp>
-      <p:sp>
-        <p:nvSpPr>
-          <p:cNvPr id="4" name="Slide Number Placeholder 3"/>
-          <p:cNvSpPr>
-            <a:spLocks noGrp="1"/>
-          </p:cNvSpPr>
-          <p:nvPr>
-            <p:ph type="sldNum" idx="4"/>
-          </p:nvPr>
-        </p:nvSpPr>
-        <p:spPr/>
-      </p:sp>
-    </p:spTree>
-  </p:cSld>
-  <p:clrMapOvr>
-    <a:masterClrMapping/>
-  </p:clrMapOvr>
-</p:notes>
-</file>
-
-<file path=ppt/notesSlides/notesSlide21.xml><?xml version="1.0" encoding="utf-8"?>
-<p:notes xmlns:a="http://schemas.openxmlformats.org/drawingml/2006/main" xmlns:p="http://schemas.openxmlformats.org/presentationml/2006/main" xmlns:r="http://schemas.openxmlformats.org/officeDocument/2006/relationships">
-  <p:cSld>
-    <p:spTree>
-      <p:nvGrpSpPr>
-        <p:cNvPr id="1" name=""/>
-        <p:cNvGrpSpPr/>
-        <p:nvPr/>
-      </p:nvGrpSpPr>
-      <p:grpSpPr>
-        <a:xfrm>
-          <a:off x="0" y="0"/>
-          <a:ext cx="0" cy="0"/>
-          <a:chOff x="0" y="0"/>
-          <a:chExt cx="0" cy="0"/>
-        </a:xfrm>
-      </p:grpSpPr>
-      <p:sp>
-        <p:nvSpPr>
-          <p:cNvPr id="2" name="Slide Image Placeholder 1"/>
-          <p:cNvSpPr>
-            <a:spLocks noGrp="1"/>
-          </p:cNvSpPr>
-          <p:nvPr>
-            <p:ph type="sldImg"/>
-          </p:nvPr>
-        </p:nvSpPr>
-        <p:spPr/>
-      </p:sp>
-      <p:sp>
-        <p:nvSpPr>
-          <p:cNvPr id="3" name="Notes Placeholder 2"/>
-          <p:cNvSpPr>
-            <a:spLocks noGrp="1"/>
-          </p:cNvSpPr>
-          <p:nvPr>
-            <p:ph type="body"/>
-          </p:nvPr>
-        </p:nvSpPr>
-        <p:spPr/>
-        <p:txBody>
-          <a:bodyPr/>
-          <a:lstStyle/>
-          <a:p>
-            <a:r>
-              <a:t>This is the data Module 5 trains on. Every conversation is synthetic: the larger model labelled it, a second model checked the labels, and we cleaned what was left. Many rows test whether the model keeps only what the user said. In this one, the assistant's suggestion must not become a memory.</a:t>
-            </a:r>
-          </a:p>
-        </p:txBody>
-      </p:sp>
-      <p:sp>
-        <p:nvSpPr>
-          <p:cNvPr id="4" name="Slide Number Placeholder 3"/>
-          <p:cNvSpPr>
-            <a:spLocks noGrp="1"/>
-          </p:cNvSpPr>
-          <p:nvPr>
-            <p:ph type="sldNum" idx="4"/>
-          </p:nvPr>
-        </p:nvSpPr>
-        <p:spPr/>
-      </p:sp>
-    </p:spTree>
-  </p:cSld>
-  <p:clrMapOvr>
-    <a:masterClrMapping/>
-  </p:clrMapOvr>
-</p:notes>
-</file>
-
-<file path=ppt/notesSlides/notesSlide22.xml><?xml version="1.0" encoding="utf-8"?>
-<p:notes xmlns:a="http://schemas.openxmlformats.org/drawingml/2006/main" xmlns:p="http://schemas.openxmlformats.org/presentationml/2006/main" xmlns:r="http://schemas.openxmlformats.org/officeDocument/2006/relationships">
-  <p:cSld>
-    <p:spTree>
-      <p:nvGrpSpPr>
-        <p:cNvPr id="1" name=""/>
-        <p:cNvGrpSpPr/>
-        <p:nvPr/>
-      </p:nvGrpSpPr>
-      <p:grpSpPr>
-        <a:xfrm>
-          <a:off x="0" y="0"/>
-          <a:ext cx="0" cy="0"/>
-          <a:chOff x="0" y="0"/>
-          <a:chExt cx="0" cy="0"/>
-        </a:xfrm>
-      </p:grpSpPr>
-      <p:sp>
-        <p:nvSpPr>
-          <p:cNvPr id="2" name="Slide Image Placeholder 1"/>
-          <p:cNvSpPr>
-            <a:spLocks noGrp="1"/>
-          </p:cNvSpPr>
-          <p:nvPr>
-            <p:ph type="sldImg"/>
-          </p:nvPr>
-        </p:nvSpPr>
-        <p:spPr/>
-      </p:sp>
-      <p:sp>
-        <p:nvSpPr>
-          <p:cNvPr id="3" name="Notes Placeholder 2"/>
-          <p:cNvSpPr>
-            <a:spLocks noGrp="1"/>
-          </p:cNvSpPr>
-          <p:nvPr>
-            <p:ph type="body"/>
-          </p:nvPr>
-        </p:nvSpPr>
-        <p:spPr/>
-        <p:txBody>
-          <a:bodyPr/>
-          <a:lstStyle/>
-          <a:p>
-            <a:r>
-              <a:t>To see how the model does on conversations it was not trained on, we use LoCoMo. Forty reference assertions is a small set, so we treat these numbers as a check, not a benchmark.</a:t>
-            </a:r>
-          </a:p>
-        </p:txBody>
-      </p:sp>
-      <p:sp>
-        <p:nvSpPr>
-          <p:cNvPr id="4" name="Slide Number Placeholder 3"/>
-          <p:cNvSpPr>
-            <a:spLocks noGrp="1"/>
-          </p:cNvSpPr>
-          <p:nvPr>
-            <p:ph type="sldNum" idx="4"/>
-          </p:nvPr>
-        </p:nvSpPr>
-        <p:spPr/>
-      </p:sp>
-    </p:spTree>
-  </p:cSld>
-  <p:clrMapOvr>
-    <a:masterClrMapping/>
-  </p:clrMapOvr>
-</p:notes>
-</file>
-
-<file path=ppt/notesSlides/notesSlide23.xml><?xml version="1.0" encoding="utf-8"?>
-<p:notes xmlns:a="http://schemas.openxmlformats.org/drawingml/2006/main" xmlns:p="http://schemas.openxmlformats.org/presentationml/2006/main" xmlns:r="http://schemas.openxmlformats.org/officeDocument/2006/relationships">
-  <p:cSld>
-    <p:spTree>
-      <p:nvGrpSpPr>
-        <p:cNvPr id="1" name=""/>
-        <p:cNvGrpSpPr/>
-        <p:nvPr/>
-      </p:nvGrpSpPr>
-      <p:grpSpPr>
-        <a:xfrm>
-          <a:off x="0" y="0"/>
-          <a:ext cx="0" cy="0"/>
-          <a:chOff x="0" y="0"/>
-          <a:chExt cx="0" cy="0"/>
-        </a:xfrm>
-      </p:grpSpPr>
-      <p:sp>
-        <p:nvSpPr>
-          <p:cNvPr id="2" name="Slide Image Placeholder 1"/>
-          <p:cNvSpPr>
-            <a:spLocks noGrp="1"/>
-          </p:cNvSpPr>
-          <p:nvPr>
-            <p:ph type="sldImg"/>
-          </p:nvPr>
-        </p:nvSpPr>
-        <p:spPr/>
-      </p:sp>
-      <p:sp>
-        <p:nvSpPr>
-          <p:cNvPr id="3" name="Notes Placeholder 2"/>
-          <p:cNvSpPr>
-            <a:spLocks noGrp="1"/>
-          </p:cNvSpPr>
-          <p:nvPr>
-            <p:ph type="body"/>
-          </p:nvPr>
-        </p:nvSpPr>
-        <p:spPr/>
-        <p:txBody>
-          <a:bodyPr/>
-          <a:lstStyle/>
-          <a:p>
-            <a:r>
-              <a:t>Software is the largest domain because the dataset began as coding conversations only. The bars count task rows, not conversations: one conversation can give an extraction row, a consolidation row and a question-answering row.</a:t>
-            </a:r>
-          </a:p>
-        </p:txBody>
-      </p:sp>
-      <p:sp>
-        <p:nvSpPr>
-          <p:cNvPr id="4" name="Slide Number Placeholder 3"/>
-          <p:cNvSpPr>
-            <a:spLocks noGrp="1"/>
-          </p:cNvSpPr>
-          <p:nvPr>
-            <p:ph type="sldNum" idx="4"/>
-          </p:nvPr>
-        </p:nvSpPr>
-        <p:spPr/>
-      </p:sp>
-    </p:spTree>
-  </p:cSld>
-  <p:clrMapOvr>
-    <a:masterClrMapping/>
-  </p:clrMapOvr>
-</p:notes>
-</file>
-
-<file path=ppt/notesSlides/notesSlide24.xml><?xml version="1.0" encoding="utf-8"?>
-<p:notes xmlns:a="http://schemas.openxmlformats.org/drawingml/2006/main" xmlns:p="http://schemas.openxmlformats.org/presentationml/2006/main" xmlns:r="http://schemas.openxmlformats.org/officeDocument/2006/relationships">
-  <p:cSld>
-    <p:spTree>
-      <p:nvGrpSpPr>
-        <p:cNvPr id="1" name=""/>
-        <p:cNvGrpSpPr/>
-        <p:nvPr/>
-      </p:nvGrpSpPr>
-      <p:grpSpPr>
-        <a:xfrm>
-          <a:off x="0" y="0"/>
-          <a:ext cx="0" cy="0"/>
-          <a:chOff x="0" y="0"/>
-          <a:chExt cx="0" cy="0"/>
-        </a:xfrm>
-      </p:grpSpPr>
-      <p:sp>
-        <p:nvSpPr>
-          <p:cNvPr id="2" name="Slide Image Placeholder 1"/>
-          <p:cNvSpPr>
-            <a:spLocks noGrp="1"/>
-          </p:cNvSpPr>
-          <p:nvPr>
-            <p:ph type="sldImg"/>
-          </p:nvPr>
-        </p:nvSpPr>
-        <p:spPr/>
-      </p:sp>
-      <p:sp>
-        <p:nvSpPr>
-          <p:cNvPr id="3" name="Notes Placeholder 2"/>
-          <p:cNvSpPr>
-            <a:spLocks noGrp="1"/>
-          </p:cNvSpPr>
-          <p:nvPr>
-            <p:ph type="body"/>
-          </p:nvPr>
-        </p:nvSpPr>
-        <p:spPr/>
-        <p:txBody>
-          <a:bodyPr/>
-          <a:lstStyle/>
-          <a:p>
-            <a:r>
-              <a:t>This is the same flow as the Maya walkthrough, with project details instead. Session 1 is in the payments-api folder and session 2 in mobile-app, so nothing carries over except through the memory service. Captured on 20 October 2026 from the current build, with Pi running Claude Sonnet 5.5.</a:t>
-            </a:r>
-          </a:p>
-        </p:txBody>
-      </p:sp>
-      <p:sp>
-        <p:nvSpPr>
-          <p:cNvPr id="4" name="Slide Number Placeholder 3"/>
-          <p:cNvSpPr>
-            <a:spLocks noGrp="1"/>
-          </p:cNvSpPr>
-          <p:nvPr>
-            <p:ph type="sldNum" idx="4"/>
-          </p:nvPr>
-        </p:nvSpPr>
-        <p:spPr/>
-      </p:sp>
-    </p:spTree>
-  </p:cSld>
-  <p:clrMapOvr>
-    <a:masterClrMapping/>
-  </p:clrMapOvr>
-</p:notes>
-</file>
-
-<file path=ppt/notesSlides/notesSlide25.xml><?xml version="1.0" encoding="utf-8"?>
-<p:notes xmlns:a="http://schemas.openxmlformats.org/drawingml/2006/main" xmlns:p="http://schemas.openxmlformats.org/presentationml/2006/main" xmlns:r="http://schemas.openxmlformats.org/officeDocument/2006/relationships">
-  <p:cSld>
-    <p:spTree>
-      <p:nvGrpSpPr>
-        <p:cNvPr id="1" name=""/>
-        <p:cNvGrpSpPr/>
-        <p:nvPr/>
-      </p:nvGrpSpPr>
-      <p:grpSpPr>
-        <a:xfrm>
-          <a:off x="0" y="0"/>
-          <a:ext cx="0" cy="0"/>
-          <a:chOff x="0" y="0"/>
-          <a:chExt cx="0" cy="0"/>
-        </a:xfrm>
-      </p:grpSpPr>
-      <p:sp>
-        <p:nvSpPr>
-          <p:cNvPr id="2" name="Slide Image Placeholder 1"/>
-          <p:cNvSpPr>
-            <a:spLocks noGrp="1"/>
-          </p:cNvSpPr>
-          <p:nvPr>
-            <p:ph type="sldImg"/>
-          </p:nvPr>
-        </p:nvSpPr>
-        <p:spPr/>
-      </p:sp>
-      <p:sp>
-        <p:nvSpPr>
-          <p:cNvPr id="3" name="Notes Placeholder 2"/>
-          <p:cNvSpPr>
-            <a:spLocks noGrp="1"/>
-          </p:cNvSpPr>
-          <p:nvPr>
-            <p:ph type="body"/>
-          </p:nvPr>
-        </p:nvSpPr>
-        <p:spPr/>
-        <p:txBody>
-          <a:bodyPr/>
-          <a:lstStyle/>
-          <a:p>
-            <a:r>
-              <a:t>In Figure 3 Pi also notices that the stored date has the year 2026 although the user never gave one. That is why every answer carries its quote: a reader can check it. Figure 4 is our graph page. The Friday assertion replaces the Thursday one, and the side panel shows the message it came from.</a:t>
-            </a:r>
-          </a:p>
-        </p:txBody>
-      </p:sp>
-      <p:sp>
-        <p:nvSpPr>
-          <p:cNvPr id="4" name="Slide Number Placeholder 3"/>
-          <p:cNvSpPr>
-            <a:spLocks noGrp="1"/>
-          </p:cNvSpPr>
-          <p:nvPr>
-            <p:ph type="sldNum" idx="4"/>
-          </p:nvPr>
-        </p:nvSpPr>
-        <p:spPr/>
-      </p:sp>
-    </p:spTree>
-  </p:cSld>
-  <p:clrMapOvr>
-    <a:masterClrMapping/>
-  </p:clrMapOvr>
-</p:notes>
-</file>
-
-<file path=ppt/notesSlides/notesSlide26.xml><?xml version="1.0" encoding="utf-8"?>
-<p:notes xmlns:a="http://schemas.openxmlformats.org/drawingml/2006/main" xmlns:p="http://schemas.openxmlformats.org/presentationml/2006/main" xmlns:r="http://schemas.openxmlformats.org/officeDocument/2006/relationships">
-  <p:cSld>
-    <p:spTree>
-      <p:nvGrpSpPr>
-        <p:cNvPr id="1" name=""/>
-        <p:cNvGrpSpPr/>
-        <p:nvPr/>
-      </p:nvGrpSpPr>
-      <p:grpSpPr>
-        <a:xfrm>
-          <a:off x="0" y="0"/>
-          <a:ext cx="0" cy="0"/>
-          <a:chOff x="0" y="0"/>
-          <a:chExt cx="0" cy="0"/>
-        </a:xfrm>
-      </p:grpSpPr>
-      <p:sp>
-        <p:nvSpPr>
-          <p:cNvPr id="2" name="Slide Image Placeholder 1"/>
-          <p:cNvSpPr>
-            <a:spLocks noGrp="1"/>
-          </p:cNvSpPr>
-          <p:nvPr>
-            <p:ph type="sldImg"/>
-          </p:nvPr>
-        </p:nvSpPr>
-        <p:spPr/>
-      </p:sp>
-      <p:sp>
-        <p:nvSpPr>
-          <p:cNvPr id="3" name="Notes Placeholder 2"/>
-          <p:cNvSpPr>
-            <a:spLocks noGrp="1"/>
-          </p:cNvSpPr>
-          <p:nvPr>
-            <p:ph type="body"/>
-          </p:nvPr>
-        </p:nvSpPr>
-        <p:spPr/>
-        <p:txBody>
-          <a:bodyPr/>
-          <a:lstStyle/>
-          <a:p>
-            <a:r>
-              <a:t>This slide is about behaviour: demos and a database audit on one machine, not a benchmark. The quote check shows that every assertion can be traced, but it does not prove the model read the quote correctly. The next slide has the model numbers.</a:t>
-            </a:r>
-          </a:p>
-        </p:txBody>
-      </p:sp>
-      <p:sp>
-        <p:nvSpPr>
-          <p:cNvPr id="4" name="Slide Number Placeholder 3"/>
-          <p:cNvSpPr>
-            <a:spLocks noGrp="1"/>
-          </p:cNvSpPr>
-          <p:nvPr>
-            <p:ph type="sldNum" idx="4"/>
-          </p:nvPr>
-        </p:nvSpPr>
-        <p:spPr/>
-      </p:sp>
-    </p:spTree>
-  </p:cSld>
-  <p:clrMapOvr>
-    <a:masterClrMapping/>
-  </p:clrMapOvr>
-</p:notes>
-</file>
-
-<file path=ppt/notesSlides/notesSlide27.xml><?xml version="1.0" encoding="utf-8"?>
-<p:notes xmlns:a="http://schemas.openxmlformats.org/drawingml/2006/main" xmlns:p="http://schemas.openxmlformats.org/presentationml/2006/main" xmlns:r="http://schemas.openxmlformats.org/officeDocument/2006/relationships">
-  <p:cSld>
-    <p:spTree>
-      <p:nvGrpSpPr>
-        <p:cNvPr id="1" name=""/>
-        <p:cNvGrpSpPr/>
-        <p:nvPr/>
-      </p:nvGrpSpPr>
-      <p:grpSpPr>
-        <a:xfrm>
-          <a:off x="0" y="0"/>
-          <a:ext cx="0" cy="0"/>
-          <a:chOff x="0" y="0"/>
-          <a:chExt cx="0" cy="0"/>
-        </a:xfrm>
-      </p:grpSpPr>
-      <p:sp>
-        <p:nvSpPr>
-          <p:cNvPr id="2" name="Slide Image Placeholder 1"/>
-          <p:cNvSpPr>
-            <a:spLocks noGrp="1"/>
-          </p:cNvSpPr>
-          <p:nvPr>
-            <p:ph type="sldImg"/>
-          </p:nvPr>
-        </p:nvSpPr>
-        <p:spPr/>
-      </p:sp>
-      <p:sp>
-        <p:nvSpPr>
-          <p:cNvPr id="3" name="Notes Placeholder 2"/>
-          <p:cNvSpPr>
-            <a:spLocks noGrp="1"/>
-          </p:cNvSpPr>
-          <p:nvPr>
-            <p:ph type="body"/>
-          </p:nvPr>
-        </p:nvSpPr>
-        <p:spPr/>
-        <p:txBody>
-          <a:bodyPr/>
-          <a:lstStyle/>
-          <a:p>
-            <a:r>
-              <a:t>Fine-tuning clearly helped with combining assertions and answering. Extraction got worse, and we have not found out why yet. The format check only says the output is valid JSON with valid IDs; it says nothing about whether the content is right.</a:t>
-            </a:r>
-          </a:p>
-        </p:txBody>
-      </p:sp>
-      <p:sp>
-        <p:nvSpPr>
-          <p:cNvPr id="4" name="Slide Number Placeholder 3"/>
-          <p:cNvSpPr>
-            <a:spLocks noGrp="1"/>
-          </p:cNvSpPr>
-          <p:nvPr>
-            <p:ph type="sldNum" idx="4"/>
-          </p:nvPr>
-        </p:nvSpPr>
-        <p:spPr/>
-      </p:sp>
-    </p:spTree>
-  </p:cSld>
-  <p:clrMapOvr>
-    <a:masterClrMapping/>
-  </p:clrMapOvr>
-</p:notes>
-</file>
-
-<file path=ppt/notesSlides/notesSlide28.xml><?xml version="1.0" encoding="utf-8"?>
-<p:notes xmlns:a="http://schemas.openxmlformats.org/drawingml/2006/main" xmlns:p="http://schemas.openxmlformats.org/presentationml/2006/main" xmlns:r="http://schemas.openxmlformats.org/officeDocument/2006/relationships">
-  <p:cSld>
-    <p:spTree>
-      <p:nvGrpSpPr>
-        <p:cNvPr id="1" name=""/>
-        <p:cNvGrpSpPr/>
-        <p:nvPr/>
-      </p:nvGrpSpPr>
-      <p:grpSpPr>
-        <a:xfrm>
-          <a:off x="0" y="0"/>
-          <a:ext cx="0" cy="0"/>
-          <a:chOff x="0" y="0"/>
-          <a:chExt cx="0" cy="0"/>
-        </a:xfrm>
-      </p:grpSpPr>
-      <p:sp>
-        <p:nvSpPr>
-          <p:cNvPr id="2" name="Slide Image Placeholder 1"/>
-          <p:cNvSpPr>
-            <a:spLocks noGrp="1"/>
-          </p:cNvSpPr>
-          <p:nvPr>
-            <p:ph type="sldImg"/>
-          </p:nvPr>
-        </p:nvSpPr>
-        <p:spPr/>
-      </p:sp>
-      <p:sp>
-        <p:nvSpPr>
-          <p:cNvPr id="3" name="Notes Placeholder 2"/>
-          <p:cNvSpPr>
-            <a:spLocks noGrp="1"/>
-          </p:cNvSpPr>
-          <p:nvPr>
-            <p:ph type="body"/>
-          </p:nvPr>
-        </p:nvSpPr>
-        <p:spPr/>
-        <p:txBody>
-          <a:bodyPr/>
-          <a:lstStyle/>
-          <a:p>
-            <a:r>
-              <a:t>These are the weak points we know about. The 1.7B model looked fine on synthetic data and failed on natural conversation, which is why we widened the training data and moved to the 4B model. The full LongMemEval-S run is still pending, so we cannot yet claim the memory helps over long histories.</a:t>
-            </a:r>
-          </a:p>
-        </p:txBody>
-      </p:sp>
-      <p:sp>
-        <p:nvSpPr>
-          <p:cNvPr id="4" name="Slide Number Placeholder 3"/>
-          <p:cNvSpPr>
-            <a:spLocks noGrp="1"/>
-          </p:cNvSpPr>
-          <p:nvPr>
-            <p:ph type="sldNum" idx="4"/>
-          </p:nvPr>
-        </p:nvSpPr>
-        <p:spPr/>
-      </p:sp>
-    </p:spTree>
-  </p:cSld>
-  <p:clrMapOvr>
-    <a:masterClrMapping/>
-  </p:clrMapOvr>
-</p:notes>
-</file>
-
-<file path=ppt/notesSlides/notesSlide29.xml><?xml version="1.0" encoding="utf-8"?>
-<p:notes xmlns:a="http://schemas.openxmlformats.org/drawingml/2006/main" xmlns:p="http://schemas.openxmlformats.org/presentationml/2006/main" xmlns:r="http://schemas.openxmlformats.org/officeDocument/2006/relationships">
-  <p:cSld>
-    <p:spTree>
-      <p:nvGrpSpPr>
-        <p:cNvPr id="1" name=""/>
-        <p:cNvGrpSpPr/>
-        <p:nvPr/>
-      </p:nvGrpSpPr>
-      <p:grpSpPr>
-        <a:xfrm>
-          <a:off x="0" y="0"/>
-          <a:ext cx="0" cy="0"/>
-          <a:chOff x="0" y="0"/>
-          <a:chExt cx="0" cy="0"/>
-        </a:xfrm>
-      </p:grpSpPr>
-      <p:sp>
-        <p:nvSpPr>
-          <p:cNvPr id="2" name="Slide Image Placeholder 1"/>
-          <p:cNvSpPr>
-            <a:spLocks noGrp="1"/>
-          </p:cNvSpPr>
-          <p:nvPr>
-            <p:ph type="sldImg"/>
-          </p:nvPr>
-        </p:nvSpPr>
-        <p:spPr/>
-      </p:sp>
-      <p:sp>
-        <p:nvSpPr>
-          <p:cNvPr id="3" name="Notes Placeholder 2"/>
-          <p:cNvSpPr>
-            <a:spLocks noGrp="1"/>
-          </p:cNvSpPr>
-          <p:nvPr>
-            <p:ph type="body"/>
-          </p:nvPr>
-        </p:nvSpPr>
-        <p:spPr/>
-        <p:txBody>
-          <a:bodyPr/>
-          <a:lstStyle/>
-          <a:p>
-            <a:r>
-              <a:t>Implemented means the feature is in the code and has tests; it does not mean it has been measured to be good. The largest missing piece is the LongMemEval-S run, which needs a 277 MB dataset and a lot of model time.</a:t>
-            </a:r>
-          </a:p>
-        </p:txBody>
-      </p:sp>
-      <p:sp>
-        <p:nvSpPr>
-          <p:cNvPr id="4" name="Slide Number Placeholder 3"/>
-          <p:cNvSpPr>
-            <a:spLocks noGrp="1"/>
-          </p:cNvSpPr>
-          <p:nvPr>
-            <p:ph type="sldNum" idx="4"/>
-          </p:nvPr>
-        </p:nvSpPr>
-        <p:spPr/>
-      </p:sp>
-    </p:spTree>
-  </p:cSld>
-  <p:clrMapOvr>
-    <a:masterClrMapping/>
-  </p:clrMapOvr>
-</p:notes>
-</file>
-
-<file path=ppt/notesSlides/notesSlide3.xml><?xml version="1.0" encoding="utf-8"?>
-<p:notes xmlns:a="http://schemas.openxmlformats.org/drawingml/2006/main" xmlns:p="http://schemas.openxmlformats.org/presentationml/2006/main" xmlns:r="http://schemas.openxmlformats.org/officeDocument/2006/relationships">
-  <p:cSld>
-    <p:spTree>
-      <p:nvGrpSpPr>
-        <p:cNvPr id="1" name=""/>
-        <p:cNvGrpSpPr/>
-        <p:nvPr/>
-      </p:nvGrpSpPr>
-      <p:grpSpPr>
-        <a:xfrm>
-          <a:off x="0" y="0"/>
-          <a:ext cx="0" cy="0"/>
-          <a:chOff x="0" y="0"/>
-          <a:chExt cx="0" cy="0"/>
-        </a:xfrm>
-      </p:grpSpPr>
-      <p:sp>
-        <p:nvSpPr>
-          <p:cNvPr id="2" name="Slide Image Placeholder 1"/>
-          <p:cNvSpPr>
-            <a:spLocks noGrp="1"/>
-          </p:cNvSpPr>
-          <p:nvPr>
-            <p:ph type="sldImg"/>
-          </p:nvPr>
-        </p:nvSpPr>
-        <p:spPr/>
-      </p:sp>
-      <p:sp>
-        <p:nvSpPr>
-          <p:cNvPr id="3" name="Notes Placeholder 2"/>
-          <p:cNvSpPr>
-            <a:spLocks noGrp="1"/>
-          </p:cNvSpPr>
-          <p:nvPr>
-            <p:ph type="body"/>
-          </p:nvPr>
-        </p:nvSpPr>
-        <p:spPr/>
-        <p:txBody>
-          <a:bodyPr/>
-          <a:lstStyle/>
-          <a:p>
-            <a:r>
-              <a:t>We read five memory systems and the plain baseline. MemGPT is a preprint, and Letta grew out of it, so this row describes the paper. Zep's numbers are from the authors' single run; Zep calls its graph edges 'facts'. Mem0's authors work for Mem0 and tested only on LoCoMo, where the full history still scored higher; Mem0's advantage is speed (1.4 s against 17 s at the 95th percentile).</a:t>
-            </a:r>
-          </a:p>
-        </p:txBody>
-      </p:sp>
-      <p:sp>
-        <p:nvSpPr>
-          <p:cNvPr id="4" name="Slide Number Placeholder 3"/>
-          <p:cNvSpPr>
-            <a:spLocks noGrp="1"/>
-          </p:cNvSpPr>
-          <p:nvPr>
-            <p:ph type="sldNum" idx="4"/>
-          </p:nvPr>
-        </p:nvSpPr>
-        <p:spPr/>
-      </p:sp>
-    </p:spTree>
-  </p:cSld>
-  <p:clrMapOvr>
-    <a:masterClrMapping/>
-  </p:clrMapOvr>
-</p:notes>
-</file>
-
-<file path=ppt/notesSlides/notesSlide30.xml><?xml version="1.0" encoding="utf-8"?>
-<p:notes xmlns:a="http://schemas.openxmlformats.org/drawingml/2006/main" xmlns:p="http://schemas.openxmlformats.org/presentationml/2006/main" xmlns:r="http://schemas.openxmlformats.org/officeDocument/2006/relationships">
-  <p:cSld>
-    <p:spTree>
-      <p:nvGrpSpPr>
-        <p:cNvPr id="1" name=""/>
-        <p:cNvGrpSpPr/>
-        <p:nvPr/>
-      </p:nvGrpSpPr>
-      <p:grpSpPr>
-        <a:xfrm>
-          <a:off x="0" y="0"/>
-          <a:ext cx="0" cy="0"/>
-          <a:chOff x="0" y="0"/>
-          <a:chExt cx="0" cy="0"/>
-        </a:xfrm>
-      </p:grpSpPr>
-      <p:sp>
-        <p:nvSpPr>
-          <p:cNvPr id="2" name="Slide Image Placeholder 1"/>
-          <p:cNvSpPr>
-            <a:spLocks noGrp="1"/>
-          </p:cNvSpPr>
-          <p:nvPr>
-            <p:ph type="sldImg"/>
-          </p:nvPr>
-        </p:nvSpPr>
-        <p:spPr/>
-      </p:sp>
-      <p:sp>
-        <p:nvSpPr>
-          <p:cNvPr id="3" name="Notes Placeholder 2"/>
-          <p:cNvSpPr>
-            <a:spLocks noGrp="1"/>
-          </p:cNvSpPr>
-          <p:nvPr>
-            <p:ph type="body"/>
-          </p:nvPr>
-        </p:nvSpPr>
-        <p:spPr/>
-        <p:txBody>
-          <a:bodyPr/>
-          <a:lstStyle/>
-          <a:p>
-            <a:r>
-              <a:t>To sum up against the objectives: memory across sessions, versioned changes and traceable quotes work; the local model works but extraction needs fixing; and the benchmark that would let us compare fairly (G5) is the main thing left.</a:t>
-            </a:r>
-          </a:p>
-        </p:txBody>
-      </p:sp>
-      <p:sp>
-        <p:nvSpPr>
-          <p:cNvPr id="4" name="Slide Number Placeholder 3"/>
-          <p:cNvSpPr>
-            <a:spLocks noGrp="1"/>
-          </p:cNvSpPr>
-          <p:nvPr>
-            <p:ph type="sldNum" idx="4"/>
-          </p:nvPr>
-        </p:nvSpPr>
-        <p:spPr/>
-      </p:sp>
-    </p:spTree>
-  </p:cSld>
-  <p:clrMapOvr>
-    <a:masterClrMapping/>
-  </p:clrMapOvr>
-</p:notes>
-</file>
-
-<file path=ppt/notesSlides/notesSlide31.xml><?xml version="1.0" encoding="utf-8"?>
-<p:notes xmlns:a="http://schemas.openxmlformats.org/drawingml/2006/main" xmlns:p="http://schemas.openxmlformats.org/presentationml/2006/main" xmlns:r="http://schemas.openxmlformats.org/officeDocument/2006/relationships">
-  <p:cSld>
-    <p:spTree>
-      <p:nvGrpSpPr>
-        <p:cNvPr id="1" name=""/>
-        <p:cNvGrpSpPr/>
-        <p:nvPr/>
-      </p:nvGrpSpPr>
-      <p:grpSpPr>
-        <a:xfrm>
-          <a:off x="0" y="0"/>
-          <a:ext cx="0" cy="0"/>
-          <a:chOff x="0" y="0"/>
-          <a:chExt cx="0" cy="0"/>
-        </a:xfrm>
-      </p:grpSpPr>
-      <p:sp>
-        <p:nvSpPr>
-          <p:cNvPr id="2" name="Slide Image Placeholder 1"/>
-          <p:cNvSpPr>
-            <a:spLocks noGrp="1"/>
-          </p:cNvSpPr>
-          <p:nvPr>
-            <p:ph type="sldImg"/>
-          </p:nvPr>
-        </p:nvSpPr>
-        <p:spPr/>
-      </p:sp>
-      <p:sp>
-        <p:nvSpPr>
-          <p:cNvPr id="3" name="Notes Placeholder 2"/>
-          <p:cNvSpPr>
-            <a:spLocks noGrp="1"/>
-          </p:cNvSpPr>
-          <p:nvPr>
-            <p:ph type="body"/>
-          </p:nvPr>
-        </p:nvSpPr>
-        <p:spPr/>
-        <p:txBody>
-          <a:bodyPr/>
-          <a:lstStyle/>
-          <a:p>
-            <a:r>
-              <a:t>References follow IEEE style and are numbered in the order they are first cited in the slides.</a:t>
-            </a:r>
-          </a:p>
-        </p:txBody>
-      </p:sp>
-      <p:sp>
-        <p:nvSpPr>
-          <p:cNvPr id="4" name="Slide Number Placeholder 3"/>
-          <p:cNvSpPr>
-            <a:spLocks noGrp="1"/>
-          </p:cNvSpPr>
-          <p:nvPr>
-            <p:ph type="sldNum" idx="4"/>
-          </p:nvPr>
-        </p:nvSpPr>
-        <p:spPr/>
-      </p:sp>
-    </p:spTree>
-  </p:cSld>
-  <p:clrMapOvr>
-    <a:masterClrMapping/>
-  </p:clrMapOvr>
-</p:notes>
-</file>
-
-<file path=ppt/notesSlides/notesSlide4.xml><?xml version="1.0" encoding="utf-8"?>
-<p:notes xmlns:a="http://schemas.openxmlformats.org/drawingml/2006/main" xmlns:p="http://schemas.openxmlformats.org/presentationml/2006/main" xmlns:r="http://schemas.openxmlformats.org/officeDocument/2006/relationships">
-  <p:cSld>
-    <p:spTree>
-      <p:nvGrpSpPr>
-        <p:cNvPr id="1" name=""/>
-        <p:cNvGrpSpPr/>
-        <p:nvPr/>
-      </p:nvGrpSpPr>
-      <p:grpSpPr>
-        <a:xfrm>
-          <a:off x="0" y="0"/>
-          <a:ext cx="0" cy="0"/>
-          <a:chOff x="0" y="0"/>
-          <a:chExt cx="0" cy="0"/>
-        </a:xfrm>
-      </p:grpSpPr>
-      <p:sp>
-        <p:nvSpPr>
-          <p:cNvPr id="2" name="Slide Image Placeholder 1"/>
-          <p:cNvSpPr>
-            <a:spLocks noGrp="1"/>
-          </p:cNvSpPr>
-          <p:nvPr>
-            <p:ph type="sldImg"/>
-          </p:nvPr>
-        </p:nvSpPr>
-        <p:spPr/>
-      </p:sp>
-      <p:sp>
-        <p:nvSpPr>
-          <p:cNvPr id="3" name="Notes Placeholder 2"/>
-          <p:cNvSpPr>
-            <a:spLocks noGrp="1"/>
-          </p:cNvSpPr>
-          <p:nvPr>
-            <p:ph type="body"/>
-          </p:nvPr>
-        </p:nvSpPr>
-        <p:spPr/>
-        <p:txBody>
-          <a:bodyPr/>
-          <a:lstStyle/>
-          <a:p>
-            <a:r>
-              <a:t>We cite Supermemory for how it works and do not repeat its numbers. Hindsight shaped our recall step. The last row is the baseline every system here tries to beat. The scores cannot be ranked against each other because each paper uses its own models, judges and benchmarks. The next slide lists what these systems leave open.</a:t>
-            </a:r>
-          </a:p>
-        </p:txBody>
-      </p:sp>
-      <p:sp>
-        <p:nvSpPr>
-          <p:cNvPr id="4" name="Slide Number Placeholder 3"/>
-          <p:cNvSpPr>
-            <a:spLocks noGrp="1"/>
-          </p:cNvSpPr>
-          <p:nvPr>
-            <p:ph type="sldNum" idx="4"/>
-          </p:nvPr>
-        </p:nvSpPr>
-        <p:spPr/>
-      </p:sp>
-    </p:spTree>
-  </p:cSld>
-  <p:clrMapOvr>
-    <a:masterClrMapping/>
-  </p:clrMapOvr>
-</p:notes>
-</file>
-
-<file path=ppt/notesSlides/notesSlide5.xml><?xml version="1.0" encoding="utf-8"?>
-<p:notes xmlns:a="http://schemas.openxmlformats.org/drawingml/2006/main" xmlns:p="http://schemas.openxmlformats.org/presentationml/2006/main" xmlns:r="http://schemas.openxmlformats.org/officeDocument/2006/relationships">
-  <p:cSld>
-    <p:spTree>
-      <p:nvGrpSpPr>
-        <p:cNvPr id="1" name=""/>
-        <p:cNvGrpSpPr/>
-        <p:nvPr/>
-      </p:nvGrpSpPr>
-      <p:grpSpPr>
-        <a:xfrm>
-          <a:off x="0" y="0"/>
-          <a:ext cx="0" cy="0"/>
-          <a:chOff x="0" y="0"/>
-          <a:chExt cx="0" cy="0"/>
-        </a:xfrm>
-      </p:grpSpPr>
-      <p:sp>
-        <p:nvSpPr>
-          <p:cNvPr id="2" name="Slide Image Placeholder 1"/>
-          <p:cNvSpPr>
-            <a:spLocks noGrp="1"/>
-          </p:cNvSpPr>
-          <p:nvPr>
-            <p:ph type="sldImg"/>
-          </p:nvPr>
-        </p:nvSpPr>
-        <p:spPr/>
-      </p:sp>
-      <p:sp>
-        <p:nvSpPr>
-          <p:cNvPr id="3" name="Notes Placeholder 2"/>
-          <p:cNvSpPr>
-            <a:spLocks noGrp="1"/>
-          </p:cNvSpPr>
-          <p:nvPr>
-            <p:ph type="body"/>
-          </p:nvPr>
-        </p:nvSpPr>
-        <p:spPr/>
-        <p:txBody>
-          <a:bodyPr/>
-          <a:lstStyle/>
-          <a:p>
-            <a:r>
-              <a:t>These are gaps we found while reading, not problems we hit while building. G1 is the main one: in MemGPT and Mem0 the model itself decides whether to add, update or delete, so a bad call means a lost or corrupted memory and there is no rule anyone can inspect. Only Zep keeps old values. G4 is about cost and privacy: Zep and Mem0 run extraction on hosted OpenAI models. G5 is why we do not compare our numbers with theirs. Each objective on the next slide points back to one of these gaps.</a:t>
-            </a:r>
-          </a:p>
-        </p:txBody>
-      </p:sp>
-      <p:sp>
-        <p:nvSpPr>
-          <p:cNvPr id="4" name="Slide Number Placeholder 3"/>
-          <p:cNvSpPr>
-            <a:spLocks noGrp="1"/>
-          </p:cNvSpPr>
-          <p:nvPr>
-            <p:ph type="sldNum" idx="4"/>
-          </p:nvPr>
-        </p:nvSpPr>
-        <p:spPr/>
-      </p:sp>
-    </p:spTree>
-  </p:cSld>
-  <p:clrMapOvr>
-    <a:masterClrMapping/>
-  </p:clrMapOvr>
-</p:notes>
-</file>
-
-<file path=ppt/notesSlides/notesSlide6.xml><?xml version="1.0" encoding="utf-8"?>
-<p:notes xmlns:a="http://schemas.openxmlformats.org/drawingml/2006/main" xmlns:p="http://schemas.openxmlformats.org/presentationml/2006/main" xmlns:r="http://schemas.openxmlformats.org/officeDocument/2006/relationships">
-  <p:cSld>
-    <p:spTree>
-      <p:nvGrpSpPr>
-        <p:cNvPr id="1" name=""/>
-        <p:cNvGrpSpPr/>
-        <p:nvPr/>
-      </p:nvGrpSpPr>
-      <p:grpSpPr>
-        <a:xfrm>
-          <a:off x="0" y="0"/>
-          <a:ext cx="0" cy="0"/>
-          <a:chOff x="0" y="0"/>
-          <a:chExt cx="0" cy="0"/>
-        </a:xfrm>
-      </p:grpSpPr>
-      <p:sp>
-        <p:nvSpPr>
-          <p:cNvPr id="2" name="Slide Image Placeholder 1"/>
-          <p:cNvSpPr>
-            <a:spLocks noGrp="1"/>
-          </p:cNvSpPr>
-          <p:nvPr>
-            <p:ph type="sldImg"/>
-          </p:nvPr>
-        </p:nvSpPr>
-        <p:spPr/>
-      </p:sp>
-      <p:sp>
-        <p:nvSpPr>
-          <p:cNvPr id="3" name="Notes Placeholder 2"/>
-          <p:cNvSpPr>
-            <a:spLocks noGrp="1"/>
-          </p:cNvSpPr>
-          <p:nvPr>
-            <p:ph type="body"/>
-          </p:nvPr>
-        </p:nvSpPr>
-        <p:spPr/>
-        <p:txBody>
-          <a:bodyPr/>
-          <a:lstStyle/>
-          <a:p>
-            <a:r>
-              <a:t>The first and fifth objectives come straight from the problem statement; the others answer the gaps G1 to G5. From here on the deck shows how the system meets each of them, and the results slides say how far we got.</a:t>
-            </a:r>
-          </a:p>
-        </p:txBody>
-      </p:sp>
-      <p:sp>
-        <p:nvSpPr>
-          <p:cNvPr id="4" name="Slide Number Placeholder 3"/>
-          <p:cNvSpPr>
-            <a:spLocks noGrp="1"/>
-          </p:cNvSpPr>
-          <p:nvPr>
-            <p:ph type="sldNum" idx="4"/>
-          </p:nvPr>
-        </p:nvSpPr>
-        <p:spPr/>
-      </p:sp>
-    </p:spTree>
-  </p:cSld>
-  <p:clrMapOvr>
-    <a:masterClrMapping/>
-  </p:clrMapOvr>
-</p:notes>
-</file>
-
-<file path=ppt/notesSlides/notesSlide7.xml><?xml version="1.0" encoding="utf-8"?>
-<p:notes xmlns:a="http://schemas.openxmlformats.org/drawingml/2006/main" xmlns:p="http://schemas.openxmlformats.org/presentationml/2006/main" xmlns:r="http://schemas.openxmlformats.org/officeDocument/2006/relationships">
-  <p:cSld>
-    <p:spTree>
-      <p:nvGrpSpPr>
-        <p:cNvPr id="1" name=""/>
-        <p:cNvGrpSpPr/>
-        <p:nvPr/>
-      </p:nvGrpSpPr>
-      <p:grpSpPr>
-        <a:xfrm>
-          <a:off x="0" y="0"/>
-          <a:ext cx="0" cy="0"/>
-          <a:chOff x="0" y="0"/>
-          <a:chExt cx="0" cy="0"/>
-        </a:xfrm>
-      </p:grpSpPr>
-      <p:sp>
-        <p:nvSpPr>
-          <p:cNvPr id="2" name="Slide Image Placeholder 1"/>
-          <p:cNvSpPr>
-            <a:spLocks noGrp="1"/>
-          </p:cNvSpPr>
-          <p:nvPr>
-            <p:ph type="sldImg"/>
-          </p:nvPr>
-        </p:nvSpPr>
-        <p:spPr/>
-      </p:sp>
-      <p:sp>
-        <p:nvSpPr>
-          <p:cNvPr id="3" name="Notes Placeholder 2"/>
-          <p:cNvSpPr>
-            <a:spLocks noGrp="1"/>
-          </p:cNvSpPr>
-          <p:nvPr>
-            <p:ph type="body"/>
-          </p:nvPr>
-        </p:nvSpPr>
-        <p:spPr/>
-        <p:txBody>
-          <a:bodyPr/>
-          <a:lstStyle/>
-          <a:p>
-            <a:r>
-              <a:t>Our guide pointed out that our earlier names, 'evidence' and 'facts', were misleading. A fact is something established, but what we extract is a model's reading of a message and can be wrong. Evidence is a role something plays for a conclusion, not a thing we store. So the stored message is a source, and what we extract from it is an assertion, following how Wikidata and W3C PROV name claims and their sources. The example column is the Maya example used on the next slides.</a:t>
-            </a:r>
-          </a:p>
-        </p:txBody>
-      </p:sp>
-      <p:sp>
-        <p:nvSpPr>
-          <p:cNvPr id="4" name="Slide Number Placeholder 3"/>
-          <p:cNvSpPr>
-            <a:spLocks noGrp="1"/>
-          </p:cNvSpPr>
-          <p:nvPr>
-            <p:ph type="sldNum" idx="4"/>
-          </p:nvPr>
-        </p:nvSpPr>
-        <p:spPr/>
-      </p:sp>
-    </p:spTree>
-  </p:cSld>
-  <p:clrMapOvr>
-    <a:masterClrMapping/>
-  </p:clrMapOvr>
-</p:notes>
-</file>
-
-<file path=ppt/notesSlides/notesSlide8.xml><?xml version="1.0" encoding="utf-8"?>
-<p:notes xmlns:a="http://schemas.openxmlformats.org/drawingml/2006/main" xmlns:p="http://schemas.openxmlformats.org/presentationml/2006/main" xmlns:r="http://schemas.openxmlformats.org/officeDocument/2006/relationships">
-  <p:cSld>
-    <p:spTree>
-      <p:nvGrpSpPr>
-        <p:cNvPr id="1" name=""/>
-        <p:cNvGrpSpPr/>
-        <p:nvPr/>
-      </p:nvGrpSpPr>
-      <p:grpSpPr>
-        <a:xfrm>
-          <a:off x="0" y="0"/>
-          <a:ext cx="0" cy="0"/>
-          <a:chOff x="0" y="0"/>
-          <a:chExt cx="0" cy="0"/>
-        </a:xfrm>
-      </p:grpSpPr>
-      <p:sp>
-        <p:nvSpPr>
-          <p:cNvPr id="2" name="Slide Image Placeholder 1"/>
-          <p:cNvSpPr>
-            <a:spLocks noGrp="1"/>
-          </p:cNvSpPr>
-          <p:nvPr>
-            <p:ph type="sldImg"/>
-          </p:nvPr>
-        </p:nvSpPr>
-        <p:spPr/>
-      </p:sp>
-      <p:sp>
-        <p:nvSpPr>
-          <p:cNvPr id="3" name="Notes Placeholder 2"/>
-          <p:cNvSpPr>
-            <a:spLocks noGrp="1"/>
-          </p:cNvSpPr>
-          <p:nvPr>
-            <p:ph type="body"/>
-          </p:nvPr>
-        </p:nvSpPr>
-        <p:spPr/>
-        <p:txBody>
-          <a:bodyPr/>
-          <a:lstStyle/>
-          <a:p>
-            <a:r>
-              <a:t>Pi saves every message through Module 1 and asks Module 4 for memory before it answers. Module 2 turns saved messages into assertions, and Module 3 is the only part that writes them, keeping old versions. PostgreSQL holds everything; Neo4j holds a graph copy that can be rebuilt from it. Ollama runs the models on our machine, and Module 5 trains the extraction model offline. The next slide follows one example through these modules.</a:t>
-            </a:r>
-          </a:p>
-        </p:txBody>
-      </p:sp>
-      <p:sp>
-        <p:nvSpPr>
-          <p:cNvPr id="4" name="Slide Number Placeholder 3"/>
-          <p:cNvSpPr>
-            <a:spLocks noGrp="1"/>
-          </p:cNvSpPr>
-          <p:nvPr>
-            <p:ph type="sldNum" idx="4"/>
-          </p:nvPr>
-        </p:nvSpPr>
-        <p:spPr/>
-      </p:sp>
-    </p:spTree>
-  </p:cSld>
-  <p:clrMapOvr>
-    <a:masterClrMapping/>
-  </p:clrMapOvr>
-</p:notes>
-</file>
-
-<file path=ppt/notesSlides/notesSlide9.xml><?xml version="1.0" encoding="utf-8"?>
-<p:notes xmlns:a="http://schemas.openxmlformats.org/drawingml/2006/main" xmlns:p="http://schemas.openxmlformats.org/presentationml/2006/main" xmlns:r="http://schemas.openxmlformats.org/officeDocument/2006/relationships">
-  <p:cSld>
-    <p:spTree>
-      <p:nvGrpSpPr>
-        <p:cNvPr id="1" name=""/>
-        <p:cNvGrpSpPr/>
-        <p:nvPr/>
-      </p:nvGrpSpPr>
-      <p:grpSpPr>
-        <a:xfrm>
-          <a:off x="0" y="0"/>
-          <a:ext cx="0" cy="0"/>
-          <a:chOff x="0" y="0"/>
-          <a:chExt cx="0" cy="0"/>
-        </a:xfrm>
-      </p:grpSpPr>
-      <p:sp>
-        <p:nvSpPr>
-          <p:cNvPr id="2" name="Slide Image Placeholder 1"/>
-          <p:cNvSpPr>
-            <a:spLocks noGrp="1"/>
-          </p:cNvSpPr>
-          <p:nvPr>
-            <p:ph type="sldImg"/>
-          </p:nvPr>
-        </p:nvSpPr>
-        <p:spPr/>
-      </p:sp>
-      <p:sp>
-        <p:nvSpPr>
-          <p:cNvPr id="3" name="Notes Placeholder 2"/>
-          <p:cNvSpPr>
-            <a:spLocks noGrp="1"/>
-          </p:cNvSpPr>
-          <p:nvPr>
-            <p:ph type="body"/>
-          </p:nvPr>
-        </p:nvSpPr>
-        <p:spPr/>
-        <p:txBody>
-          <a:bodyPr/>
-          <a:lstStyle/>
-          <a:p>
-            <a:r>
-              <a:t>This is the example from the report. Maya mentions her city in one session, corrects it in a later one, and asks about it in a third. Each row is what one module does with it. The confidence threshold and the 'supersedes' link are explained on the Module 3 slide.</a:t>
-            </a:r>
-          </a:p>
-        </p:txBody>
-      </p:sp>
-      <p:sp>
-        <p:nvSpPr>
-          <p:cNvPr id="4" name="Slide Number Placeholder 3"/>
-          <p:cNvSpPr>
-            <a:spLocks noGrp="1"/>
-          </p:cNvSpPr>
-          <p:nvPr>
-            <p:ph type="sldNum" idx="4"/>
-          </p:nvPr>
-        </p:nvSpPr>
-        <p:spPr/>
-      </p:sp>
-    </p:spTree>
-  </p:cSld>
-  <p:clrMapOvr>
-    <a:masterClrMapping/>
-  </p:clrMapOvr>
-</p:notes>
 </file>
 
 <file path=ppt/slideLayouts/slideLayout1.xml><?xml version="1.0" encoding="utf-8"?>

</xml_diff>

<commit_message>
Slides: use the full department name and the 5.9-point gap
</commit_message>
<xml_diff>
--- a/P1_R2_13.pptx
+++ b/P1_R2_13.pptx
@@ -1996,7 +1996,7 @@
                 <a:ea typeface="Times New Roman"/>
                 <a:cs typeface="Times New Roman"/>
               </a:rPr>
-              <a:t>Department of Information Technology</a:t>
+              <a:t>Department of Information Science and Technology</a:t>
             </a:r>
             <a:endParaRPr lang="en-US" sz="1800" b="0" u="none" strike="noStrike">
               <a:solidFill>
@@ -2197,7 +2197,7 @@
                 <a:ea typeface="Times New Roman"/>
                 <a:cs typeface="Times New Roman"/>
               </a:rPr>
-              <a:t>DEPARTMENT OF INFORMATION TECHNOLOGY</a:t>
+              <a:t>DEPARTMENT OF INFORMATION SCIENCE AND TECHNOLOGY</a:t>
             </a:r>
             <a:endParaRPr lang="en-US" sz="1600" b="0" u="none" strike="noStrike">
               <a:solidFill>
@@ -9552,7 +9552,7 @@
                 <a:ea typeface="Times New Roman"/>
                 <a:cs typeface="Times New Roman"/>
               </a:rPr>
-              <a:t>The engine beats plain retrieval by 3.1 points (95% interval 1.2 to 4.8) and is 6.0 points below the whole conversation, using 30% of its tokens.</a:t>
+              <a:t>The engine beats plain retrieval by 3.1 points (95% interval 1.2 to 4.8) and is 5.9 points below the whole conversation, using 30% of its tokens.</a:t>
             </a:r>
           </a:p>
           <a:p>

</xml_diff>

<commit_message>
Glossary at the end, larger module figures, Live Demo caption, acknowledge HOD and project lab panel, horizontal module 1 and 3 slides
</commit_message>
<xml_diff>
--- a/P1_R2_13.pptx
+++ b/P1_R2_13.pptx
@@ -17929,8 +17929,8 @@
         </p:blipFill>
         <p:spPr>
           <a:xfrm>
-            <a:off x="594360" y="1143000"/>
-            <a:ext cx="2733621" cy="5120640"/>
+            <a:off x="1233766" y="1100000"/>
+            <a:ext cx="9724468" cy="3750000"/>
           </a:xfrm>
           <a:prstGeom prst="rect">
             <a:avLst/>
@@ -17945,8 +17945,8 @@
         </p:nvSpPr>
         <p:spPr>
           <a:xfrm>
-            <a:off x="3648021" y="1234440"/>
-            <a:ext cx="7946571" cy="4937760"/>
+            <a:off x="594360" y="4930000"/>
+            <a:ext cx="11003280" cy="1350000"/>
           </a:xfrm>
           <a:prstGeom prst="rect">
             <a:avLst/>
@@ -17955,19 +17955,19 @@
         </p:spPr>
         <p:txBody>
           <a:bodyPr wrap="square" lIns="45720" rIns="45720" tIns="27432" bIns="27432">
-            <a:spAutoFit/>
+            <a:noAutofit/>
           </a:bodyPr>
           <a:lstStyle/>
           <a:p>
             <a:pPr marL="256032" indent="-256032">
               <a:spcAft>
-                <a:spcPts val="1200"/>
+                <a:spcPts val="600"/>
               </a:spcAft>
               <a:buFont typeface="Arial"/>
               <a:buChar char="•"/>
             </a:pPr>
             <a:r>
-              <a:rPr sz="1800" b="0" i="0">
+              <a:rPr sz="1400" b="0" i="0">
                 <a:solidFill>
                   <a:srgbClr val="000000"/>
                 </a:solidFill>
@@ -17981,13 +17981,13 @@
           <a:p>
             <a:pPr marL="256032" indent="-256032">
               <a:spcAft>
-                <a:spcPts val="1200"/>
+                <a:spcPts val="600"/>
               </a:spcAft>
               <a:buFont typeface="Arial"/>
               <a:buChar char="•"/>
             </a:pPr>
             <a:r>
-              <a:rPr sz="1800" b="0" i="0">
+              <a:rPr sz="1400" b="0" i="0">
                 <a:solidFill>
                   <a:srgbClr val="000000"/>
                 </a:solidFill>
@@ -18001,13 +18001,13 @@
           <a:p>
             <a:pPr marL="256032" indent="-256032">
               <a:spcAft>
-                <a:spcPts val="1200"/>
+                <a:spcPts val="600"/>
               </a:spcAft>
               <a:buFont typeface="Arial"/>
               <a:buChar char="•"/>
             </a:pPr>
             <a:r>
-              <a:rPr sz="1800" b="0" i="0">
+              <a:rPr sz="1400" b="0" i="0">
                 <a:solidFill>
                   <a:srgbClr val="000000"/>
                 </a:solidFill>
@@ -18021,13 +18021,13 @@
           <a:p>
             <a:pPr marL="256032" indent="-256032">
               <a:spcAft>
-                <a:spcPts val="1200"/>
+                <a:spcPts val="600"/>
               </a:spcAft>
               <a:buFont typeface="Arial"/>
               <a:buChar char="•"/>
             </a:pPr>
             <a:r>
-              <a:rPr sz="1800" b="0" i="0">
+              <a:rPr sz="1400" b="0" i="0">
                 <a:solidFill>
                   <a:srgbClr val="000000"/>
                 </a:solidFill>
@@ -18041,12 +18041,12 @@
           <a:p>
             <a:pPr marL="0" indent="0">
               <a:spcAft>
-                <a:spcPts val="1200"/>
+                <a:spcPts val="600"/>
               </a:spcAft>
               <a:buNone/>
             </a:pPr>
             <a:r>
-              <a:rPr sz="1800" b="1" i="0">
+              <a:rPr sz="1400" b="1" i="0">
                 <a:solidFill>
                   <a:srgbClr val="000000"/>
                 </a:solidFill>
@@ -18057,7 +18057,7 @@
               <a:t>Maya: </a:t>
             </a:r>
             <a:r>
-              <a:rPr sz="1800" b="0" i="0">
+              <a:rPr sz="1400" b="0" i="0">
                 <a:solidFill>
                   <a:srgbClr val="000000"/>
                 </a:solidFill>
@@ -18531,8 +18531,8 @@
         </p:blipFill>
         <p:spPr>
           <a:xfrm>
-            <a:off x="594360" y="1143000"/>
-            <a:ext cx="3457351" cy="5120640"/>
+            <a:off x="724169" y="1100000"/>
+            <a:ext cx="10743661" cy="3800000"/>
           </a:xfrm>
           <a:prstGeom prst="rect">
             <a:avLst/>
@@ -18547,8 +18547,8 @@
         </p:nvSpPr>
         <p:spPr>
           <a:xfrm>
-            <a:off x="4371751" y="1234440"/>
-            <a:ext cx="7222841" cy="4937760"/>
+            <a:off x="594360" y="4980000"/>
+            <a:ext cx="11003280" cy="1300000"/>
           </a:xfrm>
           <a:prstGeom prst="rect">
             <a:avLst/>
@@ -18557,19 +18557,19 @@
         </p:spPr>
         <p:txBody>
           <a:bodyPr wrap="square" lIns="45720" rIns="45720" tIns="27432" bIns="27432">
-            <a:spAutoFit/>
+            <a:noAutofit/>
           </a:bodyPr>
           <a:lstStyle/>
           <a:p>
             <a:pPr marL="256032" indent="-256032">
               <a:spcAft>
-                <a:spcPts val="1200"/>
+                <a:spcPts val="600"/>
               </a:spcAft>
               <a:buFont typeface="Arial"/>
               <a:buChar char="•"/>
             </a:pPr>
             <a:r>
-              <a:rPr sz="1800" b="0" i="0">
+              <a:rPr sz="1400" b="0" i="0">
                 <a:solidFill>
                   <a:srgbClr val="000000"/>
                 </a:solidFill>
@@ -18583,13 +18583,13 @@
           <a:p>
             <a:pPr marL="256032" indent="-256032">
               <a:spcAft>
-                <a:spcPts val="1200"/>
+                <a:spcPts val="600"/>
               </a:spcAft>
               <a:buFont typeface="Arial"/>
               <a:buChar char="•"/>
             </a:pPr>
             <a:r>
-              <a:rPr sz="1800" b="0" i="0">
+              <a:rPr sz="1400" b="0" i="0">
                 <a:solidFill>
                   <a:srgbClr val="000000"/>
                 </a:solidFill>
@@ -18603,13 +18603,13 @@
           <a:p>
             <a:pPr marL="256032" indent="-256032">
               <a:spcAft>
-                <a:spcPts val="1200"/>
+                <a:spcPts val="600"/>
               </a:spcAft>
               <a:buFont typeface="Arial"/>
               <a:buChar char="•"/>
             </a:pPr>
             <a:r>
-              <a:rPr sz="1800" b="0" i="0">
+              <a:rPr sz="1400" b="0" i="0">
                 <a:solidFill>
                   <a:srgbClr val="000000"/>
                 </a:solidFill>
@@ -18623,13 +18623,13 @@
           <a:p>
             <a:pPr marL="256032" indent="-256032">
               <a:spcAft>
-                <a:spcPts val="1200"/>
+                <a:spcPts val="600"/>
               </a:spcAft>
               <a:buFont typeface="Arial"/>
               <a:buChar char="•"/>
             </a:pPr>
             <a:r>
-              <a:rPr sz="1800" b="0" i="0">
+              <a:rPr sz="1400" b="0" i="0">
                 <a:solidFill>
                   <a:srgbClr val="000000"/>
                 </a:solidFill>
@@ -18643,12 +18643,12 @@
           <a:p>
             <a:pPr marL="0" indent="0">
               <a:spcAft>
-                <a:spcPts val="1200"/>
+                <a:spcPts val="600"/>
               </a:spcAft>
               <a:buNone/>
             </a:pPr>
             <a:r>
-              <a:rPr sz="1800" b="1" i="0">
+              <a:rPr sz="1400" b="1" i="0">
                 <a:solidFill>
                   <a:srgbClr val="000000"/>
                 </a:solidFill>
@@ -18659,7 +18659,7 @@
               <a:t>Maya: </a:t>
             </a:r>
             <a:r>
-              <a:rPr sz="1800" b="0" i="0">
+              <a:rPr sz="1400" b="0" i="0">
                 <a:solidFill>
                   <a:srgbClr val="000000"/>
                 </a:solidFill>

</xml_diff>